<commit_message>
Remove control flow tracing from quiz review
</commit_message>
<xml_diff>
--- a/public/presentations/CS211_Recitation_4.pptx
+++ b/public/presentations/CS211_Recitation_4.pptx
@@ -2,38 +2,37 @@
 <file path=ppt/presentation.xml><?xml version="1.0" encoding="utf-8"?>
 <p:presentation xmlns:p="http://schemas.openxmlformats.org/presentationml/2006/main" embedTrueTypeFonts="1" saveSubsetFonts="0">
   <p:sldMasterIdLst>
-    <p:sldMasterId xmlns:r="http://schemas.openxmlformats.org/officeDocument/2006/relationships" id="2147483648" r:id="R8f4129561d2c4b36"/>
+    <p:sldMasterId xmlns:r="http://schemas.openxmlformats.org/officeDocument/2006/relationships" id="2147483648" r:id="R0474acbeb6ef42d6"/>
   </p:sldMasterIdLst>
   <p:notesMasterIdLst>
-    <p:notesMasterId xmlns:r="http://schemas.openxmlformats.org/officeDocument/2006/relationships" r:id="R4b134ed10e114671"/>
+    <p:notesMasterId xmlns:r="http://schemas.openxmlformats.org/officeDocument/2006/relationships" r:id="R464e4e1faa0440bd"/>
   </p:notesMasterIdLst>
   <p:sldIdLst>
-    <p:sldId xmlns:r="http://schemas.openxmlformats.org/officeDocument/2006/relationships" id="256" r:id="Rf8f5561f75f749b5"/>
-    <p:sldId xmlns:r="http://schemas.openxmlformats.org/officeDocument/2006/relationships" id="257" r:id="R23f507d0f39d41dd"/>
-    <p:sldId xmlns:r="http://schemas.openxmlformats.org/officeDocument/2006/relationships" id="258" r:id="R243d8cf82d9147a8"/>
-    <p:sldId xmlns:r="http://schemas.openxmlformats.org/officeDocument/2006/relationships" id="259" r:id="Rbf96c38686554346"/>
-    <p:sldId xmlns:r="http://schemas.openxmlformats.org/officeDocument/2006/relationships" id="260" r:id="R6cdf88717c4e4d5a"/>
-    <p:sldId xmlns:r="http://schemas.openxmlformats.org/officeDocument/2006/relationships" id="261" r:id="R0da2c54cfbbb4955"/>
-    <p:sldId xmlns:r="http://schemas.openxmlformats.org/officeDocument/2006/relationships" id="262" r:id="Rf56571f35f7c49a2"/>
-    <p:sldId xmlns:r="http://schemas.openxmlformats.org/officeDocument/2006/relationships" id="263" r:id="Rc5aa3f9bfa394efb"/>
-    <p:sldId xmlns:r="http://schemas.openxmlformats.org/officeDocument/2006/relationships" id="264" r:id="R7a12c276c09b41ce"/>
-    <p:sldId xmlns:r="http://schemas.openxmlformats.org/officeDocument/2006/relationships" id="265" r:id="R34c26ce92494459c"/>
-    <p:sldId xmlns:r="http://schemas.openxmlformats.org/officeDocument/2006/relationships" id="266" r:id="R0915f1bf365a47ca"/>
-    <p:sldId xmlns:r="http://schemas.openxmlformats.org/officeDocument/2006/relationships" id="267" r:id="R7c4a156430184e2f"/>
-    <p:sldId xmlns:r="http://schemas.openxmlformats.org/officeDocument/2006/relationships" id="268" r:id="R75748dba5e84411e"/>
-    <p:sldId xmlns:r="http://schemas.openxmlformats.org/officeDocument/2006/relationships" id="269" r:id="R3656805c1f604c4e"/>
-    <p:sldId xmlns:r="http://schemas.openxmlformats.org/officeDocument/2006/relationships" id="270" r:id="R3489f31c95ea4bc2"/>
-    <p:sldId xmlns:r="http://schemas.openxmlformats.org/officeDocument/2006/relationships" id="271" r:id="Rd544614ceb7c4656"/>
+    <p:sldId xmlns:r="http://schemas.openxmlformats.org/officeDocument/2006/relationships" id="256" r:id="Rddf4b863eb3346b6"/>
+    <p:sldId xmlns:r="http://schemas.openxmlformats.org/officeDocument/2006/relationships" id="257" r:id="R550a20378d90448f"/>
+    <p:sldId xmlns:r="http://schemas.openxmlformats.org/officeDocument/2006/relationships" id="258" r:id="Rb5496a93ac7944fb"/>
+    <p:sldId xmlns:r="http://schemas.openxmlformats.org/officeDocument/2006/relationships" id="259" r:id="R5e539c9ec14b47b9"/>
+    <p:sldId xmlns:r="http://schemas.openxmlformats.org/officeDocument/2006/relationships" id="260" r:id="R1144e97c64cb486d"/>
+    <p:sldId xmlns:r="http://schemas.openxmlformats.org/officeDocument/2006/relationships" id="261" r:id="R597128970dc645f8"/>
+    <p:sldId xmlns:r="http://schemas.openxmlformats.org/officeDocument/2006/relationships" id="262" r:id="Rbf29355b08e24501"/>
+    <p:sldId xmlns:r="http://schemas.openxmlformats.org/officeDocument/2006/relationships" id="263" r:id="Re777f04b4f51410d"/>
+    <p:sldId xmlns:r="http://schemas.openxmlformats.org/officeDocument/2006/relationships" id="264" r:id="R799a57cd6c77482a"/>
+    <p:sldId xmlns:r="http://schemas.openxmlformats.org/officeDocument/2006/relationships" id="265" r:id="R57d4976b75a8480f"/>
+    <p:sldId xmlns:r="http://schemas.openxmlformats.org/officeDocument/2006/relationships" id="266" r:id="Rf9b1da27d8eb4278"/>
+    <p:sldId xmlns:r="http://schemas.openxmlformats.org/officeDocument/2006/relationships" id="267" r:id="R0f216277bb834475"/>
+    <p:sldId xmlns:r="http://schemas.openxmlformats.org/officeDocument/2006/relationships" id="268" r:id="Rf894c207c90b4fa9"/>
+    <p:sldId xmlns:r="http://schemas.openxmlformats.org/officeDocument/2006/relationships" id="269" r:id="Ra8326fe027004f56"/>
+    <p:sldId xmlns:r="http://schemas.openxmlformats.org/officeDocument/2006/relationships" id="270" r:id="Raa48b36903834b63"/>
   </p:sldIdLst>
   <p:sldSz cx="12192000" cy="6858000"/>
   <p:notesSz cx="6858000" cy="9144000"/>
   <p:embeddedFontLst>
     <p:embeddedFont>
       <p:font typeface="OpenAI Sans"/>
-      <p:regular xmlns:r="http://schemas.openxmlformats.org/officeDocument/2006/relationships" r:id="R766f7454b1f44811"/>
-      <p:bold xmlns:r="http://schemas.openxmlformats.org/officeDocument/2006/relationships" r:id="R9d55563d86ee4d04"/>
-      <p:italic xmlns:r="http://schemas.openxmlformats.org/officeDocument/2006/relationships" r:id="Rb21b3d4573e643d2"/>
-      <p:boldItalic xmlns:r="http://schemas.openxmlformats.org/officeDocument/2006/relationships" r:id="R050748169da0476d"/>
+      <p:regular xmlns:r="http://schemas.openxmlformats.org/officeDocument/2006/relationships" r:id="R30bc6584e4b04aff"/>
+      <p:bold xmlns:r="http://schemas.openxmlformats.org/officeDocument/2006/relationships" r:id="Rac46b8791106475e"/>
+      <p:italic xmlns:r="http://schemas.openxmlformats.org/officeDocument/2006/relationships" r:id="R9f85f219ceda4749"/>
+      <p:boldItalic xmlns:r="http://schemas.openxmlformats.org/officeDocument/2006/relationships" r:id="Ra7c595d74ce94d65"/>
     </p:embeddedFont>
   </p:embeddedFontLst>
 </p:presentation>
@@ -492,7 +491,7 @@
               <a:buNone/>
             </a:pPr>
             <a:r>
-              <a:t>A complete leaf-function body under the System V AMD64 convention: input in rdi, return value in rax. First copy x to rax. cmpq $0, %rdi sets flags as if computing rdi - 0 but preserves rdi. jge uses signed comparison: if x &gt;= 0, skip the zero assignment. Otherwise replace rax with 0. Both paths reach ret. Trace x = 12 and x = -4. call elsewhere saves the next instruction's address on the stack; ret retrieves it.</a:t>
+              <a:t>Connect the formula to assembly displacement(base,index,scale): address = displacement + base + index times scale. For long elements of 8 bytes, (%rbx,%rsi,8) with rsi = 2 selects the third element, 16 bytes from the base. Most program data lives in memory. Source: https://firner.com/presentations/cs211/2026-Fall/cs211_08/</a:t>
             </a:r>
             <a:endParaRPr/>
           </a:p>
@@ -572,7 +571,7 @@
               <a:buNone/>
             </a:pPr>
             <a:r>
-              <a:t>Connect the formula to assembly displacement(base,index,scale): address = displacement + base + index times scale. For long elements of 8 bytes, (%rbx,%rsi,8) with rsi = 2 selects the third element, 16 bytes from the base. Most program data lives in memory. Source: https://firner.com/presentations/cs211/2026-Fall/cs211_08/</a:t>
+              <a:t>Contrast int a[10], whose size is known at compile time, with int a[n], whose size is known only when execution reaches the declaration. In the address formula, rows does not appear because the address of a specific element depends on how many complete rows come before it, and each row contains cols elements. rows still matters as the bound: 0 &lt;= i &lt; rows. A VLA has automatic lifetime and is commonly allocated in the current stack frame.</a:t>
             </a:r>
             <a:endParaRPr/>
           </a:p>
@@ -652,7 +651,7 @@
               <a:buNone/>
             </a:pPr>
             <a:r>
-              <a:t>Contrast int a[10], whose size is known at compile time, with int a[n], whose size is known only when execution reaches the declaration. In the address formula, rows does not appear because the address of a specific element depends on how many complete rows come before it, and each row contains cols elements. rows still matters as the bound: 0 &lt;= i &lt; rows. A VLA has automatic lifetime and is commonly allocated in the current stack frame.</a:t>
+              <a:t>call places the return address on the stack. push decrements rsp before storing; pop loads then increments it. Subtracting 24 increases the distance between rbp and rsp by 24 bytes. To release the local storage, restore rsp from rbp, then restore the caller's saved rbp. This example has no nested call; calls may require additional stack alignment. Optimized code may omit rbp as a frame pointer.</a:t>
             </a:r>
             <a:endParaRPr/>
           </a:p>
@@ -732,7 +731,7 @@
               <a:buNone/>
             </a:pPr>
             <a:r>
-              <a:t>call places the return address on the stack. push decrements rsp before storing; pop loads then increments it. Subtracting 24 increases the distance between rbp and rsp by 24 bytes. To release the local storage, restore rsp from rbp, then restore the caller's saved rbp. This example has no nested call; calls may require additional stack alignment. Optimized code may omit rbp as a frame pointer.</a:t>
+              <a:t>Use the closet analogy carefully: the stack is a nested pile of function frames; the heap is a pool where the program requests blocks and must return them. malloc returns uninitialized storage or NULL. free only the allocation’s original address, exactly once.</a:t>
             </a:r>
             <a:endParaRPr/>
           </a:p>
@@ -812,7 +811,7 @@
               <a:buNone/>
             </a:pPr>
             <a:r>
-              <a:t>Use the closet analogy carefully: the stack is a nested pile of function frames; the heap is a pool where the program requests blocks and must return them. malloc returns uninitialized storage or NULL. free only the allocation’s original address, exactly once.</a:t>
+              <a:t>Give students two minutes before moving to the answers. For question 4, assume sizeof(int) is 4 bytes. For question 6, the format is 1 sign bit, 3 exponent bits, 4 fraction bits and the value is normalized.</a:t>
             </a:r>
             <a:endParaRPr/>
           </a:p>
@@ -844,86 +843,6 @@
 </file>
 
 <file path=ppt/notesSlides/notesSlide15.xml><?xml version="1.0" encoding="utf-8"?>
-<p:notes xmlns:p="http://schemas.openxmlformats.org/presentationml/2006/main">
-  <p:cSld>
-    <p:spTree>
-      <p:nvGrpSpPr>
-        <p:cNvPr id="1" name=""/>
-        <p:cNvGrpSpPr/>
-        <p:nvPr/>
-      </p:nvGrpSpPr>
-      <p:grpSpPr>
-        <a:xfrm xmlns:a="http://schemas.openxmlformats.org/drawingml/2006/main"/>
-      </p:grpSpPr>
-      <p:sp>
-        <p:nvSpPr>
-          <p:cNvPr id="2" name="Slide Image Placeholder 1"/>
-          <p:cNvSpPr>
-            <a:spLocks xmlns:a="http://schemas.openxmlformats.org/drawingml/2006/main" noGrp="1"/>
-          </p:cNvSpPr>
-          <p:nvPr>
-            <p:ph type="sldImg" idx="0"/>
-          </p:nvPr>
-        </p:nvSpPr>
-        <p:spPr/>
-      </p:sp>
-      <p:sp>
-        <p:nvSpPr>
-          <p:cNvPr id="3" name="Notes Placeholder 2"/>
-          <p:cNvSpPr>
-            <a:spLocks xmlns:a="http://schemas.openxmlformats.org/drawingml/2006/main" noGrp="1"/>
-          </p:cNvSpPr>
-          <p:nvPr>
-            <p:ph type="body" idx="1"/>
-          </p:nvPr>
-        </p:nvSpPr>
-        <p:spPr/>
-        <p:txBody>
-          <a:bodyPr xmlns:a="http://schemas.openxmlformats.org/drawingml/2006/main"/>
-          <a:lstStyle xmlns:a="http://schemas.openxmlformats.org/drawingml/2006/main"/>
-          <a:p xmlns:a="http://schemas.openxmlformats.org/drawingml/2006/main">
-            <a:pPr marL="0" lvl="0" indent="0" algn="l">
-              <a:spcBef>
-                <a:spcPts val="0"/>
-              </a:spcBef>
-              <a:spcAft>
-                <a:spcPts val="0"/>
-              </a:spcAft>
-              <a:buNone/>
-            </a:pPr>
-            <a:r>
-              <a:t>Give students two minutes before moving to the answers. For question 4, assume sizeof(int) is 4 bytes. For question 6, the format is 1 sign bit, 3 exponent bits, 4 fraction bits and the value is normalized.</a:t>
-            </a:r>
-            <a:endParaRPr/>
-          </a:p>
-        </p:txBody>
-      </p:sp>
-      <p:sp>
-        <p:nvSpPr>
-          <p:cNvPr id="4" name="Slide Number Placeholder 3"/>
-          <p:cNvSpPr>
-            <a:spLocks xmlns:a="http://schemas.openxmlformats.org/drawingml/2006/main" noGrp="1"/>
-          </p:cNvSpPr>
-          <p:nvPr>
-            <p:ph type="sldNum" idx="5"/>
-          </p:nvPr>
-        </p:nvSpPr>
-        <p:spPr/>
-        <p:txBody>
-          <a:bodyPr xmlns:a="http://schemas.openxmlformats.org/drawingml/2006/main"/>
-          <a:lstStyle xmlns:a="http://schemas.openxmlformats.org/drawingml/2006/main"/>
-          <a:p xmlns:a="http://schemas.openxmlformats.org/drawingml/2006/main"/>
-        </p:txBody>
-      </p:sp>
-    </p:spTree>
-  </p:cSld>
-  <p:clrMapOvr>
-    <a:masterClrMapping xmlns:a="http://schemas.openxmlformats.org/drawingml/2006/main"/>
-  </p:clrMapOvr>
-</p:notes>
-</file>
-
-<file path=ppt/notesSlides/notesSlide16.xml><?xml version="1.0" encoding="utf-8"?>
 <p:notes xmlns:p="http://schemas.openxmlformats.org/presentationml/2006/main">
   <p:cSld>
     <p:spTree>
@@ -3496,14 +3415,14 @@
   </p:cSld>
   <p:clrMap bg1="dk1" tx1="lt1" bg2="dk2" tx2="lt2" accent1="accent1" accent2="accent2" accent3="accent3" accent4="accent4" accent5="accent5" accent6="accent6" hlink="hlink" folHlink="folHlink"/>
   <p:sldLayoutIdLst>
-    <p:sldLayoutId xmlns:r="http://schemas.openxmlformats.org/officeDocument/2006/relationships" id="2147483649" r:id="R402d91f74e9c43cc"/>
-    <p:sldLayoutId xmlns:r="http://schemas.openxmlformats.org/officeDocument/2006/relationships" id="2147483650" r:id="Rb9715875074b41b8"/>
-    <p:sldLayoutId xmlns:r="http://schemas.openxmlformats.org/officeDocument/2006/relationships" id="2147483651" r:id="Rf81a466fba274a70"/>
-    <p:sldLayoutId xmlns:r="http://schemas.openxmlformats.org/officeDocument/2006/relationships" id="2147483652" r:id="R2ed21f1f46804e38"/>
-    <p:sldLayoutId xmlns:r="http://schemas.openxmlformats.org/officeDocument/2006/relationships" id="2147483653" r:id="Rf6c619a7ba764282"/>
-    <p:sldLayoutId xmlns:r="http://schemas.openxmlformats.org/officeDocument/2006/relationships" id="2147483654" r:id="R5628da84fd6c45de"/>
-    <p:sldLayoutId xmlns:r="http://schemas.openxmlformats.org/officeDocument/2006/relationships" id="2147483655" r:id="R0197705d6ccd45c4"/>
-    <p:sldLayoutId xmlns:r="http://schemas.openxmlformats.org/officeDocument/2006/relationships" id="2147483656" r:id="R69c9eedc467543ba"/>
+    <p:sldLayoutId xmlns:r="http://schemas.openxmlformats.org/officeDocument/2006/relationships" id="2147483649" r:id="R569268c9d9134464"/>
+    <p:sldLayoutId xmlns:r="http://schemas.openxmlformats.org/officeDocument/2006/relationships" id="2147483650" r:id="R0d7abc0323d94e3a"/>
+    <p:sldLayoutId xmlns:r="http://schemas.openxmlformats.org/officeDocument/2006/relationships" id="2147483651" r:id="R013b4f460ae84d95"/>
+    <p:sldLayoutId xmlns:r="http://schemas.openxmlformats.org/officeDocument/2006/relationships" id="2147483652" r:id="R3c190ca7c6a64160"/>
+    <p:sldLayoutId xmlns:r="http://schemas.openxmlformats.org/officeDocument/2006/relationships" id="2147483653" r:id="R61635ed3a7a84df3"/>
+    <p:sldLayoutId xmlns:r="http://schemas.openxmlformats.org/officeDocument/2006/relationships" id="2147483654" r:id="Re7965f5eb3234514"/>
+    <p:sldLayoutId xmlns:r="http://schemas.openxmlformats.org/officeDocument/2006/relationships" id="2147483655" r:id="R449242db58824b1d"/>
+    <p:sldLayoutId xmlns:r="http://schemas.openxmlformats.org/officeDocument/2006/relationships" id="2147483656" r:id="R8fc187ba73e340ca"/>
   </p:sldLayoutIdLst>
   <p:hf hdr="0" dt="0"/>
   <p:txStyles>
@@ -4536,7 +4455,7 @@
           <p:nvPr/>
         </p:nvPicPr>
         <p:blipFill>
-          <a:blip xmlns:r="http://schemas.openxmlformats.org/officeDocument/2006/relationships" xmlns:a="http://schemas.openxmlformats.org/drawingml/2006/main" r:embed="R6ba382b44ebb42e7"/>
+          <a:blip xmlns:r="http://schemas.openxmlformats.org/officeDocument/2006/relationships" xmlns:a="http://schemas.openxmlformats.org/drawingml/2006/main" r:embed="Rb5761fc1851a4108"/>
           <a:srcRect xmlns:a="http://schemas.openxmlformats.org/drawingml/2006/main" l="8269" t="0" r="8269" b="0"/>
           <a:stretch xmlns:a="http://schemas.openxmlformats.org/drawingml/2006/main"/>
         </p:blipFill>
@@ -4753,7 +4672,7 @@
                 <a:ea typeface="Arial"/>
                 <a:cs typeface="Arial"/>
               </a:rPr>
-              <a:t>Trace the control flow</a:t>
+              <a:t>Memory and arrays</a:t>
             </a:r>
           </a:p>
         </p:txBody>
@@ -4979,7 +4898,7 @@
                 <a:ea typeface="Arial"/>
                 <a:cs typeface="Arial"/>
               </a:rPr>
-              <a:t>Arithmetic changes data. cmp/test set condition flags. A conditional jump reads those flags.</a:t>
+              <a:t>Memory is a flat sequence of byte addresses. An array stores equal-size elements contiguously.</a:t>
             </a:r>
           </a:p>
           <a:p xmlns:a="http://schemas.openxmlformats.org/drawingml/2006/main">
@@ -5029,7 +4948,7 @@
                 <a:ea typeface="Arial"/>
                 <a:cs typeface="Arial"/>
               </a:rPr>
-              <a:t>call saves where execution should return. ret restores that location.</a:t>
+              <a:t>To reach element i, scale the index by the element size.</a:t>
             </a:r>
           </a:p>
         </p:txBody>
@@ -5255,7 +5174,7 @@
                 <a:ea typeface="Consolas"/>
                 <a:cs typeface="Consolas"/>
               </a:rPr>
-              <a:t># Return max(x, 0); x is in %rdi</a:t>
+              <a:t>address(a[i])</a:t>
             </a:r>
           </a:p>
           <a:p xmlns:a="http://schemas.openxmlformats.org/drawingml/2006/main">
@@ -5288,7 +5207,24 @@
                 <a:ea typeface="Consolas"/>
                 <a:cs typeface="Consolas"/>
               </a:rPr>
-              <a:t>movq %rdi, %rax</a:t>
+              <a:t>= base + i × sizeof(element)</a:t>
+            </a:r>
+          </a:p>
+          <a:p xmlns:a="http://schemas.openxmlformats.org/drawingml/2006/main">
+            <a:pPr marL="0" indent="0">
+              <a:lnSpc>
+                <a:spcPct val="112000"/>
+              </a:lnSpc>
+              <a:spcBef>
+                <a:spcPts val="0"/>
+              </a:spcBef>
+              <a:spcAft>
+                <a:spcPts val="0"/>
+              </a:spcAft>
+              <a:buNone/>
+            </a:pPr>
+            <a:r>
+              <a:t/>
             </a:r>
           </a:p>
           <a:p xmlns:a="http://schemas.openxmlformats.org/drawingml/2006/main">
@@ -5321,7 +5257,7 @@
                 <a:ea typeface="Consolas"/>
                 <a:cs typeface="Consolas"/>
               </a:rPr>
-              <a:t>cmpq $0, %rdi</a:t>
+              <a:t>int a[10];</a:t>
             </a:r>
           </a:p>
           <a:p xmlns:a="http://schemas.openxmlformats.org/drawingml/2006/main">
@@ -5354,7 +5290,7 @@
                 <a:ea typeface="Consolas"/>
                 <a:cs typeface="Consolas"/>
               </a:rPr>
-              <a:t>jge  .done</a:t>
+              <a:t>address(a[3]) = base + 3 × 4</a:t>
             </a:r>
           </a:p>
           <a:p xmlns:a="http://schemas.openxmlformats.org/drawingml/2006/main">
@@ -5387,73 +5323,7 @@
                 <a:ea typeface="Consolas"/>
                 <a:cs typeface="Consolas"/>
               </a:rPr>
-              <a:t>movq $0, %rax</a:t>
-            </a:r>
-          </a:p>
-          <a:p xmlns:a="http://schemas.openxmlformats.org/drawingml/2006/main">
-            <a:pPr marL="0" indent="0">
-              <a:lnSpc>
-                <a:spcPct val="112000"/>
-              </a:lnSpc>
-              <a:spcBef>
-                <a:spcPts val="0"/>
-              </a:spcBef>
-              <a:spcAft>
-                <a:spcPts val="0"/>
-              </a:spcAft>
-              <a:buNone/>
-              <a:defRPr sz="1800">
-                <a:solidFill>
-                  <a:srgbClr val="FFFFFF"/>
-                </a:solidFill>
-                <a:latin typeface="Consolas"/>
-                <a:ea typeface="Consolas"/>
-                <a:cs typeface="Consolas"/>
-              </a:defRPr>
-            </a:pPr>
-            <a:r>
-              <a:rPr sz="1800">
-                <a:solidFill>
-                  <a:srgbClr val="FFFFFF"/>
-                </a:solidFill>
-                <a:latin typeface="Consolas"/>
-                <a:ea typeface="Consolas"/>
-                <a:cs typeface="Consolas"/>
-              </a:rPr>
-              <a:t>.done:</a:t>
-            </a:r>
-          </a:p>
-          <a:p xmlns:a="http://schemas.openxmlformats.org/drawingml/2006/main">
-            <a:pPr marL="0" indent="0">
-              <a:lnSpc>
-                <a:spcPct val="112000"/>
-              </a:lnSpc>
-              <a:spcBef>
-                <a:spcPts val="0"/>
-              </a:spcBef>
-              <a:spcAft>
-                <a:spcPts val="0"/>
-              </a:spcAft>
-              <a:buNone/>
-              <a:defRPr sz="1800">
-                <a:solidFill>
-                  <a:srgbClr val="FFFFFF"/>
-                </a:solidFill>
-                <a:latin typeface="Consolas"/>
-                <a:ea typeface="Consolas"/>
-                <a:cs typeface="Consolas"/>
-              </a:defRPr>
-            </a:pPr>
-            <a:r>
-              <a:rPr sz="1800">
-                <a:solidFill>
-                  <a:srgbClr val="FFFFFF"/>
-                </a:solidFill>
-                <a:latin typeface="Consolas"/>
-                <a:ea typeface="Consolas"/>
-                <a:cs typeface="Consolas"/>
-              </a:rPr>
-              <a:t>ret</a:t>
+              <a:t>              = base + 12</a:t>
             </a:r>
           </a:p>
         </p:txBody>
@@ -5463,7 +5333,7 @@
           <p:cNvPr id="534" name="Takeaway">
             <a:extLst xmlns:a="http://schemas.openxmlformats.org/drawingml/2006/main">
               <a:ext uri="{FF2B5EF4-FFF2-40B4-BE49-F238E27FC236}">
-                <a16:creationId xmlns:a16="http://schemas.microsoft.com/office/drawing/2014/main" id="{41AC5055-0A49-4AD6-A7F9-21BCB41A6B85}"/>
+                <a16:creationId xmlns:a16="http://schemas.microsoft.com/office/drawing/2014/main" id="{D970FE01-0AE5-498C-ADD9-3AD39009B3AB}"/>
               </a:ext>
             </a:extLst>
           </p:cNvPr>
@@ -5520,7 +5390,7 @@
                 <a:ea typeface="Arial"/>
                 <a:cs typeface="Arial"/>
               </a:rPr>
-              <a:t>Trace register and memory values one instruction at a time; follow the jump that is actually taken.</a:t>
+              <a:t>Indices start at 0: index 2 selects the third element. C pointer arithmetic scales by element size.</a:t>
             </a:r>
           </a:p>
         </p:txBody>
@@ -5728,7 +5598,7 @@
                 <a:ea typeface="Arial"/>
                 <a:cs typeface="Arial"/>
               </a:rPr>
-              <a:t>Memory and arrays</a:t>
+              <a:t>Variable-length arrays</a:t>
             </a:r>
           </a:p>
         </p:txBody>
@@ -5954,7 +5824,7 @@
                 <a:ea typeface="Arial"/>
                 <a:cs typeface="Arial"/>
               </a:rPr>
-              <a:t>Memory is a flat sequence of byte addresses. An array stores equal-size elements contiguously.</a:t>
+              <a:t>A VLA’s size is known only at runtime. The compiler must compute how many bytes the current function needs.</a:t>
             </a:r>
           </a:p>
           <a:p xmlns:a="http://schemas.openxmlformats.org/drawingml/2006/main">
@@ -6004,7 +5874,7 @@
                 <a:ea typeface="Arial"/>
                 <a:cs typeface="Arial"/>
               </a:rPr>
-              <a:t>To reach element i, scale the index by the element size.</a:t>
+              <a:t>For a row-major 2D array, the column count determines the row stride.</a:t>
             </a:r>
           </a:p>
         </p:txBody>
@@ -6230,7 +6100,7 @@
                 <a:ea typeface="Consolas"/>
                 <a:cs typeface="Consolas"/>
               </a:rPr>
-              <a:t>address(a[i])</a:t>
+              <a:t>void f(size_t rows, size_t cols,</a:t>
             </a:r>
           </a:p>
           <a:p xmlns:a="http://schemas.openxmlformats.org/drawingml/2006/main">
@@ -6263,7 +6133,7 @@
                 <a:ea typeface="Consolas"/>
                 <a:cs typeface="Consolas"/>
               </a:rPr>
-              <a:t>= base + i × sizeof(element)</a:t>
+              <a:t>       int a[rows][cols]);</a:t>
             </a:r>
           </a:p>
           <a:p xmlns:a="http://schemas.openxmlformats.org/drawingml/2006/main">
@@ -6313,7 +6183,7 @@
                 <a:ea typeface="Consolas"/>
                 <a:cs typeface="Consolas"/>
               </a:rPr>
-              <a:t>int a[10];</a:t>
+              <a:t>address(a[i][j])</a:t>
             </a:r>
           </a:p>
           <a:p xmlns:a="http://schemas.openxmlformats.org/drawingml/2006/main">
@@ -6346,40 +6216,7 @@
                 <a:ea typeface="Consolas"/>
                 <a:cs typeface="Consolas"/>
               </a:rPr>
-              <a:t>address(a[3]) = base + 3 × 4</a:t>
-            </a:r>
-          </a:p>
-          <a:p xmlns:a="http://schemas.openxmlformats.org/drawingml/2006/main">
-            <a:pPr marL="0" indent="0">
-              <a:lnSpc>
-                <a:spcPct val="112000"/>
-              </a:lnSpc>
-              <a:spcBef>
-                <a:spcPts val="0"/>
-              </a:spcBef>
-              <a:spcAft>
-                <a:spcPts val="0"/>
-              </a:spcAft>
-              <a:buNone/>
-              <a:defRPr sz="1800">
-                <a:solidFill>
-                  <a:srgbClr val="FFFFFF"/>
-                </a:solidFill>
-                <a:latin typeface="Consolas"/>
-                <a:ea typeface="Consolas"/>
-                <a:cs typeface="Consolas"/>
-              </a:defRPr>
-            </a:pPr>
-            <a:r>
-              <a:rPr sz="1800">
-                <a:solidFill>
-                  <a:srgbClr val="FFFFFF"/>
-                </a:solidFill>
-                <a:latin typeface="Consolas"/>
-                <a:ea typeface="Consolas"/>
-                <a:cs typeface="Consolas"/>
-              </a:rPr>
-              <a:t>              = base + 12</a:t>
+              <a:t>= base + (i × cols + j) × sizeof(int)</a:t>
             </a:r>
           </a:p>
         </p:txBody>
@@ -6389,7 +6226,7 @@
           <p:cNvPr id="534" name="Takeaway">
             <a:extLst xmlns:a="http://schemas.openxmlformats.org/drawingml/2006/main">
               <a:ext uri="{FF2B5EF4-FFF2-40B4-BE49-F238E27FC236}">
-                <a16:creationId xmlns:a16="http://schemas.microsoft.com/office/drawing/2014/main" id="{F0D4B618-C8D7-4561-9D00-E0C318CE736D}"/>
+                <a16:creationId xmlns:a16="http://schemas.microsoft.com/office/drawing/2014/main" id="{9DEC82DC-1C64-4C3C-AAA9-B564EF50E386}"/>
               </a:ext>
             </a:extLst>
           </p:cNvPr>
@@ -6446,7 +6283,7 @@
                 <a:ea typeface="Arial"/>
                 <a:cs typeface="Arial"/>
               </a:rPr>
-              <a:t>Indices start at 0: index 2 selects the third element. C pointer arithmetic scales by element size.</a:t>
+              <a:t>rows limits valid values of i; cols determines the row stride used in the address.</a:t>
             </a:r>
           </a:p>
         </p:txBody>
@@ -6654,7 +6491,7 @@
                 <a:ea typeface="Arial"/>
                 <a:cs typeface="Arial"/>
               </a:rPr>
-              <a:t>Variable-length arrays</a:t>
+              <a:t>A stack frame</a:t>
             </a:r>
           </a:p>
         </p:txBody>
@@ -6880,7 +6717,7 @@
                 <a:ea typeface="Arial"/>
                 <a:cs typeface="Arial"/>
               </a:rPr>
-              <a:t>A VLA’s size is known only at runtime. The compiler must compute how many bytes the current function needs.</a:t>
+              <a:t>Each function call gets a frame for its local work. On x86-64, the stack grows toward lower addresses.</a:t>
             </a:r>
           </a:p>
           <a:p xmlns:a="http://schemas.openxmlformats.org/drawingml/2006/main">
@@ -6930,7 +6767,7 @@
                 <a:ea typeface="Arial"/>
                 <a:cs typeface="Arial"/>
               </a:rPr>
-              <a:t>For a row-major 2D array, the column count determines the row stride.</a:t>
+              <a:t>%rsp marks the top of the stack. %rbp may provide a stable frame reference.</a:t>
             </a:r>
           </a:p>
         </p:txBody>
@@ -7156,7 +6993,7 @@
                 <a:ea typeface="Consolas"/>
                 <a:cs typeface="Consolas"/>
               </a:rPr>
-              <a:t>void f(size_t rows, size_t cols,</a:t>
+              <a:t>pushq %rbp</a:t>
             </a:r>
           </a:p>
           <a:p xmlns:a="http://schemas.openxmlformats.org/drawingml/2006/main">
@@ -7189,24 +7026,7 @@
                 <a:ea typeface="Consolas"/>
                 <a:cs typeface="Consolas"/>
               </a:rPr>
-              <a:t>       int a[rows][cols]);</a:t>
-            </a:r>
-          </a:p>
-          <a:p xmlns:a="http://schemas.openxmlformats.org/drawingml/2006/main">
-            <a:pPr marL="0" indent="0">
-              <a:lnSpc>
-                <a:spcPct val="112000"/>
-              </a:lnSpc>
-              <a:spcBef>
-                <a:spcPts val="0"/>
-              </a:spcBef>
-              <a:spcAft>
-                <a:spcPts val="0"/>
-              </a:spcAft>
-              <a:buNone/>
-            </a:pPr>
-            <a:r>
-              <a:t/>
+              <a:t>movq  %rsp, %rbp</a:t>
             </a:r>
           </a:p>
           <a:p xmlns:a="http://schemas.openxmlformats.org/drawingml/2006/main">
@@ -7239,7 +7059,7 @@
                 <a:ea typeface="Consolas"/>
                 <a:cs typeface="Consolas"/>
               </a:rPr>
-              <a:t>address(a[i][j])</a:t>
+              <a:t>subq  $24, %rsp   # reserve space</a:t>
             </a:r>
           </a:p>
           <a:p xmlns:a="http://schemas.openxmlformats.org/drawingml/2006/main">
@@ -7272,7 +7092,106 @@
                 <a:ea typeface="Consolas"/>
                 <a:cs typeface="Consolas"/>
               </a:rPr>
-              <a:t>= base + (i × cols + j) × sizeof(int)</a:t>
+              <a:t>   ...</a:t>
+            </a:r>
+          </a:p>
+          <a:p xmlns:a="http://schemas.openxmlformats.org/drawingml/2006/main">
+            <a:pPr marL="0" indent="0">
+              <a:lnSpc>
+                <a:spcPct val="112000"/>
+              </a:lnSpc>
+              <a:spcBef>
+                <a:spcPts val="0"/>
+              </a:spcBef>
+              <a:spcAft>
+                <a:spcPts val="0"/>
+              </a:spcAft>
+              <a:buNone/>
+              <a:defRPr sz="1800">
+                <a:solidFill>
+                  <a:srgbClr val="FFFFFF"/>
+                </a:solidFill>
+                <a:latin typeface="Consolas"/>
+                <a:ea typeface="Consolas"/>
+                <a:cs typeface="Consolas"/>
+              </a:defRPr>
+            </a:pPr>
+            <a:r>
+              <a:rPr sz="1800">
+                <a:solidFill>
+                  <a:srgbClr val="FFFFFF"/>
+                </a:solidFill>
+                <a:latin typeface="Consolas"/>
+                <a:ea typeface="Consolas"/>
+                <a:cs typeface="Consolas"/>
+              </a:rPr>
+              <a:t>movq  %rbp, %rsp  # discard locals</a:t>
+            </a:r>
+          </a:p>
+          <a:p xmlns:a="http://schemas.openxmlformats.org/drawingml/2006/main">
+            <a:pPr marL="0" indent="0">
+              <a:lnSpc>
+                <a:spcPct val="112000"/>
+              </a:lnSpc>
+              <a:spcBef>
+                <a:spcPts val="0"/>
+              </a:spcBef>
+              <a:spcAft>
+                <a:spcPts val="0"/>
+              </a:spcAft>
+              <a:buNone/>
+              <a:defRPr sz="1800">
+                <a:solidFill>
+                  <a:srgbClr val="FFFFFF"/>
+                </a:solidFill>
+                <a:latin typeface="Consolas"/>
+                <a:ea typeface="Consolas"/>
+                <a:cs typeface="Consolas"/>
+              </a:defRPr>
+            </a:pPr>
+            <a:r>
+              <a:rPr sz="1800">
+                <a:solidFill>
+                  <a:srgbClr val="FFFFFF"/>
+                </a:solidFill>
+                <a:latin typeface="Consolas"/>
+                <a:ea typeface="Consolas"/>
+                <a:cs typeface="Consolas"/>
+              </a:rPr>
+              <a:t>popq  %rbp        # restore caller frame</a:t>
+            </a:r>
+          </a:p>
+          <a:p xmlns:a="http://schemas.openxmlformats.org/drawingml/2006/main">
+            <a:pPr marL="0" indent="0">
+              <a:lnSpc>
+                <a:spcPct val="112000"/>
+              </a:lnSpc>
+              <a:spcBef>
+                <a:spcPts val="0"/>
+              </a:spcBef>
+              <a:spcAft>
+                <a:spcPts val="0"/>
+              </a:spcAft>
+              <a:buNone/>
+              <a:defRPr sz="1800">
+                <a:solidFill>
+                  <a:srgbClr val="FFFFFF"/>
+                </a:solidFill>
+                <a:latin typeface="Consolas"/>
+                <a:ea typeface="Consolas"/>
+                <a:cs typeface="Consolas"/>
+              </a:defRPr>
+            </a:pPr>
+            <a:r>
+              <a:rPr sz="1800">
+                <a:solidFill>
+                  <a:srgbClr val="FFFFFF"/>
+                </a:solidFill>
+                <a:latin typeface="Consolas"/>
+                <a:ea typeface="Consolas"/>
+                <a:cs typeface="Consolas"/>
+              </a:rPr>
+              <a:t>ret</a:t>
             </a:r>
           </a:p>
         </p:txBody>
@@ -7282,7 +7201,7 @@
           <p:cNvPr id="534" name="Takeaway">
             <a:extLst xmlns:a="http://schemas.openxmlformats.org/drawingml/2006/main">
               <a:ext uri="{FF2B5EF4-FFF2-40B4-BE49-F238E27FC236}">
-                <a16:creationId xmlns:a16="http://schemas.microsoft.com/office/drawing/2014/main" id="{680DB521-6E67-47F2-8856-1BAE1BFA20FF}"/>
+                <a16:creationId xmlns:a16="http://schemas.microsoft.com/office/drawing/2014/main" id="{5879D53E-C48B-43B7-A473-702F5340E520}"/>
               </a:ext>
             </a:extLst>
           </p:cNvPr>
@@ -7339,7 +7258,7 @@
                 <a:ea typeface="Arial"/>
                 <a:cs typeface="Arial"/>
               </a:rPr>
-              <a:t>rows limits valid values of i; cols determines the row stride used in the address.</a:t>
+              <a:t>leave performs movq %rbp, %rsp followed by popq %rbp. Check which register is the destination.</a:t>
             </a:r>
           </a:p>
         </p:txBody>
@@ -7547,7 +7466,7 @@
                 <a:ea typeface="Arial"/>
                 <a:cs typeface="Arial"/>
               </a:rPr>
-              <a:t>A stack frame</a:t>
+              <a:t>Stack or heap?</a:t>
             </a:r>
           </a:p>
         </p:txBody>
@@ -7773,7 +7692,7 @@
                 <a:ea typeface="Arial"/>
                 <a:cs typeface="Arial"/>
               </a:rPr>
-              <a:t>Each function call gets a frame for its local work. On x86-64, the stack grows toward lower addresses.</a:t>
+              <a:t>Stack: automatic lifetime, tied to a function call.</a:t>
             </a:r>
           </a:p>
           <a:p xmlns:a="http://schemas.openxmlformats.org/drawingml/2006/main">
@@ -7823,7 +7742,57 @@
                 <a:ea typeface="Arial"/>
                 <a:cs typeface="Arial"/>
               </a:rPr>
-              <a:t>%rsp marks the top of the stack. %rbp may provide a stable frame reference.</a:t>
+              <a:t>Heap: requested at runtime and remains allocated until free.</a:t>
+            </a:r>
+          </a:p>
+          <a:p xmlns:a="http://schemas.openxmlformats.org/drawingml/2006/main">
+            <a:pPr marL="0" indent="0">
+              <a:lnSpc>
+                <a:spcPct val="112000"/>
+              </a:lnSpc>
+              <a:spcBef>
+                <a:spcPts val="0"/>
+              </a:spcBef>
+              <a:spcAft>
+                <a:spcPts val="0"/>
+              </a:spcAft>
+              <a:buNone/>
+            </a:pPr>
+            <a:r>
+              <a:t/>
+            </a:r>
+          </a:p>
+          <a:p xmlns:a="http://schemas.openxmlformats.org/drawingml/2006/main">
+            <a:pPr marL="0" indent="0">
+              <a:lnSpc>
+                <a:spcPct val="112000"/>
+              </a:lnSpc>
+              <a:spcBef>
+                <a:spcPts val="0"/>
+              </a:spcBef>
+              <a:spcAft>
+                <a:spcPts val="0"/>
+              </a:spcAft>
+              <a:buNone/>
+              <a:defRPr sz="1875">
+                <a:solidFill>
+                  <a:srgbClr val="FFFFFF"/>
+                </a:solidFill>
+                <a:latin typeface="Arial"/>
+                <a:ea typeface="Arial"/>
+                <a:cs typeface="Arial"/>
+              </a:defRPr>
+            </a:pPr>
+            <a:r>
+              <a:rPr sz="1875">
+                <a:solidFill>
+                  <a:srgbClr val="FFFFFF"/>
+                </a:solidFill>
+                <a:latin typeface="Arial"/>
+                <a:ea typeface="Arial"/>
+                <a:cs typeface="Arial"/>
+              </a:rPr>
+              <a:t>A pointer may live on the stack while the memory it points to lives on the heap.</a:t>
             </a:r>
           </a:p>
         </p:txBody>
@@ -8049,7 +8018,24 @@
                 <a:ea typeface="Consolas"/>
                 <a:cs typeface="Consolas"/>
               </a:rPr>
-              <a:t>pushq %rbp</a:t>
+              <a:t>int local[10];          // stack</a:t>
+            </a:r>
+          </a:p>
+          <a:p xmlns:a="http://schemas.openxmlformats.org/drawingml/2006/main">
+            <a:pPr marL="0" indent="0">
+              <a:lnSpc>
+                <a:spcPct val="112000"/>
+              </a:lnSpc>
+              <a:spcBef>
+                <a:spcPts val="0"/>
+              </a:spcBef>
+              <a:spcAft>
+                <a:spcPts val="0"/>
+              </a:spcAft>
+              <a:buNone/>
+            </a:pPr>
+            <a:r>
+              <a:t/>
             </a:r>
           </a:p>
           <a:p xmlns:a="http://schemas.openxmlformats.org/drawingml/2006/main">
@@ -8082,7 +8068,7 @@
                 <a:ea typeface="Consolas"/>
                 <a:cs typeface="Consolas"/>
               </a:rPr>
-              <a:t>movq  %rsp, %rbp</a:t>
+              <a:t>int *data = malloc(n * sizeof *data);</a:t>
             </a:r>
           </a:p>
           <a:p xmlns:a="http://schemas.openxmlformats.org/drawingml/2006/main">
@@ -8115,7 +8101,24 @@
                 <a:ea typeface="Consolas"/>
                 <a:cs typeface="Consolas"/>
               </a:rPr>
-              <a:t>subq  $24, %rsp   # reserve space</a:t>
+              <a:t>if (data == NULL) { /* handle failure */ }</a:t>
+            </a:r>
+          </a:p>
+          <a:p xmlns:a="http://schemas.openxmlformats.org/drawingml/2006/main">
+            <a:pPr marL="0" indent="0">
+              <a:lnSpc>
+                <a:spcPct val="112000"/>
+              </a:lnSpc>
+              <a:spcBef>
+                <a:spcPts val="0"/>
+              </a:spcBef>
+              <a:spcAft>
+                <a:spcPts val="0"/>
+              </a:spcAft>
+              <a:buNone/>
+            </a:pPr>
+            <a:r>
+              <a:t/>
             </a:r>
           </a:p>
           <a:p xmlns:a="http://schemas.openxmlformats.org/drawingml/2006/main">
@@ -8148,7 +8151,7 @@
                 <a:ea typeface="Consolas"/>
                 <a:cs typeface="Consolas"/>
               </a:rPr>
-              <a:t>   ...</a:t>
+              <a:t>free(data);</a:t>
             </a:r>
           </a:p>
           <a:p xmlns:a="http://schemas.openxmlformats.org/drawingml/2006/main">
@@ -8181,73 +8184,7 @@
                 <a:ea typeface="Consolas"/>
                 <a:cs typeface="Consolas"/>
               </a:rPr>
-              <a:t>movq  %rbp, %rsp  # discard locals</a:t>
-            </a:r>
-          </a:p>
-          <a:p xmlns:a="http://schemas.openxmlformats.org/drawingml/2006/main">
-            <a:pPr marL="0" indent="0">
-              <a:lnSpc>
-                <a:spcPct val="112000"/>
-              </a:lnSpc>
-              <a:spcBef>
-                <a:spcPts val="0"/>
-              </a:spcBef>
-              <a:spcAft>
-                <a:spcPts val="0"/>
-              </a:spcAft>
-              <a:buNone/>
-              <a:defRPr sz="1800">
-                <a:solidFill>
-                  <a:srgbClr val="FFFFFF"/>
-                </a:solidFill>
-                <a:latin typeface="Consolas"/>
-                <a:ea typeface="Consolas"/>
-                <a:cs typeface="Consolas"/>
-              </a:defRPr>
-            </a:pPr>
-            <a:r>
-              <a:rPr sz="1800">
-                <a:solidFill>
-                  <a:srgbClr val="FFFFFF"/>
-                </a:solidFill>
-                <a:latin typeface="Consolas"/>
-                <a:ea typeface="Consolas"/>
-                <a:cs typeface="Consolas"/>
-              </a:rPr>
-              <a:t>popq  %rbp        # restore caller frame</a:t>
-            </a:r>
-          </a:p>
-          <a:p xmlns:a="http://schemas.openxmlformats.org/drawingml/2006/main">
-            <a:pPr marL="0" indent="0">
-              <a:lnSpc>
-                <a:spcPct val="112000"/>
-              </a:lnSpc>
-              <a:spcBef>
-                <a:spcPts val="0"/>
-              </a:spcBef>
-              <a:spcAft>
-                <a:spcPts val="0"/>
-              </a:spcAft>
-              <a:buNone/>
-              <a:defRPr sz="1800">
-                <a:solidFill>
-                  <a:srgbClr val="FFFFFF"/>
-                </a:solidFill>
-                <a:latin typeface="Consolas"/>
-                <a:ea typeface="Consolas"/>
-                <a:cs typeface="Consolas"/>
-              </a:defRPr>
-            </a:pPr>
-            <a:r>
-              <a:rPr sz="1800">
-                <a:solidFill>
-                  <a:srgbClr val="FFFFFF"/>
-                </a:solidFill>
-                <a:latin typeface="Consolas"/>
-                <a:ea typeface="Consolas"/>
-                <a:cs typeface="Consolas"/>
-              </a:rPr>
-              <a:t>ret</a:t>
+              <a:t>data = NULL;</a:t>
             </a:r>
           </a:p>
         </p:txBody>
@@ -8257,7 +8194,7 @@
           <p:cNvPr id="534" name="Takeaway">
             <a:extLst xmlns:a="http://schemas.openxmlformats.org/drawingml/2006/main">
               <a:ext uri="{FF2B5EF4-FFF2-40B4-BE49-F238E27FC236}">
-                <a16:creationId xmlns:a16="http://schemas.microsoft.com/office/drawing/2014/main" id="{EBB9247C-EEAE-45BD-9ADB-6CE41C087F05}"/>
+                <a16:creationId xmlns:a16="http://schemas.microsoft.com/office/drawing/2014/main" id="{9E630726-DC14-4620-87A6-EEE8A7E30F0E}"/>
               </a:ext>
             </a:extLst>
           </p:cNvPr>
@@ -8314,7 +8251,7 @@
                 <a:ea typeface="Arial"/>
                 <a:cs typeface="Arial"/>
               </a:rPr>
-              <a:t>leave performs movq %rbp, %rsp followed by popq %rbp. Check which register is the destination.</a:t>
+              <a:t>Losing the last pointer before free causes a leak; using memory after free is invalid.</a:t>
             </a:r>
           </a:p>
         </p:txBody>
@@ -8522,7 +8459,7 @@
                 <a:ea typeface="Arial"/>
                 <a:cs typeface="Arial"/>
               </a:rPr>
-              <a:t>Stack or heap?</a:t>
+              <a:t>Quick check</a:t>
             </a:r>
           </a:p>
         </p:txBody>
@@ -8748,7 +8685,7 @@
                 <a:ea typeface="Arial"/>
                 <a:cs typeface="Arial"/>
               </a:rPr>
-              <a:t>Stack: automatic lifetime, tied to a function call.</a:t>
+              <a:t>1. Convert 1011 0110₂ to hex.</a:t>
             </a:r>
           </a:p>
           <a:p xmlns:a="http://schemas.openxmlformats.org/drawingml/2006/main">
@@ -8798,7 +8735,7 @@
                 <a:ea typeface="Arial"/>
                 <a:cs typeface="Arial"/>
               </a:rPr>
-              <a:t>Heap: requested at runtime and remains allocated until free.</a:t>
+              <a:t>2. Convert 0x4D to binary.</a:t>
             </a:r>
           </a:p>
           <a:p xmlns:a="http://schemas.openxmlformats.org/drawingml/2006/main">
@@ -8848,7 +8785,7 @@
                 <a:ea typeface="Arial"/>
                 <a:cs typeface="Arial"/>
               </a:rPr>
-              <a:t>A pointer may live on the stack while the memory it points to lives on the heap.</a:t>
+              <a:t>3. In movq $8, %rax, which operand is the destination?</a:t>
             </a:r>
           </a:p>
         </p:txBody>
@@ -9074,7 +9011,7 @@
                 <a:ea typeface="Consolas"/>
                 <a:cs typeface="Consolas"/>
               </a:rPr>
-              <a:t>int local[10];          // stack</a:t>
+              <a:t>4. If an int array begins at 0x1000, where is a[5]?</a:t>
             </a:r>
           </a:p>
           <a:p xmlns:a="http://schemas.openxmlformats.org/drawingml/2006/main">
@@ -9124,7 +9061,24 @@
                 <a:ea typeface="Consolas"/>
                 <a:cs typeface="Consolas"/>
               </a:rPr>
-              <a:t>int *data = malloc(n * sizeof *data);</a:t>
+              <a:t>5. Which storage must be released with free?</a:t>
+            </a:r>
+          </a:p>
+          <a:p xmlns:a="http://schemas.openxmlformats.org/drawingml/2006/main">
+            <a:pPr marL="0" indent="0">
+              <a:lnSpc>
+                <a:spcPct val="112000"/>
+              </a:lnSpc>
+              <a:spcBef>
+                <a:spcPts val="0"/>
+              </a:spcBef>
+              <a:spcAft>
+                <a:spcPts val="0"/>
+              </a:spcAft>
+              <a:buNone/>
+            </a:pPr>
+            <a:r>
+              <a:t/>
             </a:r>
           </a:p>
           <a:p xmlns:a="http://schemas.openxmlformats.org/drawingml/2006/main">
@@ -9157,24 +9111,7 @@
                 <a:ea typeface="Consolas"/>
                 <a:cs typeface="Consolas"/>
               </a:rPr>
-              <a:t>if (data == NULL) { /* handle failure */ }</a:t>
-            </a:r>
-          </a:p>
-          <a:p xmlns:a="http://schemas.openxmlformats.org/drawingml/2006/main">
-            <a:pPr marL="0" indent="0">
-              <a:lnSpc>
-                <a:spcPct val="112000"/>
-              </a:lnSpc>
-              <a:spcBef>
-                <a:spcPts val="0"/>
-              </a:spcBef>
-              <a:spcAft>
-                <a:spcPts val="0"/>
-              </a:spcAft>
-              <a:buNone/>
-            </a:pPr>
-            <a:r>
-              <a:t/>
+              <a:t>6. Mini-float 0 100 1000</a:t>
             </a:r>
           </a:p>
           <a:p xmlns:a="http://schemas.openxmlformats.org/drawingml/2006/main">
@@ -9207,7 +9144,7 @@
                 <a:ea typeface="Consolas"/>
                 <a:cs typeface="Consolas"/>
               </a:rPr>
-              <a:t>free(data);</a:t>
+              <a:t>   Bias 3</a:t>
             </a:r>
           </a:p>
           <a:p xmlns:a="http://schemas.openxmlformats.org/drawingml/2006/main">
@@ -9240,7 +9177,7 @@
                 <a:ea typeface="Consolas"/>
                 <a:cs typeface="Consolas"/>
               </a:rPr>
-              <a:t>data = NULL;</a:t>
+              <a:t>   What value is it?</a:t>
             </a:r>
           </a:p>
         </p:txBody>
@@ -9250,7 +9187,7 @@
           <p:cNvPr id="534" name="Takeaway">
             <a:extLst xmlns:a="http://schemas.openxmlformats.org/drawingml/2006/main">
               <a:ext uri="{FF2B5EF4-FFF2-40B4-BE49-F238E27FC236}">
-                <a16:creationId xmlns:a16="http://schemas.microsoft.com/office/drawing/2014/main" id="{29AFDAA5-077D-4AE4-A648-83FE4F570222}"/>
+                <a16:creationId xmlns:a16="http://schemas.microsoft.com/office/drawing/2014/main" id="{0D9E1135-F5D8-461F-A4E6-2587C8DEBF96}"/>
               </a:ext>
             </a:extLst>
           </p:cNvPr>
@@ -9307,7 +9244,7 @@
                 <a:ea typeface="Arial"/>
                 <a:cs typeface="Arial"/>
               </a:rPr>
-              <a:t>Losing the last pointer before free causes a leak; using memory after free is invalid.</a:t>
+              <a:t>Answer each by showing the representation or address calculation.</a:t>
             </a:r>
           </a:p>
         </p:txBody>
@@ -9515,7 +9452,7 @@
                 <a:ea typeface="Arial"/>
                 <a:cs typeface="Arial"/>
               </a:rPr>
-              <a:t>Quick check</a:t>
+              <a:t>Quick check answers</a:t>
             </a:r>
           </a:p>
         </p:txBody>
@@ -9741,7 +9678,7 @@
                 <a:ea typeface="Arial"/>
                 <a:cs typeface="Arial"/>
               </a:rPr>
-              <a:t>1. Convert 1011 0110₂ to hex.</a:t>
+              <a:t>1. 0xB6</a:t>
             </a:r>
           </a:p>
           <a:p xmlns:a="http://schemas.openxmlformats.org/drawingml/2006/main">
@@ -9791,7 +9728,7 @@
                 <a:ea typeface="Arial"/>
                 <a:cs typeface="Arial"/>
               </a:rPr>
-              <a:t>2. Convert 0x4D to binary.</a:t>
+              <a:t>2. 0100 1101₂</a:t>
             </a:r>
           </a:p>
           <a:p xmlns:a="http://schemas.openxmlformats.org/drawingml/2006/main">
@@ -9841,7 +9778,7 @@
                 <a:ea typeface="Arial"/>
                 <a:cs typeface="Arial"/>
               </a:rPr>
-              <a:t>3. In movq $8, %rax, which operand is the destination?</a:t>
+              <a:t>3. %rax</a:t>
             </a:r>
           </a:p>
         </p:txBody>
@@ -10067,7 +10004,7 @@
                 <a:ea typeface="Consolas"/>
                 <a:cs typeface="Consolas"/>
               </a:rPr>
-              <a:t>4. If an int array begins at 0x1000, where is a[5]?</a:t>
+              <a:t>4. 0x1000 + 5 × 4 = 0x1014</a:t>
             </a:r>
           </a:p>
           <a:p xmlns:a="http://schemas.openxmlformats.org/drawingml/2006/main">
@@ -10117,7 +10054,7 @@
                 <a:ea typeface="Consolas"/>
                 <a:cs typeface="Consolas"/>
               </a:rPr>
-              <a:t>5. Which storage must be released with free?</a:t>
+              <a:t>5. Heap storage from malloc/calloc/realloc</a:t>
             </a:r>
           </a:p>
           <a:p xmlns:a="http://schemas.openxmlformats.org/drawingml/2006/main">
@@ -10167,73 +10104,7 @@
                 <a:ea typeface="Consolas"/>
                 <a:cs typeface="Consolas"/>
               </a:rPr>
-              <a:t>6. Mini-float 0 100 1000</a:t>
-            </a:r>
-          </a:p>
-          <a:p xmlns:a="http://schemas.openxmlformats.org/drawingml/2006/main">
-            <a:pPr marL="0" indent="0">
-              <a:lnSpc>
-                <a:spcPct val="112000"/>
-              </a:lnSpc>
-              <a:spcBef>
-                <a:spcPts val="0"/>
-              </a:spcBef>
-              <a:spcAft>
-                <a:spcPts val="0"/>
-              </a:spcAft>
-              <a:buNone/>
-              <a:defRPr sz="1800">
-                <a:solidFill>
-                  <a:srgbClr val="FFFFFF"/>
-                </a:solidFill>
-                <a:latin typeface="Consolas"/>
-                <a:ea typeface="Consolas"/>
-                <a:cs typeface="Consolas"/>
-              </a:defRPr>
-            </a:pPr>
-            <a:r>
-              <a:rPr sz="1800">
-                <a:solidFill>
-                  <a:srgbClr val="FFFFFF"/>
-                </a:solidFill>
-                <a:latin typeface="Consolas"/>
-                <a:ea typeface="Consolas"/>
-                <a:cs typeface="Consolas"/>
-              </a:rPr>
-              <a:t>   Bias 3</a:t>
-            </a:r>
-          </a:p>
-          <a:p xmlns:a="http://schemas.openxmlformats.org/drawingml/2006/main">
-            <a:pPr marL="0" indent="0">
-              <a:lnSpc>
-                <a:spcPct val="112000"/>
-              </a:lnSpc>
-              <a:spcBef>
-                <a:spcPts val="0"/>
-              </a:spcBef>
-              <a:spcAft>
-                <a:spcPts val="0"/>
-              </a:spcAft>
-              <a:buNone/>
-              <a:defRPr sz="1800">
-                <a:solidFill>
-                  <a:srgbClr val="FFFFFF"/>
-                </a:solidFill>
-                <a:latin typeface="Consolas"/>
-                <a:ea typeface="Consolas"/>
-                <a:cs typeface="Consolas"/>
-              </a:defRPr>
-            </a:pPr>
-            <a:r>
-              <a:rPr sz="1800">
-                <a:solidFill>
-                  <a:srgbClr val="FFFFFF"/>
-                </a:solidFill>
-                <a:latin typeface="Consolas"/>
-                <a:ea typeface="Consolas"/>
-                <a:cs typeface="Consolas"/>
-              </a:rPr>
-              <a:t>   What value is it?</a:t>
+              <a:t>6. (+1) × 2¹ × 1.5 = 3.0</a:t>
             </a:r>
           </a:p>
         </p:txBody>
@@ -10243,934 +10114,7 @@
           <p:cNvPr id="534" name="Takeaway">
             <a:extLst xmlns:a="http://schemas.openxmlformats.org/drawingml/2006/main">
               <a:ext uri="{FF2B5EF4-FFF2-40B4-BE49-F238E27FC236}">
-                <a16:creationId xmlns:a16="http://schemas.microsoft.com/office/drawing/2014/main" id="{9A3B6A7B-9A28-4E24-B5CF-A13C06347E89}"/>
-              </a:ext>
-            </a:extLst>
-          </p:cNvPr>
-          <p:cNvSpPr>
-            <a:spLocks xmlns:a="http://schemas.openxmlformats.org/drawingml/2006/main" noGrp="1"/>
-          </p:cNvSpPr>
-          <p:nvPr/>
-        </p:nvSpPr>
-        <p:spPr>
-          <a:xfrm xmlns:a="http://schemas.openxmlformats.org/drawingml/2006/main">
-            <a:off x="393668" y="5715000"/>
-            <a:ext cx="11404283" cy="466725"/>
-          </a:xfrm>
-          <a:prstGeom xmlns:a="http://schemas.openxmlformats.org/drawingml/2006/main" prst="rect">
-            <a:avLst/>
-          </a:prstGeom>
-          <a:noFill xmlns:a="http://schemas.openxmlformats.org/drawingml/2006/main"/>
-          <a:ln xmlns:a="http://schemas.openxmlformats.org/drawingml/2006/main" w="0">
-            <a:noFill/>
-          </a:ln>
-        </p:spPr>
-        <p:txBody>
-          <a:bodyPr xmlns:a="http://schemas.openxmlformats.org/drawingml/2006/main" lIns="0" tIns="0" rIns="0" bIns="0" anchor="t">
-            <a:noAutofit/>
-          </a:bodyPr>
-          <a:lstStyle xmlns:a="http://schemas.openxmlformats.org/drawingml/2006/main"/>
-          <a:p xmlns:a="http://schemas.openxmlformats.org/drawingml/2006/main">
-            <a:pPr marL="0" indent="0">
-              <a:lnSpc>
-                <a:spcPct val="112000"/>
-              </a:lnSpc>
-              <a:spcBef>
-                <a:spcPts val="0"/>
-              </a:spcBef>
-              <a:spcAft>
-                <a:spcPts val="0"/>
-              </a:spcAft>
-              <a:buNone/>
-              <a:defRPr sz="1350">
-                <a:solidFill>
-                  <a:srgbClr val="CCCCCC"/>
-                </a:solidFill>
-                <a:latin typeface="Arial"/>
-                <a:ea typeface="Arial"/>
-                <a:cs typeface="Arial"/>
-              </a:defRPr>
-            </a:pPr>
-            <a:r>
-              <a:rPr sz="1350">
-                <a:solidFill>
-                  <a:srgbClr val="CCCCCC"/>
-                </a:solidFill>
-                <a:latin typeface="Arial"/>
-                <a:ea typeface="Arial"/>
-                <a:cs typeface="Arial"/>
-              </a:rPr>
-              <a:t>Answer each by showing the representation or address calculation.</a:t>
-            </a:r>
-          </a:p>
-        </p:txBody>
-      </p:sp>
-    </p:spTree>
-    <p:extLst>
-      <p:ext uri="{BB962C8B-B14F-4D97-AF65-F5344CB8AC3E}">
-        <p14:creationId xmlns:p14="http://schemas.microsoft.com/office/powerpoint/2010/main" val="3667182145"/>
-      </p:ext>
-    </p:extLst>
-  </p:cSld>
-</p:sld>
-</file>
-
-<file path=ppt/slides/slide16.xml><?xml version="1.0" encoding="utf-8"?>
-<p:sld xmlns:p="http://schemas.openxmlformats.org/presentationml/2006/main">
-  <p:cSld>
-    <p:spTree>
-      <p:nvGrpSpPr>
-        <p:cNvPr id="1" name=""/>
-        <p:cNvGrpSpPr/>
-        <p:nvPr/>
-      </p:nvGrpSpPr>
-      <p:grpSpPr>
-        <a:xfrm xmlns:a="http://schemas.openxmlformats.org/drawingml/2006/main"/>
-      </p:grpSpPr>
-      <p:sp>
-        <p:nvSpPr>
-          <p:cNvPr id="3" name="Footer Placeholder 2">
-            <a:extLst xmlns:a="http://schemas.openxmlformats.org/drawingml/2006/main">
-              <a:ext uri="{FF2B5EF4-FFF2-40B4-BE49-F238E27FC236}">
-                <a16:creationId xmlns:a16="http://schemas.microsoft.com/office/drawing/2014/main" id="{39EA4C82-C623-0196-4A95-876ADF5DEE92}"/>
-              </a:ext>
-            </a:extLst>
-          </p:cNvPr>
-          <p:cNvSpPr>
-            <a:spLocks xmlns:a="http://schemas.openxmlformats.org/drawingml/2006/main" noGrp="1"/>
-          </p:cNvSpPr>
-          <p:nvPr>
-            <p:ph type="ftr" idx="3"/>
-          </p:nvPr>
-        </p:nvSpPr>
-        <p:spPr>
-          <a:xfrm xmlns:a="http://schemas.openxmlformats.org/drawingml/2006/main">
-            <a:off x="393700" y="6279952"/>
-            <a:ext cx="3568700" cy="241240"/>
-          </a:xfrm>
-        </p:spPr>
-        <p:txBody>
-          <a:bodyPr xmlns:a="http://schemas.openxmlformats.org/drawingml/2006/main" lIns="0" tIns="0" rIns="0" bIns="0" anchor="t">
-            <a:noAutofit/>
-          </a:bodyPr>
-          <a:lstStyle xmlns:a="http://schemas.openxmlformats.org/drawingml/2006/main"/>
-          <a:p xmlns:a="http://schemas.openxmlformats.org/drawingml/2006/main">
-            <a:pPr marL="0" indent="0">
-              <a:lnSpc>
-                <a:spcPct val="112000"/>
-              </a:lnSpc>
-              <a:spcBef>
-                <a:spcPts val="0"/>
-              </a:spcBef>
-              <a:spcAft>
-                <a:spcPts val="0"/>
-              </a:spcAft>
-              <a:buNone/>
-              <a:defRPr sz="1125">
-                <a:solidFill>
-                  <a:srgbClr val="FFFFFF"/>
-                </a:solidFill>
-                <a:latin typeface="Arial"/>
-                <a:ea typeface="Arial"/>
-                <a:cs typeface="Arial"/>
-              </a:defRPr>
-            </a:pPr>
-            <a:r>
-              <a:rPr sz="1125">
-                <a:solidFill>
-                  <a:srgbClr val="FFFFFF"/>
-                </a:solidFill>
-                <a:latin typeface="Arial"/>
-                <a:ea typeface="Arial"/>
-                <a:cs typeface="Arial"/>
-              </a:rPr>
-              <a:t>CS 211 · Recitation 04</a:t>
-            </a:r>
-          </a:p>
-        </p:txBody>
-      </p:sp>
-      <p:sp>
-        <p:nvSpPr>
-          <p:cNvPr id="532" name="Google Shape;532;p58">
-            <a:extLst xmlns:a="http://schemas.openxmlformats.org/drawingml/2006/main">
-              <a:ext uri="{FF2B5EF4-FFF2-40B4-BE49-F238E27FC236}">
-                <a16:creationId xmlns:a16="http://schemas.microsoft.com/office/drawing/2014/main" id="{1BCBE750-7048-686D-1472-52C53362D6CD}"/>
-              </a:ext>
-            </a:extLst>
-          </p:cNvPr>
-          <p:cNvSpPr>
-            <a:spLocks xmlns:a="http://schemas.openxmlformats.org/drawingml/2006/main" noGrp="1"/>
-          </p:cNvSpPr>
-          <p:nvPr>
-            <p:ph type="sldNum" idx="4"/>
-          </p:nvPr>
-        </p:nvSpPr>
-        <p:spPr>
-          <a:xfrm xmlns:a="http://schemas.openxmlformats.org/drawingml/2006/main">
-            <a:off x="11279332" y="6279294"/>
-            <a:ext cx="518968" cy="241240"/>
-          </a:xfrm>
-        </p:spPr>
-        <p:txBody>
-          <a:bodyPr xmlns:a="http://schemas.openxmlformats.org/drawingml/2006/main" spcFirstLastPara="1" vert="horz" wrap="square" lIns="0" tIns="0" rIns="0" bIns="0" anchor="t">
-            <a:noAutofit/>
-          </a:bodyPr>
-          <a:lstStyle xmlns:a="http://schemas.openxmlformats.org/drawingml/2006/main"/>
-          <a:p xmlns:a="http://schemas.openxmlformats.org/drawingml/2006/main">
-            <a:pPr marL="0" indent="0">
-              <a:lnSpc>
-                <a:spcPct val="112000"/>
-              </a:lnSpc>
-              <a:spcBef>
-                <a:spcPts val="0"/>
-              </a:spcBef>
-              <a:spcAft>
-                <a:spcPts val="0"/>
-              </a:spcAft>
-              <a:buNone/>
-              <a:defRPr sz="1125">
-                <a:solidFill>
-                  <a:srgbClr val="FFFFFF"/>
-                </a:solidFill>
-                <a:latin typeface="Arial"/>
-                <a:ea typeface="Arial"/>
-                <a:cs typeface="Arial"/>
-              </a:defRPr>
-            </a:pPr>
-            <a:r>
-              <a:rPr sz="1125">
-                <a:solidFill>
-                  <a:srgbClr val="FFFFFF"/>
-                </a:solidFill>
-                <a:latin typeface="Arial"/>
-                <a:ea typeface="Arial"/>
-                <a:cs typeface="Arial"/>
-              </a:rPr>
-              <a:t>16</a:t>
-            </a:r>
-          </a:p>
-        </p:txBody>
-      </p:sp>
-      <p:sp>
-        <p:nvSpPr>
-          <p:cNvPr id="533" name="Google Shape;533;p58">
-            <a:extLst xmlns:a="http://schemas.openxmlformats.org/drawingml/2006/main">
-              <a:ext uri="{FF2B5EF4-FFF2-40B4-BE49-F238E27FC236}">
-                <a16:creationId xmlns:a16="http://schemas.microsoft.com/office/drawing/2014/main" id="{1B5D55CD-1C17-7CD8-F26A-2DD65B067687}"/>
-              </a:ext>
-            </a:extLst>
-          </p:cNvPr>
-          <p:cNvSpPr>
-            <a:spLocks xmlns:a="http://schemas.openxmlformats.org/drawingml/2006/main" noGrp="1"/>
-          </p:cNvSpPr>
-          <p:nvPr>
-            <p:ph type="title" idx="0"/>
-          </p:nvPr>
-        </p:nvSpPr>
-        <p:spPr>
-          <a:xfrm xmlns:a="http://schemas.openxmlformats.org/drawingml/2006/main">
-            <a:off x="393700" y="344008"/>
-            <a:ext cx="11404600" cy="1047491"/>
-          </a:xfrm>
-        </p:spPr>
-        <p:txBody>
-          <a:bodyPr xmlns:a="http://schemas.openxmlformats.org/drawingml/2006/main" spcFirstLastPara="1" vert="horz" wrap="square" lIns="0" tIns="0" rIns="0" bIns="0" anchor="t">
-            <a:noAutofit/>
-          </a:bodyPr>
-          <a:lstStyle xmlns:a="http://schemas.openxmlformats.org/drawingml/2006/main"/>
-          <a:p xmlns:a="http://schemas.openxmlformats.org/drawingml/2006/main">
-            <a:pPr marL="0" indent="0">
-              <a:lnSpc>
-                <a:spcPct val="112000"/>
-              </a:lnSpc>
-              <a:spcBef>
-                <a:spcPts val="0"/>
-              </a:spcBef>
-              <a:spcAft>
-                <a:spcPts val="0"/>
-              </a:spcAft>
-              <a:buNone/>
-              <a:defRPr sz="3150">
-                <a:solidFill>
-                  <a:srgbClr val="FFFFFF"/>
-                </a:solidFill>
-                <a:latin typeface="Arial"/>
-                <a:ea typeface="Arial"/>
-                <a:cs typeface="Arial"/>
-              </a:defRPr>
-            </a:pPr>
-            <a:r>
-              <a:rPr sz="3150">
-                <a:solidFill>
-                  <a:srgbClr val="FFFFFF"/>
-                </a:solidFill>
-                <a:latin typeface="Arial"/>
-                <a:ea typeface="Arial"/>
-                <a:cs typeface="Arial"/>
-              </a:rPr>
-              <a:t>Quick check answers</a:t>
-            </a:r>
-          </a:p>
-        </p:txBody>
-      </p:sp>
-      <p:sp>
-        <p:nvSpPr>
-          <p:cNvPr id="7" name="Google Shape;534;p58">
-            <a:extLst xmlns:a="http://schemas.openxmlformats.org/drawingml/2006/main">
-              <a:ext uri="{FF2B5EF4-FFF2-40B4-BE49-F238E27FC236}">
-                <a16:creationId xmlns:a16="http://schemas.microsoft.com/office/drawing/2014/main" id="{3A923FEE-B8D2-CD3A-ABBD-21770B40AA24}"/>
-              </a:ext>
-            </a:extLst>
-          </p:cNvPr>
-          <p:cNvSpPr>
-            <a:spLocks xmlns:a="http://schemas.openxmlformats.org/drawingml/2006/main" noGrp="1"/>
-          </p:cNvSpPr>
-          <p:nvPr/>
-        </p:nvSpPr>
-        <p:spPr>
-          <a:xfrm xmlns:a="http://schemas.openxmlformats.org/drawingml/2006/main">
-            <a:off x="393700" y="2031999"/>
-            <a:ext cx="5537200" cy="3534787"/>
-          </a:xfrm>
-          <a:prstGeom xmlns:a="http://schemas.openxmlformats.org/drawingml/2006/main" prst="rect">
-            <a:avLst/>
-          </a:prstGeom>
-        </p:spPr>
-        <p:txBody>
-          <a:bodyPr xmlns:a="http://schemas.openxmlformats.org/drawingml/2006/main" spcFirstLastPara="1" vert="horz" wrap="square" lIns="0" tIns="0" rIns="0" bIns="0" anchor="t">
-            <a:noAutofit/>
-          </a:bodyPr>
-          <a:lstStyle xmlns:a="http://schemas.openxmlformats.org/drawingml/2006/main">
-            <a:lvl1pPr marL="228600" indent="-228600" algn="l" defTabSz="914400">
-              <a:lnSpc>
-                <a:spcPct val="90000"/>
-              </a:lnSpc>
-              <a:spcBef>
-                <a:spcPts val="1000"/>
-              </a:spcBef>
-              <a:buFont typeface="Arial"/>
-              <a:buChar char="•"/>
-              <a:defRPr sz="2400" kern="1200">
-                <a:solidFill>
-                  <a:schemeClr val="tx1"/>
-                </a:solidFill>
-                <a:latin typeface="+mn-lt"/>
-                <a:ea typeface="+mn-lt"/>
-                <a:cs typeface="+mn-lt"/>
-              </a:defRPr>
-            </a:lvl1pPr>
-            <a:lvl2pPr marL="685800" indent="-228600" algn="l" defTabSz="914400">
-              <a:lnSpc>
-                <a:spcPct val="90000"/>
-              </a:lnSpc>
-              <a:spcBef>
-                <a:spcPts val="500"/>
-              </a:spcBef>
-              <a:buFont typeface="Arial"/>
-              <a:buChar char="•"/>
-              <a:defRPr sz="2000" kern="1200">
-                <a:solidFill>
-                  <a:schemeClr val="tx1"/>
-                </a:solidFill>
-                <a:latin typeface="+mn-lt"/>
-                <a:ea typeface="+mn-lt"/>
-                <a:cs typeface="+mn-lt"/>
-              </a:defRPr>
-            </a:lvl2pPr>
-            <a:lvl3pPr marL="1143000" indent="-228600" algn="l" defTabSz="914400">
-              <a:lnSpc>
-                <a:spcPct val="90000"/>
-              </a:lnSpc>
-              <a:spcBef>
-                <a:spcPts val="500"/>
-              </a:spcBef>
-              <a:buFont typeface="Arial"/>
-              <a:buChar char="•"/>
-              <a:defRPr sz="1800" kern="1200">
-                <a:solidFill>
-                  <a:schemeClr val="tx1"/>
-                </a:solidFill>
-                <a:latin typeface="+mn-lt"/>
-                <a:ea typeface="+mn-lt"/>
-                <a:cs typeface="+mn-lt"/>
-              </a:defRPr>
-            </a:lvl3pPr>
-            <a:lvl4pPr marL="1600200" indent="-228600" algn="l" defTabSz="914400">
-              <a:lnSpc>
-                <a:spcPct val="90000"/>
-              </a:lnSpc>
-              <a:spcBef>
-                <a:spcPts val="500"/>
-              </a:spcBef>
-              <a:buFont typeface="Arial"/>
-              <a:buChar char="•"/>
-              <a:defRPr sz="1800" kern="1200">
-                <a:solidFill>
-                  <a:schemeClr val="tx1"/>
-                </a:solidFill>
-                <a:latin typeface="+mn-lt"/>
-                <a:ea typeface="+mn-lt"/>
-                <a:cs typeface="+mn-lt"/>
-              </a:defRPr>
-            </a:lvl4pPr>
-            <a:lvl5pPr marL="2057400" indent="-228600" algn="l" defTabSz="914400">
-              <a:lnSpc>
-                <a:spcPct val="90000"/>
-              </a:lnSpc>
-              <a:spcBef>
-                <a:spcPts val="500"/>
-              </a:spcBef>
-              <a:buFont typeface="Arial"/>
-              <a:buChar char="•"/>
-              <a:defRPr sz="1800" kern="1200">
-                <a:solidFill>
-                  <a:schemeClr val="tx1"/>
-                </a:solidFill>
-                <a:latin typeface="+mn-lt"/>
-                <a:ea typeface="+mn-lt"/>
-                <a:cs typeface="+mn-lt"/>
-              </a:defRPr>
-            </a:lvl5pPr>
-            <a:lvl6pPr marL="2514600" indent="-228600" algn="l" defTabSz="914400">
-              <a:lnSpc>
-                <a:spcPct val="90000"/>
-              </a:lnSpc>
-              <a:spcBef>
-                <a:spcPts val="500"/>
-              </a:spcBef>
-              <a:buFont typeface="Arial"/>
-              <a:buChar char="•"/>
-              <a:defRPr sz="1800" kern="1200">
-                <a:solidFill>
-                  <a:schemeClr val="tx1"/>
-                </a:solidFill>
-                <a:latin typeface="+mn-lt"/>
-                <a:ea typeface="+mn-lt"/>
-                <a:cs typeface="+mn-lt"/>
-              </a:defRPr>
-            </a:lvl6pPr>
-            <a:lvl7pPr marL="2971800" indent="-228600" algn="l" defTabSz="914400">
-              <a:lnSpc>
-                <a:spcPct val="90000"/>
-              </a:lnSpc>
-              <a:spcBef>
-                <a:spcPts val="500"/>
-              </a:spcBef>
-              <a:buFont typeface="Arial"/>
-              <a:buChar char="•"/>
-              <a:defRPr sz="1800" kern="1200">
-                <a:solidFill>
-                  <a:schemeClr val="tx1"/>
-                </a:solidFill>
-                <a:latin typeface="+mn-lt"/>
-                <a:ea typeface="+mn-lt"/>
-                <a:cs typeface="+mn-lt"/>
-              </a:defRPr>
-            </a:lvl7pPr>
-            <a:lvl8pPr marL="3429000" indent="-228600" algn="l" defTabSz="914400">
-              <a:lnSpc>
-                <a:spcPct val="90000"/>
-              </a:lnSpc>
-              <a:spcBef>
-                <a:spcPts val="500"/>
-              </a:spcBef>
-              <a:buFont typeface="Arial"/>
-              <a:buChar char="•"/>
-              <a:defRPr sz="1800" kern="1200">
-                <a:solidFill>
-                  <a:schemeClr val="tx1"/>
-                </a:solidFill>
-                <a:latin typeface="+mn-lt"/>
-                <a:ea typeface="+mn-lt"/>
-                <a:cs typeface="+mn-lt"/>
-              </a:defRPr>
-            </a:lvl8pPr>
-            <a:lvl9pPr marL="3886200" indent="-228600" algn="l" defTabSz="914400">
-              <a:lnSpc>
-                <a:spcPct val="90000"/>
-              </a:lnSpc>
-              <a:spcBef>
-                <a:spcPts val="500"/>
-              </a:spcBef>
-              <a:buFont typeface="Arial"/>
-              <a:buChar char="•"/>
-              <a:defRPr sz="1800" kern="1200">
-                <a:solidFill>
-                  <a:schemeClr val="tx1"/>
-                </a:solidFill>
-                <a:latin typeface="+mn-lt"/>
-                <a:ea typeface="+mn-lt"/>
-                <a:cs typeface="+mn-lt"/>
-              </a:defRPr>
-            </a:lvl9pPr>
-          </a:lstStyle>
-          <a:p xmlns:a="http://schemas.openxmlformats.org/drawingml/2006/main">
-            <a:pPr marL="0" indent="0">
-              <a:lnSpc>
-                <a:spcPct val="112000"/>
-              </a:lnSpc>
-              <a:spcBef>
-                <a:spcPts val="0"/>
-              </a:spcBef>
-              <a:spcAft>
-                <a:spcPts val="0"/>
-              </a:spcAft>
-              <a:buNone/>
-              <a:defRPr sz="1875">
-                <a:solidFill>
-                  <a:srgbClr val="FFFFFF"/>
-                </a:solidFill>
-                <a:latin typeface="Arial"/>
-                <a:ea typeface="Arial"/>
-                <a:cs typeface="Arial"/>
-              </a:defRPr>
-            </a:pPr>
-            <a:r>
-              <a:rPr sz="1875">
-                <a:solidFill>
-                  <a:srgbClr val="FFFFFF"/>
-                </a:solidFill>
-                <a:latin typeface="Arial"/>
-                <a:ea typeface="Arial"/>
-                <a:cs typeface="Arial"/>
-              </a:rPr>
-              <a:t>1. 0xB6</a:t>
-            </a:r>
-          </a:p>
-          <a:p xmlns:a="http://schemas.openxmlformats.org/drawingml/2006/main">
-            <a:pPr marL="0" indent="0">
-              <a:lnSpc>
-                <a:spcPct val="112000"/>
-              </a:lnSpc>
-              <a:spcBef>
-                <a:spcPts val="0"/>
-              </a:spcBef>
-              <a:spcAft>
-                <a:spcPts val="0"/>
-              </a:spcAft>
-              <a:buNone/>
-            </a:pPr>
-            <a:r>
-              <a:t/>
-            </a:r>
-          </a:p>
-          <a:p xmlns:a="http://schemas.openxmlformats.org/drawingml/2006/main">
-            <a:pPr marL="0" indent="0">
-              <a:lnSpc>
-                <a:spcPct val="112000"/>
-              </a:lnSpc>
-              <a:spcBef>
-                <a:spcPts val="0"/>
-              </a:spcBef>
-              <a:spcAft>
-                <a:spcPts val="0"/>
-              </a:spcAft>
-              <a:buNone/>
-              <a:defRPr sz="1875">
-                <a:solidFill>
-                  <a:srgbClr val="FFFFFF"/>
-                </a:solidFill>
-                <a:latin typeface="Arial"/>
-                <a:ea typeface="Arial"/>
-                <a:cs typeface="Arial"/>
-              </a:defRPr>
-            </a:pPr>
-            <a:r>
-              <a:rPr sz="1875">
-                <a:solidFill>
-                  <a:srgbClr val="FFFFFF"/>
-                </a:solidFill>
-                <a:latin typeface="Arial"/>
-                <a:ea typeface="Arial"/>
-                <a:cs typeface="Arial"/>
-              </a:rPr>
-              <a:t>2. 0100 1101₂</a:t>
-            </a:r>
-          </a:p>
-          <a:p xmlns:a="http://schemas.openxmlformats.org/drawingml/2006/main">
-            <a:pPr marL="0" indent="0">
-              <a:lnSpc>
-                <a:spcPct val="112000"/>
-              </a:lnSpc>
-              <a:spcBef>
-                <a:spcPts val="0"/>
-              </a:spcBef>
-              <a:spcAft>
-                <a:spcPts val="0"/>
-              </a:spcAft>
-              <a:buNone/>
-            </a:pPr>
-            <a:r>
-              <a:t/>
-            </a:r>
-          </a:p>
-          <a:p xmlns:a="http://schemas.openxmlformats.org/drawingml/2006/main">
-            <a:pPr marL="0" indent="0">
-              <a:lnSpc>
-                <a:spcPct val="112000"/>
-              </a:lnSpc>
-              <a:spcBef>
-                <a:spcPts val="0"/>
-              </a:spcBef>
-              <a:spcAft>
-                <a:spcPts val="0"/>
-              </a:spcAft>
-              <a:buNone/>
-              <a:defRPr sz="1875">
-                <a:solidFill>
-                  <a:srgbClr val="FFFFFF"/>
-                </a:solidFill>
-                <a:latin typeface="Arial"/>
-                <a:ea typeface="Arial"/>
-                <a:cs typeface="Arial"/>
-              </a:defRPr>
-            </a:pPr>
-            <a:r>
-              <a:rPr sz="1875">
-                <a:solidFill>
-                  <a:srgbClr val="FFFFFF"/>
-                </a:solidFill>
-                <a:latin typeface="Arial"/>
-                <a:ea typeface="Arial"/>
-                <a:cs typeface="Arial"/>
-              </a:rPr>
-              <a:t>3. %rax</a:t>
-            </a:r>
-          </a:p>
-        </p:txBody>
-      </p:sp>
-      <p:sp>
-        <p:nvSpPr>
-          <p:cNvPr id="8" name="Content Placeholder 3">
-            <a:extLst xmlns:a="http://schemas.openxmlformats.org/drawingml/2006/main">
-              <a:ext uri="{FF2B5EF4-FFF2-40B4-BE49-F238E27FC236}">
-                <a16:creationId xmlns:a16="http://schemas.microsoft.com/office/drawing/2014/main" id="{2EE8F343-A95F-2AAA-FE9E-A6C31E298DF7}"/>
-              </a:ext>
-            </a:extLst>
-          </p:cNvPr>
-          <p:cNvSpPr>
-            <a:spLocks xmlns:a="http://schemas.openxmlformats.org/drawingml/2006/main" noGrp="1"/>
-          </p:cNvSpPr>
-          <p:nvPr/>
-        </p:nvSpPr>
-        <p:spPr>
-          <a:xfrm xmlns:a="http://schemas.openxmlformats.org/drawingml/2006/main">
-            <a:off x="6256618" y="2031999"/>
-            <a:ext cx="5537200" cy="3534787"/>
-          </a:xfrm>
-          <a:prstGeom xmlns:a="http://schemas.openxmlformats.org/drawingml/2006/main" prst="rect">
-            <a:avLst/>
-          </a:prstGeom>
-        </p:spPr>
-        <p:txBody>
-          <a:bodyPr xmlns:a="http://schemas.openxmlformats.org/drawingml/2006/main" lIns="0" tIns="0" rIns="0" bIns="0" anchor="t">
-            <a:noAutofit/>
-          </a:bodyPr>
-          <a:lstStyle xmlns:a="http://schemas.openxmlformats.org/drawingml/2006/main">
-            <a:lvl1pPr marL="228600" indent="-228600" algn="l" defTabSz="914400">
-              <a:lnSpc>
-                <a:spcPct val="90000"/>
-              </a:lnSpc>
-              <a:spcBef>
-                <a:spcPts val="1000"/>
-              </a:spcBef>
-              <a:buFont typeface="Arial"/>
-              <a:buChar char="•"/>
-              <a:defRPr sz="2400" kern="1200">
-                <a:solidFill>
-                  <a:schemeClr val="tx1"/>
-                </a:solidFill>
-                <a:latin typeface="+mn-lt"/>
-                <a:ea typeface="+mn-lt"/>
-                <a:cs typeface="+mn-lt"/>
-              </a:defRPr>
-            </a:lvl1pPr>
-            <a:lvl2pPr marL="685800" indent="-228600" algn="l" defTabSz="914400">
-              <a:lnSpc>
-                <a:spcPct val="90000"/>
-              </a:lnSpc>
-              <a:spcBef>
-                <a:spcPts val="500"/>
-              </a:spcBef>
-              <a:buFont typeface="Arial"/>
-              <a:buChar char="•"/>
-              <a:defRPr sz="2000" kern="1200">
-                <a:solidFill>
-                  <a:schemeClr val="tx1"/>
-                </a:solidFill>
-                <a:latin typeface="+mn-lt"/>
-                <a:ea typeface="+mn-lt"/>
-                <a:cs typeface="+mn-lt"/>
-              </a:defRPr>
-            </a:lvl2pPr>
-            <a:lvl3pPr marL="1143000" indent="-228600" algn="l" defTabSz="914400">
-              <a:lnSpc>
-                <a:spcPct val="90000"/>
-              </a:lnSpc>
-              <a:spcBef>
-                <a:spcPts val="500"/>
-              </a:spcBef>
-              <a:buFont typeface="Arial"/>
-              <a:buChar char="•"/>
-              <a:defRPr sz="1800" kern="1200">
-                <a:solidFill>
-                  <a:schemeClr val="tx1"/>
-                </a:solidFill>
-                <a:latin typeface="+mn-lt"/>
-                <a:ea typeface="+mn-lt"/>
-                <a:cs typeface="+mn-lt"/>
-              </a:defRPr>
-            </a:lvl3pPr>
-            <a:lvl4pPr marL="1600200" indent="-228600" algn="l" defTabSz="914400">
-              <a:lnSpc>
-                <a:spcPct val="90000"/>
-              </a:lnSpc>
-              <a:spcBef>
-                <a:spcPts val="500"/>
-              </a:spcBef>
-              <a:buFont typeface="Arial"/>
-              <a:buChar char="•"/>
-              <a:defRPr sz="1800" kern="1200">
-                <a:solidFill>
-                  <a:schemeClr val="tx1"/>
-                </a:solidFill>
-                <a:latin typeface="+mn-lt"/>
-                <a:ea typeface="+mn-lt"/>
-                <a:cs typeface="+mn-lt"/>
-              </a:defRPr>
-            </a:lvl4pPr>
-            <a:lvl5pPr marL="2057400" indent="-228600" algn="l" defTabSz="914400">
-              <a:lnSpc>
-                <a:spcPct val="90000"/>
-              </a:lnSpc>
-              <a:spcBef>
-                <a:spcPts val="500"/>
-              </a:spcBef>
-              <a:buFont typeface="Arial"/>
-              <a:buChar char="•"/>
-              <a:defRPr sz="1800" kern="1200">
-                <a:solidFill>
-                  <a:schemeClr val="tx1"/>
-                </a:solidFill>
-                <a:latin typeface="+mn-lt"/>
-                <a:ea typeface="+mn-lt"/>
-                <a:cs typeface="+mn-lt"/>
-              </a:defRPr>
-            </a:lvl5pPr>
-            <a:lvl6pPr marL="2514600" indent="-228600" algn="l" defTabSz="914400">
-              <a:lnSpc>
-                <a:spcPct val="90000"/>
-              </a:lnSpc>
-              <a:spcBef>
-                <a:spcPts val="500"/>
-              </a:spcBef>
-              <a:buFont typeface="Arial"/>
-              <a:buChar char="•"/>
-              <a:defRPr sz="1800" kern="1200">
-                <a:solidFill>
-                  <a:schemeClr val="tx1"/>
-                </a:solidFill>
-                <a:latin typeface="+mn-lt"/>
-                <a:ea typeface="+mn-lt"/>
-                <a:cs typeface="+mn-lt"/>
-              </a:defRPr>
-            </a:lvl6pPr>
-            <a:lvl7pPr marL="2971800" indent="-228600" algn="l" defTabSz="914400">
-              <a:lnSpc>
-                <a:spcPct val="90000"/>
-              </a:lnSpc>
-              <a:spcBef>
-                <a:spcPts val="500"/>
-              </a:spcBef>
-              <a:buFont typeface="Arial"/>
-              <a:buChar char="•"/>
-              <a:defRPr sz="1800" kern="1200">
-                <a:solidFill>
-                  <a:schemeClr val="tx1"/>
-                </a:solidFill>
-                <a:latin typeface="+mn-lt"/>
-                <a:ea typeface="+mn-lt"/>
-                <a:cs typeface="+mn-lt"/>
-              </a:defRPr>
-            </a:lvl7pPr>
-            <a:lvl8pPr marL="3429000" indent="-228600" algn="l" defTabSz="914400">
-              <a:lnSpc>
-                <a:spcPct val="90000"/>
-              </a:lnSpc>
-              <a:spcBef>
-                <a:spcPts val="500"/>
-              </a:spcBef>
-              <a:buFont typeface="Arial"/>
-              <a:buChar char="•"/>
-              <a:defRPr sz="1800" kern="1200">
-                <a:solidFill>
-                  <a:schemeClr val="tx1"/>
-                </a:solidFill>
-                <a:latin typeface="+mn-lt"/>
-                <a:ea typeface="+mn-lt"/>
-                <a:cs typeface="+mn-lt"/>
-              </a:defRPr>
-            </a:lvl8pPr>
-            <a:lvl9pPr marL="3886200" indent="-228600" algn="l" defTabSz="914400">
-              <a:lnSpc>
-                <a:spcPct val="90000"/>
-              </a:lnSpc>
-              <a:spcBef>
-                <a:spcPts val="500"/>
-              </a:spcBef>
-              <a:buFont typeface="Arial"/>
-              <a:buChar char="•"/>
-              <a:defRPr sz="1800" kern="1200">
-                <a:solidFill>
-                  <a:schemeClr val="tx1"/>
-                </a:solidFill>
-                <a:latin typeface="+mn-lt"/>
-                <a:ea typeface="+mn-lt"/>
-                <a:cs typeface="+mn-lt"/>
-              </a:defRPr>
-            </a:lvl9pPr>
-          </a:lstStyle>
-          <a:p xmlns:a="http://schemas.openxmlformats.org/drawingml/2006/main">
-            <a:pPr marL="0" indent="0">
-              <a:lnSpc>
-                <a:spcPct val="112000"/>
-              </a:lnSpc>
-              <a:spcBef>
-                <a:spcPts val="0"/>
-              </a:spcBef>
-              <a:spcAft>
-                <a:spcPts val="0"/>
-              </a:spcAft>
-              <a:buNone/>
-              <a:defRPr sz="1800">
-                <a:solidFill>
-                  <a:srgbClr val="FFFFFF"/>
-                </a:solidFill>
-                <a:latin typeface="Consolas"/>
-                <a:ea typeface="Consolas"/>
-                <a:cs typeface="Consolas"/>
-              </a:defRPr>
-            </a:pPr>
-            <a:r>
-              <a:rPr sz="1800">
-                <a:solidFill>
-                  <a:srgbClr val="FFFFFF"/>
-                </a:solidFill>
-                <a:latin typeface="Consolas"/>
-                <a:ea typeface="Consolas"/>
-                <a:cs typeface="Consolas"/>
-              </a:rPr>
-              <a:t>4. 0x1000 + 5 × 4 = 0x1014</a:t>
-            </a:r>
-          </a:p>
-          <a:p xmlns:a="http://schemas.openxmlformats.org/drawingml/2006/main">
-            <a:pPr marL="0" indent="0">
-              <a:lnSpc>
-                <a:spcPct val="112000"/>
-              </a:lnSpc>
-              <a:spcBef>
-                <a:spcPts val="0"/>
-              </a:spcBef>
-              <a:spcAft>
-                <a:spcPts val="0"/>
-              </a:spcAft>
-              <a:buNone/>
-            </a:pPr>
-            <a:r>
-              <a:t/>
-            </a:r>
-          </a:p>
-          <a:p xmlns:a="http://schemas.openxmlformats.org/drawingml/2006/main">
-            <a:pPr marL="0" indent="0">
-              <a:lnSpc>
-                <a:spcPct val="112000"/>
-              </a:lnSpc>
-              <a:spcBef>
-                <a:spcPts val="0"/>
-              </a:spcBef>
-              <a:spcAft>
-                <a:spcPts val="0"/>
-              </a:spcAft>
-              <a:buNone/>
-              <a:defRPr sz="1800">
-                <a:solidFill>
-                  <a:srgbClr val="FFFFFF"/>
-                </a:solidFill>
-                <a:latin typeface="Consolas"/>
-                <a:ea typeface="Consolas"/>
-                <a:cs typeface="Consolas"/>
-              </a:defRPr>
-            </a:pPr>
-            <a:r>
-              <a:rPr sz="1800">
-                <a:solidFill>
-                  <a:srgbClr val="FFFFFF"/>
-                </a:solidFill>
-                <a:latin typeface="Consolas"/>
-                <a:ea typeface="Consolas"/>
-                <a:cs typeface="Consolas"/>
-              </a:rPr>
-              <a:t>5. Heap storage from malloc/calloc/realloc</a:t>
-            </a:r>
-          </a:p>
-          <a:p xmlns:a="http://schemas.openxmlformats.org/drawingml/2006/main">
-            <a:pPr marL="0" indent="0">
-              <a:lnSpc>
-                <a:spcPct val="112000"/>
-              </a:lnSpc>
-              <a:spcBef>
-                <a:spcPts val="0"/>
-              </a:spcBef>
-              <a:spcAft>
-                <a:spcPts val="0"/>
-              </a:spcAft>
-              <a:buNone/>
-            </a:pPr>
-            <a:r>
-              <a:t/>
-            </a:r>
-          </a:p>
-          <a:p xmlns:a="http://schemas.openxmlformats.org/drawingml/2006/main">
-            <a:pPr marL="0" indent="0">
-              <a:lnSpc>
-                <a:spcPct val="112000"/>
-              </a:lnSpc>
-              <a:spcBef>
-                <a:spcPts val="0"/>
-              </a:spcBef>
-              <a:spcAft>
-                <a:spcPts val="0"/>
-              </a:spcAft>
-              <a:buNone/>
-              <a:defRPr sz="1800">
-                <a:solidFill>
-                  <a:srgbClr val="FFFFFF"/>
-                </a:solidFill>
-                <a:latin typeface="Consolas"/>
-                <a:ea typeface="Consolas"/>
-                <a:cs typeface="Consolas"/>
-              </a:defRPr>
-            </a:pPr>
-            <a:r>
-              <a:rPr sz="1800">
-                <a:solidFill>
-                  <a:srgbClr val="FFFFFF"/>
-                </a:solidFill>
-                <a:latin typeface="Consolas"/>
-                <a:ea typeface="Consolas"/>
-                <a:cs typeface="Consolas"/>
-              </a:rPr>
-              <a:t>6. (+1) × 2¹ × 1.5 = 3.0</a:t>
-            </a:r>
-          </a:p>
-        </p:txBody>
-      </p:sp>
-      <p:sp>
-        <p:nvSpPr>
-          <p:cNvPr id="534" name="Takeaway">
-            <a:extLst xmlns:a="http://schemas.openxmlformats.org/drawingml/2006/main">
-              <a:ext uri="{FF2B5EF4-FFF2-40B4-BE49-F238E27FC236}">
-                <a16:creationId xmlns:a16="http://schemas.microsoft.com/office/drawing/2014/main" id="{D32F7557-0012-4058-8172-2E9A67DAFCC2}"/>
+                <a16:creationId xmlns:a16="http://schemas.microsoft.com/office/drawing/2014/main" id="{FAB3D919-D1A7-4CCB-BC93-AA8F82599E3B}"/>
               </a:ext>
             </a:extLst>
           </p:cNvPr>
@@ -12163,7 +11107,7 @@
           <p:cNvPr id="534" name="Takeaway">
             <a:extLst xmlns:a="http://schemas.openxmlformats.org/drawingml/2006/main">
               <a:ext uri="{FF2B5EF4-FFF2-40B4-BE49-F238E27FC236}">
-                <a16:creationId xmlns:a16="http://schemas.microsoft.com/office/drawing/2014/main" id="{EB56ED31-ABCA-40DC-9033-E4F94586EAC2}"/>
+                <a16:creationId xmlns:a16="http://schemas.microsoft.com/office/drawing/2014/main" id="{C424D42C-8D84-43C0-8ED0-C1EAD4A11BAC}"/>
               </a:ext>
             </a:extLst>
           </p:cNvPr>
@@ -13139,7 +12083,7 @@
           <p:cNvPr id="534" name="Takeaway">
             <a:extLst xmlns:a="http://schemas.openxmlformats.org/drawingml/2006/main">
               <a:ext uri="{FF2B5EF4-FFF2-40B4-BE49-F238E27FC236}">
-                <a16:creationId xmlns:a16="http://schemas.microsoft.com/office/drawing/2014/main" id="{FB94F7D5-926E-4BA6-94EC-7129880E1180}"/>
+                <a16:creationId xmlns:a16="http://schemas.microsoft.com/office/drawing/2014/main" id="{0C47D024-AD49-427A-881C-257BBAC9EB8C}"/>
               </a:ext>
             </a:extLst>
           </p:cNvPr>
@@ -14065,7 +13009,7 @@
           <p:cNvPr id="534" name="Takeaway">
             <a:extLst xmlns:a="http://schemas.openxmlformats.org/drawingml/2006/main">
               <a:ext uri="{FF2B5EF4-FFF2-40B4-BE49-F238E27FC236}">
-                <a16:creationId xmlns:a16="http://schemas.microsoft.com/office/drawing/2014/main" id="{06557F5A-0919-444D-9D0B-9AA0675624C9}"/>
+                <a16:creationId xmlns:a16="http://schemas.microsoft.com/office/drawing/2014/main" id="{2559B224-7DF5-4ADC-A624-F44E1BE78252}"/>
               </a:ext>
             </a:extLst>
           </p:cNvPr>
@@ -15008,7 +13952,7 @@
           <p:cNvPr id="534" name="Takeaway">
             <a:extLst xmlns:a="http://schemas.openxmlformats.org/drawingml/2006/main">
               <a:ext uri="{FF2B5EF4-FFF2-40B4-BE49-F238E27FC236}">
-                <a16:creationId xmlns:a16="http://schemas.microsoft.com/office/drawing/2014/main" id="{7B20CD0B-1BBC-4991-9CEC-01954C395492}"/>
+                <a16:creationId xmlns:a16="http://schemas.microsoft.com/office/drawing/2014/main" id="{F5B1F170-C508-4478-AD44-886A61E0868A}"/>
               </a:ext>
             </a:extLst>
           </p:cNvPr>
@@ -15984,7 +14928,7 @@
           <p:cNvPr id="534" name="Takeaway">
             <a:extLst xmlns:a="http://schemas.openxmlformats.org/drawingml/2006/main">
               <a:ext uri="{FF2B5EF4-FFF2-40B4-BE49-F238E27FC236}">
-                <a16:creationId xmlns:a16="http://schemas.microsoft.com/office/drawing/2014/main" id="{D7660413-99FB-4547-B9D3-83DB81E7F939}"/>
+                <a16:creationId xmlns:a16="http://schemas.microsoft.com/office/drawing/2014/main" id="{13DD2C91-C8AB-4318-8EF8-84A511B4F938}"/>
               </a:ext>
             </a:extLst>
           </p:cNvPr>
@@ -16959,7 +15903,7 @@
           <p:cNvPr id="534" name="Takeaway">
             <a:extLst xmlns:a="http://schemas.openxmlformats.org/drawingml/2006/main">
               <a:ext uri="{FF2B5EF4-FFF2-40B4-BE49-F238E27FC236}">
-                <a16:creationId xmlns:a16="http://schemas.microsoft.com/office/drawing/2014/main" id="{8564580C-5384-4EC4-A0EA-E5784D391085}"/>
+                <a16:creationId xmlns:a16="http://schemas.microsoft.com/office/drawing/2014/main" id="{4B1E1149-DD98-4B24-9E32-5869C257DC81}"/>
               </a:ext>
             </a:extLst>
           </p:cNvPr>
@@ -17935,7 +16879,7 @@
           <p:cNvPr id="534" name="Takeaway">
             <a:extLst xmlns:a="http://schemas.openxmlformats.org/drawingml/2006/main">
               <a:ext uri="{FF2B5EF4-FFF2-40B4-BE49-F238E27FC236}">
-                <a16:creationId xmlns:a16="http://schemas.microsoft.com/office/drawing/2014/main" id="{A8AA51E5-936D-48E3-9C6D-BD4AFA3F2D7E}"/>
+                <a16:creationId xmlns:a16="http://schemas.microsoft.com/office/drawing/2014/main" id="{76675D4D-3945-4958-ABC7-11C38694961E}"/>
               </a:ext>
             </a:extLst>
           </p:cNvPr>
@@ -18927,7 +17871,7 @@
           <p:cNvPr id="534" name="Takeaway">
             <a:extLst xmlns:a="http://schemas.openxmlformats.org/drawingml/2006/main">
               <a:ext uri="{FF2B5EF4-FFF2-40B4-BE49-F238E27FC236}">
-                <a16:creationId xmlns:a16="http://schemas.microsoft.com/office/drawing/2014/main" id="{383A75D2-07A6-42DA-9962-BFC7E7990081}"/>
+                <a16:creationId xmlns:a16="http://schemas.microsoft.com/office/drawing/2014/main" id="{094735AB-C2F1-4F15-914C-10078B1BEB06}"/>
               </a:ext>
             </a:extLst>
           </p:cNvPr>

</xml_diff>

<commit_message>
Remove variable-length arrays from quiz review
</commit_message>
<xml_diff>
--- a/public/presentations/CS211_Recitation_4.pptx
+++ b/public/presentations/CS211_Recitation_4.pptx
@@ -2,37 +2,36 @@
 <file path=ppt/presentation.xml><?xml version="1.0" encoding="utf-8"?>
 <p:presentation xmlns:p="http://schemas.openxmlformats.org/presentationml/2006/main" embedTrueTypeFonts="1" saveSubsetFonts="0">
   <p:sldMasterIdLst>
-    <p:sldMasterId xmlns:r="http://schemas.openxmlformats.org/officeDocument/2006/relationships" id="2147483648" r:id="R0474acbeb6ef42d6"/>
+    <p:sldMasterId xmlns:r="http://schemas.openxmlformats.org/officeDocument/2006/relationships" id="2147483648" r:id="R8f0bd23c65e84e99"/>
   </p:sldMasterIdLst>
   <p:notesMasterIdLst>
-    <p:notesMasterId xmlns:r="http://schemas.openxmlformats.org/officeDocument/2006/relationships" r:id="R464e4e1faa0440bd"/>
+    <p:notesMasterId xmlns:r="http://schemas.openxmlformats.org/officeDocument/2006/relationships" r:id="Rc81aa6ad41bd4ec9"/>
   </p:notesMasterIdLst>
   <p:sldIdLst>
-    <p:sldId xmlns:r="http://schemas.openxmlformats.org/officeDocument/2006/relationships" id="256" r:id="Rddf4b863eb3346b6"/>
-    <p:sldId xmlns:r="http://schemas.openxmlformats.org/officeDocument/2006/relationships" id="257" r:id="R550a20378d90448f"/>
-    <p:sldId xmlns:r="http://schemas.openxmlformats.org/officeDocument/2006/relationships" id="258" r:id="Rb5496a93ac7944fb"/>
-    <p:sldId xmlns:r="http://schemas.openxmlformats.org/officeDocument/2006/relationships" id="259" r:id="R5e539c9ec14b47b9"/>
-    <p:sldId xmlns:r="http://schemas.openxmlformats.org/officeDocument/2006/relationships" id="260" r:id="R1144e97c64cb486d"/>
-    <p:sldId xmlns:r="http://schemas.openxmlformats.org/officeDocument/2006/relationships" id="261" r:id="R597128970dc645f8"/>
-    <p:sldId xmlns:r="http://schemas.openxmlformats.org/officeDocument/2006/relationships" id="262" r:id="Rbf29355b08e24501"/>
-    <p:sldId xmlns:r="http://schemas.openxmlformats.org/officeDocument/2006/relationships" id="263" r:id="Re777f04b4f51410d"/>
-    <p:sldId xmlns:r="http://schemas.openxmlformats.org/officeDocument/2006/relationships" id="264" r:id="R799a57cd6c77482a"/>
-    <p:sldId xmlns:r="http://schemas.openxmlformats.org/officeDocument/2006/relationships" id="265" r:id="R57d4976b75a8480f"/>
-    <p:sldId xmlns:r="http://schemas.openxmlformats.org/officeDocument/2006/relationships" id="266" r:id="Rf9b1da27d8eb4278"/>
-    <p:sldId xmlns:r="http://schemas.openxmlformats.org/officeDocument/2006/relationships" id="267" r:id="R0f216277bb834475"/>
-    <p:sldId xmlns:r="http://schemas.openxmlformats.org/officeDocument/2006/relationships" id="268" r:id="Rf894c207c90b4fa9"/>
-    <p:sldId xmlns:r="http://schemas.openxmlformats.org/officeDocument/2006/relationships" id="269" r:id="Ra8326fe027004f56"/>
-    <p:sldId xmlns:r="http://schemas.openxmlformats.org/officeDocument/2006/relationships" id="270" r:id="Raa48b36903834b63"/>
+    <p:sldId xmlns:r="http://schemas.openxmlformats.org/officeDocument/2006/relationships" id="256" r:id="R6d6d43fb8f7a42ec"/>
+    <p:sldId xmlns:r="http://schemas.openxmlformats.org/officeDocument/2006/relationships" id="257" r:id="Rc396024c66e342da"/>
+    <p:sldId xmlns:r="http://schemas.openxmlformats.org/officeDocument/2006/relationships" id="258" r:id="R7d14d7898f104242"/>
+    <p:sldId xmlns:r="http://schemas.openxmlformats.org/officeDocument/2006/relationships" id="259" r:id="R22009fad478e4447"/>
+    <p:sldId xmlns:r="http://schemas.openxmlformats.org/officeDocument/2006/relationships" id="260" r:id="Ra4d6b97c6334422e"/>
+    <p:sldId xmlns:r="http://schemas.openxmlformats.org/officeDocument/2006/relationships" id="261" r:id="Rb4d72a2b207448a5"/>
+    <p:sldId xmlns:r="http://schemas.openxmlformats.org/officeDocument/2006/relationships" id="262" r:id="R5a9c0269a7da4b13"/>
+    <p:sldId xmlns:r="http://schemas.openxmlformats.org/officeDocument/2006/relationships" id="263" r:id="R221e894dd4254af1"/>
+    <p:sldId xmlns:r="http://schemas.openxmlformats.org/officeDocument/2006/relationships" id="264" r:id="R38f487c8db414a35"/>
+    <p:sldId xmlns:r="http://schemas.openxmlformats.org/officeDocument/2006/relationships" id="265" r:id="R1c2783e6051445fe"/>
+    <p:sldId xmlns:r="http://schemas.openxmlformats.org/officeDocument/2006/relationships" id="266" r:id="R621214695dfa45f7"/>
+    <p:sldId xmlns:r="http://schemas.openxmlformats.org/officeDocument/2006/relationships" id="267" r:id="R0d9692e036454694"/>
+    <p:sldId xmlns:r="http://schemas.openxmlformats.org/officeDocument/2006/relationships" id="268" r:id="Re8239a0acedf4682"/>
+    <p:sldId xmlns:r="http://schemas.openxmlformats.org/officeDocument/2006/relationships" id="269" r:id="R1e7a33576cb9433e"/>
   </p:sldIdLst>
   <p:sldSz cx="12192000" cy="6858000"/>
   <p:notesSz cx="6858000" cy="9144000"/>
   <p:embeddedFontLst>
     <p:embeddedFont>
       <p:font typeface="OpenAI Sans"/>
-      <p:regular xmlns:r="http://schemas.openxmlformats.org/officeDocument/2006/relationships" r:id="R30bc6584e4b04aff"/>
-      <p:bold xmlns:r="http://schemas.openxmlformats.org/officeDocument/2006/relationships" r:id="Rac46b8791106475e"/>
-      <p:italic xmlns:r="http://schemas.openxmlformats.org/officeDocument/2006/relationships" r:id="R9f85f219ceda4749"/>
-      <p:boldItalic xmlns:r="http://schemas.openxmlformats.org/officeDocument/2006/relationships" r:id="Ra7c595d74ce94d65"/>
+      <p:regular xmlns:r="http://schemas.openxmlformats.org/officeDocument/2006/relationships" r:id="R89bf8907ad4b4646"/>
+      <p:bold xmlns:r="http://schemas.openxmlformats.org/officeDocument/2006/relationships" r:id="R7ae8332b01c349ee"/>
+      <p:italic xmlns:r="http://schemas.openxmlformats.org/officeDocument/2006/relationships" r:id="R2f975c6bf8124dba"/>
+      <p:boldItalic xmlns:r="http://schemas.openxmlformats.org/officeDocument/2006/relationships" r:id="Rf0a304ebf3d24ee3"/>
     </p:embeddedFont>
   </p:embeddedFontLst>
 </p:presentation>
@@ -571,7 +570,7 @@
               <a:buNone/>
             </a:pPr>
             <a:r>
-              <a:t>Contrast int a[10], whose size is known at compile time, with int a[n], whose size is known only when execution reaches the declaration. In the address formula, rows does not appear because the address of a specific element depends on how many complete rows come before it, and each row contains cols elements. rows still matters as the bound: 0 &lt;= i &lt; rows. A VLA has automatic lifetime and is commonly allocated in the current stack frame.</a:t>
+              <a:t>call places the return address on the stack. push decrements rsp before storing; pop loads then increments it. Subtracting 24 increases the distance between rbp and rsp by 24 bytes. To release the local storage, restore rsp from rbp, then restore the caller's saved rbp. This example has no nested call; calls may require additional stack alignment. Optimized code may omit rbp as a frame pointer.</a:t>
             </a:r>
             <a:endParaRPr/>
           </a:p>
@@ -651,7 +650,7 @@
               <a:buNone/>
             </a:pPr>
             <a:r>
-              <a:t>call places the return address on the stack. push decrements rsp before storing; pop loads then increments it. Subtracting 24 increases the distance between rbp and rsp by 24 bytes. To release the local storage, restore rsp from rbp, then restore the caller's saved rbp. This example has no nested call; calls may require additional stack alignment. Optimized code may omit rbp as a frame pointer.</a:t>
+              <a:t>Use the closet analogy carefully: the stack is a nested pile of function frames; the heap is a pool where the program requests blocks and must return them. malloc returns uninitialized storage or NULL. free only the allocation’s original address, exactly once.</a:t>
             </a:r>
             <a:endParaRPr/>
           </a:p>
@@ -731,7 +730,7 @@
               <a:buNone/>
             </a:pPr>
             <a:r>
-              <a:t>Use the closet analogy carefully: the stack is a nested pile of function frames; the heap is a pool where the program requests blocks and must return them. malloc returns uninitialized storage or NULL. free only the allocation’s original address, exactly once.</a:t>
+              <a:t>Give students two minutes before moving to the answers. For question 4, assume sizeof(int) is 4 bytes. For question 6, the format is 1 sign bit, 3 exponent bits, 4 fraction bits and the value is normalized.</a:t>
             </a:r>
             <a:endParaRPr/>
           </a:p>
@@ -763,86 +762,6 @@
 </file>
 
 <file path=ppt/notesSlides/notesSlide14.xml><?xml version="1.0" encoding="utf-8"?>
-<p:notes xmlns:p="http://schemas.openxmlformats.org/presentationml/2006/main">
-  <p:cSld>
-    <p:spTree>
-      <p:nvGrpSpPr>
-        <p:cNvPr id="1" name=""/>
-        <p:cNvGrpSpPr/>
-        <p:nvPr/>
-      </p:nvGrpSpPr>
-      <p:grpSpPr>
-        <a:xfrm xmlns:a="http://schemas.openxmlformats.org/drawingml/2006/main"/>
-      </p:grpSpPr>
-      <p:sp>
-        <p:nvSpPr>
-          <p:cNvPr id="2" name="Slide Image Placeholder 1"/>
-          <p:cNvSpPr>
-            <a:spLocks xmlns:a="http://schemas.openxmlformats.org/drawingml/2006/main" noGrp="1"/>
-          </p:cNvSpPr>
-          <p:nvPr>
-            <p:ph type="sldImg" idx="0"/>
-          </p:nvPr>
-        </p:nvSpPr>
-        <p:spPr/>
-      </p:sp>
-      <p:sp>
-        <p:nvSpPr>
-          <p:cNvPr id="3" name="Notes Placeholder 2"/>
-          <p:cNvSpPr>
-            <a:spLocks xmlns:a="http://schemas.openxmlformats.org/drawingml/2006/main" noGrp="1"/>
-          </p:cNvSpPr>
-          <p:nvPr>
-            <p:ph type="body" idx="1"/>
-          </p:nvPr>
-        </p:nvSpPr>
-        <p:spPr/>
-        <p:txBody>
-          <a:bodyPr xmlns:a="http://schemas.openxmlformats.org/drawingml/2006/main"/>
-          <a:lstStyle xmlns:a="http://schemas.openxmlformats.org/drawingml/2006/main"/>
-          <a:p xmlns:a="http://schemas.openxmlformats.org/drawingml/2006/main">
-            <a:pPr marL="0" lvl="0" indent="0" algn="l">
-              <a:spcBef>
-                <a:spcPts val="0"/>
-              </a:spcBef>
-              <a:spcAft>
-                <a:spcPts val="0"/>
-              </a:spcAft>
-              <a:buNone/>
-            </a:pPr>
-            <a:r>
-              <a:t>Give students two minutes before moving to the answers. For question 4, assume sizeof(int) is 4 bytes. For question 6, the format is 1 sign bit, 3 exponent bits, 4 fraction bits and the value is normalized.</a:t>
-            </a:r>
-            <a:endParaRPr/>
-          </a:p>
-        </p:txBody>
-      </p:sp>
-      <p:sp>
-        <p:nvSpPr>
-          <p:cNvPr id="4" name="Slide Number Placeholder 3"/>
-          <p:cNvSpPr>
-            <a:spLocks xmlns:a="http://schemas.openxmlformats.org/drawingml/2006/main" noGrp="1"/>
-          </p:cNvSpPr>
-          <p:nvPr>
-            <p:ph type="sldNum" idx="5"/>
-          </p:nvPr>
-        </p:nvSpPr>
-        <p:spPr/>
-        <p:txBody>
-          <a:bodyPr xmlns:a="http://schemas.openxmlformats.org/drawingml/2006/main"/>
-          <a:lstStyle xmlns:a="http://schemas.openxmlformats.org/drawingml/2006/main"/>
-          <a:p xmlns:a="http://schemas.openxmlformats.org/drawingml/2006/main"/>
-        </p:txBody>
-      </p:sp>
-    </p:spTree>
-  </p:cSld>
-  <p:clrMapOvr>
-    <a:masterClrMapping xmlns:a="http://schemas.openxmlformats.org/drawingml/2006/main"/>
-  </p:clrMapOvr>
-</p:notes>
-</file>
-
-<file path=ppt/notesSlides/notesSlide15.xml><?xml version="1.0" encoding="utf-8"?>
 <p:notes xmlns:p="http://schemas.openxmlformats.org/presentationml/2006/main">
   <p:cSld>
     <p:spTree>
@@ -3415,14 +3334,14 @@
   </p:cSld>
   <p:clrMap bg1="dk1" tx1="lt1" bg2="dk2" tx2="lt2" accent1="accent1" accent2="accent2" accent3="accent3" accent4="accent4" accent5="accent5" accent6="accent6" hlink="hlink" folHlink="folHlink"/>
   <p:sldLayoutIdLst>
-    <p:sldLayoutId xmlns:r="http://schemas.openxmlformats.org/officeDocument/2006/relationships" id="2147483649" r:id="R569268c9d9134464"/>
-    <p:sldLayoutId xmlns:r="http://schemas.openxmlformats.org/officeDocument/2006/relationships" id="2147483650" r:id="R0d7abc0323d94e3a"/>
-    <p:sldLayoutId xmlns:r="http://schemas.openxmlformats.org/officeDocument/2006/relationships" id="2147483651" r:id="R013b4f460ae84d95"/>
-    <p:sldLayoutId xmlns:r="http://schemas.openxmlformats.org/officeDocument/2006/relationships" id="2147483652" r:id="R3c190ca7c6a64160"/>
-    <p:sldLayoutId xmlns:r="http://schemas.openxmlformats.org/officeDocument/2006/relationships" id="2147483653" r:id="R61635ed3a7a84df3"/>
-    <p:sldLayoutId xmlns:r="http://schemas.openxmlformats.org/officeDocument/2006/relationships" id="2147483654" r:id="Re7965f5eb3234514"/>
-    <p:sldLayoutId xmlns:r="http://schemas.openxmlformats.org/officeDocument/2006/relationships" id="2147483655" r:id="R449242db58824b1d"/>
-    <p:sldLayoutId xmlns:r="http://schemas.openxmlformats.org/officeDocument/2006/relationships" id="2147483656" r:id="R8fc187ba73e340ca"/>
+    <p:sldLayoutId xmlns:r="http://schemas.openxmlformats.org/officeDocument/2006/relationships" id="2147483649" r:id="R7e98a7fb02bb43b5"/>
+    <p:sldLayoutId xmlns:r="http://schemas.openxmlformats.org/officeDocument/2006/relationships" id="2147483650" r:id="R8cfe0bac8d4749d4"/>
+    <p:sldLayoutId xmlns:r="http://schemas.openxmlformats.org/officeDocument/2006/relationships" id="2147483651" r:id="R2311546c7e6d4a1c"/>
+    <p:sldLayoutId xmlns:r="http://schemas.openxmlformats.org/officeDocument/2006/relationships" id="2147483652" r:id="R46de6821b03b49bd"/>
+    <p:sldLayoutId xmlns:r="http://schemas.openxmlformats.org/officeDocument/2006/relationships" id="2147483653" r:id="Rc95ae3d90c634c4c"/>
+    <p:sldLayoutId xmlns:r="http://schemas.openxmlformats.org/officeDocument/2006/relationships" id="2147483654" r:id="R5fe81431b94741ca"/>
+    <p:sldLayoutId xmlns:r="http://schemas.openxmlformats.org/officeDocument/2006/relationships" id="2147483655" r:id="R5daf3506bb534765"/>
+    <p:sldLayoutId xmlns:r="http://schemas.openxmlformats.org/officeDocument/2006/relationships" id="2147483656" r:id="Ra9ad12d660ea448a"/>
   </p:sldLayoutIdLst>
   <p:hf hdr="0" dt="0"/>
   <p:txStyles>
@@ -4455,7 +4374,7 @@
           <p:nvPr/>
         </p:nvPicPr>
         <p:blipFill>
-          <a:blip xmlns:r="http://schemas.openxmlformats.org/officeDocument/2006/relationships" xmlns:a="http://schemas.openxmlformats.org/drawingml/2006/main" r:embed="Rb5761fc1851a4108"/>
+          <a:blip xmlns:r="http://schemas.openxmlformats.org/officeDocument/2006/relationships" xmlns:a="http://schemas.openxmlformats.org/drawingml/2006/main" r:embed="R2992c69a416d491e"/>
           <a:srcRect xmlns:a="http://schemas.openxmlformats.org/drawingml/2006/main" l="8269" t="0" r="8269" b="0"/>
           <a:stretch xmlns:a="http://schemas.openxmlformats.org/drawingml/2006/main"/>
         </p:blipFill>
@@ -5333,7 +5252,7 @@
           <p:cNvPr id="534" name="Takeaway">
             <a:extLst xmlns:a="http://schemas.openxmlformats.org/drawingml/2006/main">
               <a:ext uri="{FF2B5EF4-FFF2-40B4-BE49-F238E27FC236}">
-                <a16:creationId xmlns:a16="http://schemas.microsoft.com/office/drawing/2014/main" id="{D970FE01-0AE5-498C-ADD9-3AD39009B3AB}"/>
+                <a16:creationId xmlns:a16="http://schemas.microsoft.com/office/drawing/2014/main" id="{9FDE8D85-B573-42D2-9D48-C968388CCED8}"/>
               </a:ext>
             </a:extLst>
           </p:cNvPr>
@@ -5598,7 +5517,7 @@
                 <a:ea typeface="Arial"/>
                 <a:cs typeface="Arial"/>
               </a:rPr>
-              <a:t>Variable-length arrays</a:t>
+              <a:t>A stack frame</a:t>
             </a:r>
           </a:p>
         </p:txBody>
@@ -5824,7 +5743,7 @@
                 <a:ea typeface="Arial"/>
                 <a:cs typeface="Arial"/>
               </a:rPr>
-              <a:t>A VLA’s size is known only at runtime. The compiler must compute how many bytes the current function needs.</a:t>
+              <a:t>Each function call gets a frame for its local work. On x86-64, the stack grows toward lower addresses.</a:t>
             </a:r>
           </a:p>
           <a:p xmlns:a="http://schemas.openxmlformats.org/drawingml/2006/main">
@@ -5874,7 +5793,7 @@
                 <a:ea typeface="Arial"/>
                 <a:cs typeface="Arial"/>
               </a:rPr>
-              <a:t>For a row-major 2D array, the column count determines the row stride.</a:t>
+              <a:t>%rsp marks the top of the stack. %rbp may provide a stable frame reference.</a:t>
             </a:r>
           </a:p>
         </p:txBody>
@@ -6100,7 +6019,7 @@
                 <a:ea typeface="Consolas"/>
                 <a:cs typeface="Consolas"/>
               </a:rPr>
-              <a:t>void f(size_t rows, size_t cols,</a:t>
+              <a:t>pushq %rbp</a:t>
             </a:r>
           </a:p>
           <a:p xmlns:a="http://schemas.openxmlformats.org/drawingml/2006/main">
@@ -6133,24 +6052,7 @@
                 <a:ea typeface="Consolas"/>
                 <a:cs typeface="Consolas"/>
               </a:rPr>
-              <a:t>       int a[rows][cols]);</a:t>
-            </a:r>
-          </a:p>
-          <a:p xmlns:a="http://schemas.openxmlformats.org/drawingml/2006/main">
-            <a:pPr marL="0" indent="0">
-              <a:lnSpc>
-                <a:spcPct val="112000"/>
-              </a:lnSpc>
-              <a:spcBef>
-                <a:spcPts val="0"/>
-              </a:spcBef>
-              <a:spcAft>
-                <a:spcPts val="0"/>
-              </a:spcAft>
-              <a:buNone/>
-            </a:pPr>
-            <a:r>
-              <a:t/>
+              <a:t>movq  %rsp, %rbp</a:t>
             </a:r>
           </a:p>
           <a:p xmlns:a="http://schemas.openxmlformats.org/drawingml/2006/main">
@@ -6183,7 +6085,7 @@
                 <a:ea typeface="Consolas"/>
                 <a:cs typeface="Consolas"/>
               </a:rPr>
-              <a:t>address(a[i][j])</a:t>
+              <a:t>subq  $24, %rsp   # reserve space</a:t>
             </a:r>
           </a:p>
           <a:p xmlns:a="http://schemas.openxmlformats.org/drawingml/2006/main">
@@ -6216,7 +6118,106 @@
                 <a:ea typeface="Consolas"/>
                 <a:cs typeface="Consolas"/>
               </a:rPr>
-              <a:t>= base + (i × cols + j) × sizeof(int)</a:t>
+              <a:t>   ...</a:t>
+            </a:r>
+          </a:p>
+          <a:p xmlns:a="http://schemas.openxmlformats.org/drawingml/2006/main">
+            <a:pPr marL="0" indent="0">
+              <a:lnSpc>
+                <a:spcPct val="112000"/>
+              </a:lnSpc>
+              <a:spcBef>
+                <a:spcPts val="0"/>
+              </a:spcBef>
+              <a:spcAft>
+                <a:spcPts val="0"/>
+              </a:spcAft>
+              <a:buNone/>
+              <a:defRPr sz="1800">
+                <a:solidFill>
+                  <a:srgbClr val="FFFFFF"/>
+                </a:solidFill>
+                <a:latin typeface="Consolas"/>
+                <a:ea typeface="Consolas"/>
+                <a:cs typeface="Consolas"/>
+              </a:defRPr>
+            </a:pPr>
+            <a:r>
+              <a:rPr sz="1800">
+                <a:solidFill>
+                  <a:srgbClr val="FFFFFF"/>
+                </a:solidFill>
+                <a:latin typeface="Consolas"/>
+                <a:ea typeface="Consolas"/>
+                <a:cs typeface="Consolas"/>
+              </a:rPr>
+              <a:t>movq  %rbp, %rsp  # discard locals</a:t>
+            </a:r>
+          </a:p>
+          <a:p xmlns:a="http://schemas.openxmlformats.org/drawingml/2006/main">
+            <a:pPr marL="0" indent="0">
+              <a:lnSpc>
+                <a:spcPct val="112000"/>
+              </a:lnSpc>
+              <a:spcBef>
+                <a:spcPts val="0"/>
+              </a:spcBef>
+              <a:spcAft>
+                <a:spcPts val="0"/>
+              </a:spcAft>
+              <a:buNone/>
+              <a:defRPr sz="1800">
+                <a:solidFill>
+                  <a:srgbClr val="FFFFFF"/>
+                </a:solidFill>
+                <a:latin typeface="Consolas"/>
+                <a:ea typeface="Consolas"/>
+                <a:cs typeface="Consolas"/>
+              </a:defRPr>
+            </a:pPr>
+            <a:r>
+              <a:rPr sz="1800">
+                <a:solidFill>
+                  <a:srgbClr val="FFFFFF"/>
+                </a:solidFill>
+                <a:latin typeface="Consolas"/>
+                <a:ea typeface="Consolas"/>
+                <a:cs typeface="Consolas"/>
+              </a:rPr>
+              <a:t>popq  %rbp        # restore caller frame</a:t>
+            </a:r>
+          </a:p>
+          <a:p xmlns:a="http://schemas.openxmlformats.org/drawingml/2006/main">
+            <a:pPr marL="0" indent="0">
+              <a:lnSpc>
+                <a:spcPct val="112000"/>
+              </a:lnSpc>
+              <a:spcBef>
+                <a:spcPts val="0"/>
+              </a:spcBef>
+              <a:spcAft>
+                <a:spcPts val="0"/>
+              </a:spcAft>
+              <a:buNone/>
+              <a:defRPr sz="1800">
+                <a:solidFill>
+                  <a:srgbClr val="FFFFFF"/>
+                </a:solidFill>
+                <a:latin typeface="Consolas"/>
+                <a:ea typeface="Consolas"/>
+                <a:cs typeface="Consolas"/>
+              </a:defRPr>
+            </a:pPr>
+            <a:r>
+              <a:rPr sz="1800">
+                <a:solidFill>
+                  <a:srgbClr val="FFFFFF"/>
+                </a:solidFill>
+                <a:latin typeface="Consolas"/>
+                <a:ea typeface="Consolas"/>
+                <a:cs typeface="Consolas"/>
+              </a:rPr>
+              <a:t>ret</a:t>
             </a:r>
           </a:p>
         </p:txBody>
@@ -6226,7 +6227,7 @@
           <p:cNvPr id="534" name="Takeaway">
             <a:extLst xmlns:a="http://schemas.openxmlformats.org/drawingml/2006/main">
               <a:ext uri="{FF2B5EF4-FFF2-40B4-BE49-F238E27FC236}">
-                <a16:creationId xmlns:a16="http://schemas.microsoft.com/office/drawing/2014/main" id="{9DEC82DC-1C64-4C3C-AAA9-B564EF50E386}"/>
+                <a16:creationId xmlns:a16="http://schemas.microsoft.com/office/drawing/2014/main" id="{2ADFC182-7368-47B3-B96D-48D407B274DB}"/>
               </a:ext>
             </a:extLst>
           </p:cNvPr>
@@ -6283,7 +6284,7 @@
                 <a:ea typeface="Arial"/>
                 <a:cs typeface="Arial"/>
               </a:rPr>
-              <a:t>rows limits valid values of i; cols determines the row stride used in the address.</a:t>
+              <a:t>leave performs movq %rbp, %rsp followed by popq %rbp. Check which register is the destination.</a:t>
             </a:r>
           </a:p>
         </p:txBody>
@@ -6491,7 +6492,7 @@
                 <a:ea typeface="Arial"/>
                 <a:cs typeface="Arial"/>
               </a:rPr>
-              <a:t>A stack frame</a:t>
+              <a:t>Stack or heap?</a:t>
             </a:r>
           </a:p>
         </p:txBody>
@@ -6717,7 +6718,7 @@
                 <a:ea typeface="Arial"/>
                 <a:cs typeface="Arial"/>
               </a:rPr>
-              <a:t>Each function call gets a frame for its local work. On x86-64, the stack grows toward lower addresses.</a:t>
+              <a:t>Stack: automatic lifetime, tied to a function call.</a:t>
             </a:r>
           </a:p>
           <a:p xmlns:a="http://schemas.openxmlformats.org/drawingml/2006/main">
@@ -6767,7 +6768,57 @@
                 <a:ea typeface="Arial"/>
                 <a:cs typeface="Arial"/>
               </a:rPr>
-              <a:t>%rsp marks the top of the stack. %rbp may provide a stable frame reference.</a:t>
+              <a:t>Heap: requested at runtime and remains allocated until free.</a:t>
+            </a:r>
+          </a:p>
+          <a:p xmlns:a="http://schemas.openxmlformats.org/drawingml/2006/main">
+            <a:pPr marL="0" indent="0">
+              <a:lnSpc>
+                <a:spcPct val="112000"/>
+              </a:lnSpc>
+              <a:spcBef>
+                <a:spcPts val="0"/>
+              </a:spcBef>
+              <a:spcAft>
+                <a:spcPts val="0"/>
+              </a:spcAft>
+              <a:buNone/>
+            </a:pPr>
+            <a:r>
+              <a:t/>
+            </a:r>
+          </a:p>
+          <a:p xmlns:a="http://schemas.openxmlformats.org/drawingml/2006/main">
+            <a:pPr marL="0" indent="0">
+              <a:lnSpc>
+                <a:spcPct val="112000"/>
+              </a:lnSpc>
+              <a:spcBef>
+                <a:spcPts val="0"/>
+              </a:spcBef>
+              <a:spcAft>
+                <a:spcPts val="0"/>
+              </a:spcAft>
+              <a:buNone/>
+              <a:defRPr sz="1875">
+                <a:solidFill>
+                  <a:srgbClr val="FFFFFF"/>
+                </a:solidFill>
+                <a:latin typeface="Arial"/>
+                <a:ea typeface="Arial"/>
+                <a:cs typeface="Arial"/>
+              </a:defRPr>
+            </a:pPr>
+            <a:r>
+              <a:rPr sz="1875">
+                <a:solidFill>
+                  <a:srgbClr val="FFFFFF"/>
+                </a:solidFill>
+                <a:latin typeface="Arial"/>
+                <a:ea typeface="Arial"/>
+                <a:cs typeface="Arial"/>
+              </a:rPr>
+              <a:t>A pointer may live on the stack while the memory it points to lives on the heap.</a:t>
             </a:r>
           </a:p>
         </p:txBody>
@@ -6993,7 +7044,24 @@
                 <a:ea typeface="Consolas"/>
                 <a:cs typeface="Consolas"/>
               </a:rPr>
-              <a:t>pushq %rbp</a:t>
+              <a:t>int local[10];          // stack</a:t>
+            </a:r>
+          </a:p>
+          <a:p xmlns:a="http://schemas.openxmlformats.org/drawingml/2006/main">
+            <a:pPr marL="0" indent="0">
+              <a:lnSpc>
+                <a:spcPct val="112000"/>
+              </a:lnSpc>
+              <a:spcBef>
+                <a:spcPts val="0"/>
+              </a:spcBef>
+              <a:spcAft>
+                <a:spcPts val="0"/>
+              </a:spcAft>
+              <a:buNone/>
+            </a:pPr>
+            <a:r>
+              <a:t/>
             </a:r>
           </a:p>
           <a:p xmlns:a="http://schemas.openxmlformats.org/drawingml/2006/main">
@@ -7026,7 +7094,7 @@
                 <a:ea typeface="Consolas"/>
                 <a:cs typeface="Consolas"/>
               </a:rPr>
-              <a:t>movq  %rsp, %rbp</a:t>
+              <a:t>int *data = malloc(n * sizeof *data);</a:t>
             </a:r>
           </a:p>
           <a:p xmlns:a="http://schemas.openxmlformats.org/drawingml/2006/main">
@@ -7059,7 +7127,24 @@
                 <a:ea typeface="Consolas"/>
                 <a:cs typeface="Consolas"/>
               </a:rPr>
-              <a:t>subq  $24, %rsp   # reserve space</a:t>
+              <a:t>if (data == NULL) { /* handle failure */ }</a:t>
+            </a:r>
+          </a:p>
+          <a:p xmlns:a="http://schemas.openxmlformats.org/drawingml/2006/main">
+            <a:pPr marL="0" indent="0">
+              <a:lnSpc>
+                <a:spcPct val="112000"/>
+              </a:lnSpc>
+              <a:spcBef>
+                <a:spcPts val="0"/>
+              </a:spcBef>
+              <a:spcAft>
+                <a:spcPts val="0"/>
+              </a:spcAft>
+              <a:buNone/>
+            </a:pPr>
+            <a:r>
+              <a:t/>
             </a:r>
           </a:p>
           <a:p xmlns:a="http://schemas.openxmlformats.org/drawingml/2006/main">
@@ -7092,7 +7177,7 @@
                 <a:ea typeface="Consolas"/>
                 <a:cs typeface="Consolas"/>
               </a:rPr>
-              <a:t>   ...</a:t>
+              <a:t>free(data);</a:t>
             </a:r>
           </a:p>
           <a:p xmlns:a="http://schemas.openxmlformats.org/drawingml/2006/main">
@@ -7125,73 +7210,7 @@
                 <a:ea typeface="Consolas"/>
                 <a:cs typeface="Consolas"/>
               </a:rPr>
-              <a:t>movq  %rbp, %rsp  # discard locals</a:t>
-            </a:r>
-          </a:p>
-          <a:p xmlns:a="http://schemas.openxmlformats.org/drawingml/2006/main">
-            <a:pPr marL="0" indent="0">
-              <a:lnSpc>
-                <a:spcPct val="112000"/>
-              </a:lnSpc>
-              <a:spcBef>
-                <a:spcPts val="0"/>
-              </a:spcBef>
-              <a:spcAft>
-                <a:spcPts val="0"/>
-              </a:spcAft>
-              <a:buNone/>
-              <a:defRPr sz="1800">
-                <a:solidFill>
-                  <a:srgbClr val="FFFFFF"/>
-                </a:solidFill>
-                <a:latin typeface="Consolas"/>
-                <a:ea typeface="Consolas"/>
-                <a:cs typeface="Consolas"/>
-              </a:defRPr>
-            </a:pPr>
-            <a:r>
-              <a:rPr sz="1800">
-                <a:solidFill>
-                  <a:srgbClr val="FFFFFF"/>
-                </a:solidFill>
-                <a:latin typeface="Consolas"/>
-                <a:ea typeface="Consolas"/>
-                <a:cs typeface="Consolas"/>
-              </a:rPr>
-              <a:t>popq  %rbp        # restore caller frame</a:t>
-            </a:r>
-          </a:p>
-          <a:p xmlns:a="http://schemas.openxmlformats.org/drawingml/2006/main">
-            <a:pPr marL="0" indent="0">
-              <a:lnSpc>
-                <a:spcPct val="112000"/>
-              </a:lnSpc>
-              <a:spcBef>
-                <a:spcPts val="0"/>
-              </a:spcBef>
-              <a:spcAft>
-                <a:spcPts val="0"/>
-              </a:spcAft>
-              <a:buNone/>
-              <a:defRPr sz="1800">
-                <a:solidFill>
-                  <a:srgbClr val="FFFFFF"/>
-                </a:solidFill>
-                <a:latin typeface="Consolas"/>
-                <a:ea typeface="Consolas"/>
-                <a:cs typeface="Consolas"/>
-              </a:defRPr>
-            </a:pPr>
-            <a:r>
-              <a:rPr sz="1800">
-                <a:solidFill>
-                  <a:srgbClr val="FFFFFF"/>
-                </a:solidFill>
-                <a:latin typeface="Consolas"/>
-                <a:ea typeface="Consolas"/>
-                <a:cs typeface="Consolas"/>
-              </a:rPr>
-              <a:t>ret</a:t>
+              <a:t>data = NULL;</a:t>
             </a:r>
           </a:p>
         </p:txBody>
@@ -7201,7 +7220,7 @@
           <p:cNvPr id="534" name="Takeaway">
             <a:extLst xmlns:a="http://schemas.openxmlformats.org/drawingml/2006/main">
               <a:ext uri="{FF2B5EF4-FFF2-40B4-BE49-F238E27FC236}">
-                <a16:creationId xmlns:a16="http://schemas.microsoft.com/office/drawing/2014/main" id="{5879D53E-C48B-43B7-A473-702F5340E520}"/>
+                <a16:creationId xmlns:a16="http://schemas.microsoft.com/office/drawing/2014/main" id="{C9F268C3-6009-40FB-8ABB-793DF20B6F06}"/>
               </a:ext>
             </a:extLst>
           </p:cNvPr>
@@ -7258,7 +7277,7 @@
                 <a:ea typeface="Arial"/>
                 <a:cs typeface="Arial"/>
               </a:rPr>
-              <a:t>leave performs movq %rbp, %rsp followed by popq %rbp. Check which register is the destination.</a:t>
+              <a:t>Losing the last pointer before free causes a leak; using memory after free is invalid.</a:t>
             </a:r>
           </a:p>
         </p:txBody>
@@ -7466,7 +7485,7 @@
                 <a:ea typeface="Arial"/>
                 <a:cs typeface="Arial"/>
               </a:rPr>
-              <a:t>Stack or heap?</a:t>
+              <a:t>Quick check</a:t>
             </a:r>
           </a:p>
         </p:txBody>
@@ -7692,7 +7711,7 @@
                 <a:ea typeface="Arial"/>
                 <a:cs typeface="Arial"/>
               </a:rPr>
-              <a:t>Stack: automatic lifetime, tied to a function call.</a:t>
+              <a:t>1. Convert 1011 0110₂ to hex.</a:t>
             </a:r>
           </a:p>
           <a:p xmlns:a="http://schemas.openxmlformats.org/drawingml/2006/main">
@@ -7742,7 +7761,7 @@
                 <a:ea typeface="Arial"/>
                 <a:cs typeface="Arial"/>
               </a:rPr>
-              <a:t>Heap: requested at runtime and remains allocated until free.</a:t>
+              <a:t>2. Convert 0x4D to binary.</a:t>
             </a:r>
           </a:p>
           <a:p xmlns:a="http://schemas.openxmlformats.org/drawingml/2006/main">
@@ -7792,7 +7811,7 @@
                 <a:ea typeface="Arial"/>
                 <a:cs typeface="Arial"/>
               </a:rPr>
-              <a:t>A pointer may live on the stack while the memory it points to lives on the heap.</a:t>
+              <a:t>3. In movq $8, %rax, which operand is the destination?</a:t>
             </a:r>
           </a:p>
         </p:txBody>
@@ -8018,7 +8037,7 @@
                 <a:ea typeface="Consolas"/>
                 <a:cs typeface="Consolas"/>
               </a:rPr>
-              <a:t>int local[10];          // stack</a:t>
+              <a:t>4. If an int array begins at 0x1000, where is a[5]?</a:t>
             </a:r>
           </a:p>
           <a:p xmlns:a="http://schemas.openxmlformats.org/drawingml/2006/main">
@@ -8068,7 +8087,24 @@
                 <a:ea typeface="Consolas"/>
                 <a:cs typeface="Consolas"/>
               </a:rPr>
-              <a:t>int *data = malloc(n * sizeof *data);</a:t>
+              <a:t>5. Which storage must be released with free?</a:t>
+            </a:r>
+          </a:p>
+          <a:p xmlns:a="http://schemas.openxmlformats.org/drawingml/2006/main">
+            <a:pPr marL="0" indent="0">
+              <a:lnSpc>
+                <a:spcPct val="112000"/>
+              </a:lnSpc>
+              <a:spcBef>
+                <a:spcPts val="0"/>
+              </a:spcBef>
+              <a:spcAft>
+                <a:spcPts val="0"/>
+              </a:spcAft>
+              <a:buNone/>
+            </a:pPr>
+            <a:r>
+              <a:t/>
             </a:r>
           </a:p>
           <a:p xmlns:a="http://schemas.openxmlformats.org/drawingml/2006/main">
@@ -8101,24 +8137,7 @@
                 <a:ea typeface="Consolas"/>
                 <a:cs typeface="Consolas"/>
               </a:rPr>
-              <a:t>if (data == NULL) { /* handle failure */ }</a:t>
-            </a:r>
-          </a:p>
-          <a:p xmlns:a="http://schemas.openxmlformats.org/drawingml/2006/main">
-            <a:pPr marL="0" indent="0">
-              <a:lnSpc>
-                <a:spcPct val="112000"/>
-              </a:lnSpc>
-              <a:spcBef>
-                <a:spcPts val="0"/>
-              </a:spcBef>
-              <a:spcAft>
-                <a:spcPts val="0"/>
-              </a:spcAft>
-              <a:buNone/>
-            </a:pPr>
-            <a:r>
-              <a:t/>
+              <a:t>6. Mini-float 0 100 1000</a:t>
             </a:r>
           </a:p>
           <a:p xmlns:a="http://schemas.openxmlformats.org/drawingml/2006/main">
@@ -8151,7 +8170,7 @@
                 <a:ea typeface="Consolas"/>
                 <a:cs typeface="Consolas"/>
               </a:rPr>
-              <a:t>free(data);</a:t>
+              <a:t>   Bias 3</a:t>
             </a:r>
           </a:p>
           <a:p xmlns:a="http://schemas.openxmlformats.org/drawingml/2006/main">
@@ -8184,7 +8203,7 @@
                 <a:ea typeface="Consolas"/>
                 <a:cs typeface="Consolas"/>
               </a:rPr>
-              <a:t>data = NULL;</a:t>
+              <a:t>   What value is it?</a:t>
             </a:r>
           </a:p>
         </p:txBody>
@@ -8194,7 +8213,7 @@
           <p:cNvPr id="534" name="Takeaway">
             <a:extLst xmlns:a="http://schemas.openxmlformats.org/drawingml/2006/main">
               <a:ext uri="{FF2B5EF4-FFF2-40B4-BE49-F238E27FC236}">
-                <a16:creationId xmlns:a16="http://schemas.microsoft.com/office/drawing/2014/main" id="{9E630726-DC14-4620-87A6-EEE8A7E30F0E}"/>
+                <a16:creationId xmlns:a16="http://schemas.microsoft.com/office/drawing/2014/main" id="{C2F37112-65B3-4922-A67A-B87F405B209B}"/>
               </a:ext>
             </a:extLst>
           </p:cNvPr>
@@ -8251,7 +8270,7 @@
                 <a:ea typeface="Arial"/>
                 <a:cs typeface="Arial"/>
               </a:rPr>
-              <a:t>Losing the last pointer before free causes a leak; using memory after free is invalid.</a:t>
+              <a:t>Answer each by showing the representation or address calculation.</a:t>
             </a:r>
           </a:p>
         </p:txBody>
@@ -8459,7 +8478,7 @@
                 <a:ea typeface="Arial"/>
                 <a:cs typeface="Arial"/>
               </a:rPr>
-              <a:t>Quick check</a:t>
+              <a:t>Quick check answers</a:t>
             </a:r>
           </a:p>
         </p:txBody>
@@ -8685,7 +8704,7 @@
                 <a:ea typeface="Arial"/>
                 <a:cs typeface="Arial"/>
               </a:rPr>
-              <a:t>1. Convert 1011 0110₂ to hex.</a:t>
+              <a:t>1. 0xB6</a:t>
             </a:r>
           </a:p>
           <a:p xmlns:a="http://schemas.openxmlformats.org/drawingml/2006/main">
@@ -8735,7 +8754,7 @@
                 <a:ea typeface="Arial"/>
                 <a:cs typeface="Arial"/>
               </a:rPr>
-              <a:t>2. Convert 0x4D to binary.</a:t>
+              <a:t>2. 0100 1101₂</a:t>
             </a:r>
           </a:p>
           <a:p xmlns:a="http://schemas.openxmlformats.org/drawingml/2006/main">
@@ -8785,7 +8804,7 @@
                 <a:ea typeface="Arial"/>
                 <a:cs typeface="Arial"/>
               </a:rPr>
-              <a:t>3. In movq $8, %rax, which operand is the destination?</a:t>
+              <a:t>3. %rax</a:t>
             </a:r>
           </a:p>
         </p:txBody>
@@ -9011,7 +9030,7 @@
                 <a:ea typeface="Consolas"/>
                 <a:cs typeface="Consolas"/>
               </a:rPr>
-              <a:t>4. If an int array begins at 0x1000, where is a[5]?</a:t>
+              <a:t>4. 0x1000 + 5 × 4 = 0x1014</a:t>
             </a:r>
           </a:p>
           <a:p xmlns:a="http://schemas.openxmlformats.org/drawingml/2006/main">
@@ -9061,7 +9080,7 @@
                 <a:ea typeface="Consolas"/>
                 <a:cs typeface="Consolas"/>
               </a:rPr>
-              <a:t>5. Which storage must be released with free?</a:t>
+              <a:t>5. Heap storage from malloc/calloc/realloc</a:t>
             </a:r>
           </a:p>
           <a:p xmlns:a="http://schemas.openxmlformats.org/drawingml/2006/main">
@@ -9111,73 +9130,7 @@
                 <a:ea typeface="Consolas"/>
                 <a:cs typeface="Consolas"/>
               </a:rPr>
-              <a:t>6. Mini-float 0 100 1000</a:t>
-            </a:r>
-          </a:p>
-          <a:p xmlns:a="http://schemas.openxmlformats.org/drawingml/2006/main">
-            <a:pPr marL="0" indent="0">
-              <a:lnSpc>
-                <a:spcPct val="112000"/>
-              </a:lnSpc>
-              <a:spcBef>
-                <a:spcPts val="0"/>
-              </a:spcBef>
-              <a:spcAft>
-                <a:spcPts val="0"/>
-              </a:spcAft>
-              <a:buNone/>
-              <a:defRPr sz="1800">
-                <a:solidFill>
-                  <a:srgbClr val="FFFFFF"/>
-                </a:solidFill>
-                <a:latin typeface="Consolas"/>
-                <a:ea typeface="Consolas"/>
-                <a:cs typeface="Consolas"/>
-              </a:defRPr>
-            </a:pPr>
-            <a:r>
-              <a:rPr sz="1800">
-                <a:solidFill>
-                  <a:srgbClr val="FFFFFF"/>
-                </a:solidFill>
-                <a:latin typeface="Consolas"/>
-                <a:ea typeface="Consolas"/>
-                <a:cs typeface="Consolas"/>
-              </a:rPr>
-              <a:t>   Bias 3</a:t>
-            </a:r>
-          </a:p>
-          <a:p xmlns:a="http://schemas.openxmlformats.org/drawingml/2006/main">
-            <a:pPr marL="0" indent="0">
-              <a:lnSpc>
-                <a:spcPct val="112000"/>
-              </a:lnSpc>
-              <a:spcBef>
-                <a:spcPts val="0"/>
-              </a:spcBef>
-              <a:spcAft>
-                <a:spcPts val="0"/>
-              </a:spcAft>
-              <a:buNone/>
-              <a:defRPr sz="1800">
-                <a:solidFill>
-                  <a:srgbClr val="FFFFFF"/>
-                </a:solidFill>
-                <a:latin typeface="Consolas"/>
-                <a:ea typeface="Consolas"/>
-                <a:cs typeface="Consolas"/>
-              </a:defRPr>
-            </a:pPr>
-            <a:r>
-              <a:rPr sz="1800">
-                <a:solidFill>
-                  <a:srgbClr val="FFFFFF"/>
-                </a:solidFill>
-                <a:latin typeface="Consolas"/>
-                <a:ea typeface="Consolas"/>
-                <a:cs typeface="Consolas"/>
-              </a:rPr>
-              <a:t>   What value is it?</a:t>
+              <a:t>6. (+1) × 2¹ × 1.5 = 3.0</a:t>
             </a:r>
           </a:p>
         </p:txBody>
@@ -9187,934 +9140,7 @@
           <p:cNvPr id="534" name="Takeaway">
             <a:extLst xmlns:a="http://schemas.openxmlformats.org/drawingml/2006/main">
               <a:ext uri="{FF2B5EF4-FFF2-40B4-BE49-F238E27FC236}">
-                <a16:creationId xmlns:a16="http://schemas.microsoft.com/office/drawing/2014/main" id="{0D9E1135-F5D8-461F-A4E6-2587C8DEBF96}"/>
-              </a:ext>
-            </a:extLst>
-          </p:cNvPr>
-          <p:cNvSpPr>
-            <a:spLocks xmlns:a="http://schemas.openxmlformats.org/drawingml/2006/main" noGrp="1"/>
-          </p:cNvSpPr>
-          <p:nvPr/>
-        </p:nvSpPr>
-        <p:spPr>
-          <a:xfrm xmlns:a="http://schemas.openxmlformats.org/drawingml/2006/main">
-            <a:off x="393668" y="5715000"/>
-            <a:ext cx="11404283" cy="466725"/>
-          </a:xfrm>
-          <a:prstGeom xmlns:a="http://schemas.openxmlformats.org/drawingml/2006/main" prst="rect">
-            <a:avLst/>
-          </a:prstGeom>
-          <a:noFill xmlns:a="http://schemas.openxmlformats.org/drawingml/2006/main"/>
-          <a:ln xmlns:a="http://schemas.openxmlformats.org/drawingml/2006/main" w="0">
-            <a:noFill/>
-          </a:ln>
-        </p:spPr>
-        <p:txBody>
-          <a:bodyPr xmlns:a="http://schemas.openxmlformats.org/drawingml/2006/main" lIns="0" tIns="0" rIns="0" bIns="0" anchor="t">
-            <a:noAutofit/>
-          </a:bodyPr>
-          <a:lstStyle xmlns:a="http://schemas.openxmlformats.org/drawingml/2006/main"/>
-          <a:p xmlns:a="http://schemas.openxmlformats.org/drawingml/2006/main">
-            <a:pPr marL="0" indent="0">
-              <a:lnSpc>
-                <a:spcPct val="112000"/>
-              </a:lnSpc>
-              <a:spcBef>
-                <a:spcPts val="0"/>
-              </a:spcBef>
-              <a:spcAft>
-                <a:spcPts val="0"/>
-              </a:spcAft>
-              <a:buNone/>
-              <a:defRPr sz="1350">
-                <a:solidFill>
-                  <a:srgbClr val="CCCCCC"/>
-                </a:solidFill>
-                <a:latin typeface="Arial"/>
-                <a:ea typeface="Arial"/>
-                <a:cs typeface="Arial"/>
-              </a:defRPr>
-            </a:pPr>
-            <a:r>
-              <a:rPr sz="1350">
-                <a:solidFill>
-                  <a:srgbClr val="CCCCCC"/>
-                </a:solidFill>
-                <a:latin typeface="Arial"/>
-                <a:ea typeface="Arial"/>
-                <a:cs typeface="Arial"/>
-              </a:rPr>
-              <a:t>Answer each by showing the representation or address calculation.</a:t>
-            </a:r>
-          </a:p>
-        </p:txBody>
-      </p:sp>
-    </p:spTree>
-    <p:extLst>
-      <p:ext uri="{BB962C8B-B14F-4D97-AF65-F5344CB8AC3E}">
-        <p14:creationId xmlns:p14="http://schemas.microsoft.com/office/powerpoint/2010/main" val="3667182145"/>
-      </p:ext>
-    </p:extLst>
-  </p:cSld>
-</p:sld>
-</file>
-
-<file path=ppt/slides/slide15.xml><?xml version="1.0" encoding="utf-8"?>
-<p:sld xmlns:p="http://schemas.openxmlformats.org/presentationml/2006/main">
-  <p:cSld>
-    <p:spTree>
-      <p:nvGrpSpPr>
-        <p:cNvPr id="1" name=""/>
-        <p:cNvGrpSpPr/>
-        <p:nvPr/>
-      </p:nvGrpSpPr>
-      <p:grpSpPr>
-        <a:xfrm xmlns:a="http://schemas.openxmlformats.org/drawingml/2006/main"/>
-      </p:grpSpPr>
-      <p:sp>
-        <p:nvSpPr>
-          <p:cNvPr id="3" name="Footer Placeholder 2">
-            <a:extLst xmlns:a="http://schemas.openxmlformats.org/drawingml/2006/main">
-              <a:ext uri="{FF2B5EF4-FFF2-40B4-BE49-F238E27FC236}">
-                <a16:creationId xmlns:a16="http://schemas.microsoft.com/office/drawing/2014/main" id="{39EA4C82-C623-0196-4A95-876ADF5DEE92}"/>
-              </a:ext>
-            </a:extLst>
-          </p:cNvPr>
-          <p:cNvSpPr>
-            <a:spLocks xmlns:a="http://schemas.openxmlformats.org/drawingml/2006/main" noGrp="1"/>
-          </p:cNvSpPr>
-          <p:nvPr>
-            <p:ph type="ftr" idx="3"/>
-          </p:nvPr>
-        </p:nvSpPr>
-        <p:spPr>
-          <a:xfrm xmlns:a="http://schemas.openxmlformats.org/drawingml/2006/main">
-            <a:off x="393700" y="6279952"/>
-            <a:ext cx="3568700" cy="241240"/>
-          </a:xfrm>
-        </p:spPr>
-        <p:txBody>
-          <a:bodyPr xmlns:a="http://schemas.openxmlformats.org/drawingml/2006/main" lIns="0" tIns="0" rIns="0" bIns="0" anchor="t">
-            <a:noAutofit/>
-          </a:bodyPr>
-          <a:lstStyle xmlns:a="http://schemas.openxmlformats.org/drawingml/2006/main"/>
-          <a:p xmlns:a="http://schemas.openxmlformats.org/drawingml/2006/main">
-            <a:pPr marL="0" indent="0">
-              <a:lnSpc>
-                <a:spcPct val="112000"/>
-              </a:lnSpc>
-              <a:spcBef>
-                <a:spcPts val="0"/>
-              </a:spcBef>
-              <a:spcAft>
-                <a:spcPts val="0"/>
-              </a:spcAft>
-              <a:buNone/>
-              <a:defRPr sz="1125">
-                <a:solidFill>
-                  <a:srgbClr val="FFFFFF"/>
-                </a:solidFill>
-                <a:latin typeface="Arial"/>
-                <a:ea typeface="Arial"/>
-                <a:cs typeface="Arial"/>
-              </a:defRPr>
-            </a:pPr>
-            <a:r>
-              <a:rPr sz="1125">
-                <a:solidFill>
-                  <a:srgbClr val="FFFFFF"/>
-                </a:solidFill>
-                <a:latin typeface="Arial"/>
-                <a:ea typeface="Arial"/>
-                <a:cs typeface="Arial"/>
-              </a:rPr>
-              <a:t>CS 211 · Recitation 04</a:t>
-            </a:r>
-          </a:p>
-        </p:txBody>
-      </p:sp>
-      <p:sp>
-        <p:nvSpPr>
-          <p:cNvPr id="532" name="Google Shape;532;p58">
-            <a:extLst xmlns:a="http://schemas.openxmlformats.org/drawingml/2006/main">
-              <a:ext uri="{FF2B5EF4-FFF2-40B4-BE49-F238E27FC236}">
-                <a16:creationId xmlns:a16="http://schemas.microsoft.com/office/drawing/2014/main" id="{1BCBE750-7048-686D-1472-52C53362D6CD}"/>
-              </a:ext>
-            </a:extLst>
-          </p:cNvPr>
-          <p:cNvSpPr>
-            <a:spLocks xmlns:a="http://schemas.openxmlformats.org/drawingml/2006/main" noGrp="1"/>
-          </p:cNvSpPr>
-          <p:nvPr>
-            <p:ph type="sldNum" idx="4"/>
-          </p:nvPr>
-        </p:nvSpPr>
-        <p:spPr>
-          <a:xfrm xmlns:a="http://schemas.openxmlformats.org/drawingml/2006/main">
-            <a:off x="11279332" y="6279294"/>
-            <a:ext cx="518968" cy="241240"/>
-          </a:xfrm>
-        </p:spPr>
-        <p:txBody>
-          <a:bodyPr xmlns:a="http://schemas.openxmlformats.org/drawingml/2006/main" spcFirstLastPara="1" vert="horz" wrap="square" lIns="0" tIns="0" rIns="0" bIns="0" anchor="t">
-            <a:noAutofit/>
-          </a:bodyPr>
-          <a:lstStyle xmlns:a="http://schemas.openxmlformats.org/drawingml/2006/main"/>
-          <a:p xmlns:a="http://schemas.openxmlformats.org/drawingml/2006/main">
-            <a:pPr marL="0" indent="0">
-              <a:lnSpc>
-                <a:spcPct val="112000"/>
-              </a:lnSpc>
-              <a:spcBef>
-                <a:spcPts val="0"/>
-              </a:spcBef>
-              <a:spcAft>
-                <a:spcPts val="0"/>
-              </a:spcAft>
-              <a:buNone/>
-              <a:defRPr sz="1125">
-                <a:solidFill>
-                  <a:srgbClr val="FFFFFF"/>
-                </a:solidFill>
-                <a:latin typeface="Arial"/>
-                <a:ea typeface="Arial"/>
-                <a:cs typeface="Arial"/>
-              </a:defRPr>
-            </a:pPr>
-            <a:r>
-              <a:rPr sz="1125">
-                <a:solidFill>
-                  <a:srgbClr val="FFFFFF"/>
-                </a:solidFill>
-                <a:latin typeface="Arial"/>
-                <a:ea typeface="Arial"/>
-                <a:cs typeface="Arial"/>
-              </a:rPr>
-              <a:t>15</a:t>
-            </a:r>
-          </a:p>
-        </p:txBody>
-      </p:sp>
-      <p:sp>
-        <p:nvSpPr>
-          <p:cNvPr id="533" name="Google Shape;533;p58">
-            <a:extLst xmlns:a="http://schemas.openxmlformats.org/drawingml/2006/main">
-              <a:ext uri="{FF2B5EF4-FFF2-40B4-BE49-F238E27FC236}">
-                <a16:creationId xmlns:a16="http://schemas.microsoft.com/office/drawing/2014/main" id="{1B5D55CD-1C17-7CD8-F26A-2DD65B067687}"/>
-              </a:ext>
-            </a:extLst>
-          </p:cNvPr>
-          <p:cNvSpPr>
-            <a:spLocks xmlns:a="http://schemas.openxmlformats.org/drawingml/2006/main" noGrp="1"/>
-          </p:cNvSpPr>
-          <p:nvPr>
-            <p:ph type="title" idx="0"/>
-          </p:nvPr>
-        </p:nvSpPr>
-        <p:spPr>
-          <a:xfrm xmlns:a="http://schemas.openxmlformats.org/drawingml/2006/main">
-            <a:off x="393700" y="344008"/>
-            <a:ext cx="11404600" cy="1047491"/>
-          </a:xfrm>
-        </p:spPr>
-        <p:txBody>
-          <a:bodyPr xmlns:a="http://schemas.openxmlformats.org/drawingml/2006/main" spcFirstLastPara="1" vert="horz" wrap="square" lIns="0" tIns="0" rIns="0" bIns="0" anchor="t">
-            <a:noAutofit/>
-          </a:bodyPr>
-          <a:lstStyle xmlns:a="http://schemas.openxmlformats.org/drawingml/2006/main"/>
-          <a:p xmlns:a="http://schemas.openxmlformats.org/drawingml/2006/main">
-            <a:pPr marL="0" indent="0">
-              <a:lnSpc>
-                <a:spcPct val="112000"/>
-              </a:lnSpc>
-              <a:spcBef>
-                <a:spcPts val="0"/>
-              </a:spcBef>
-              <a:spcAft>
-                <a:spcPts val="0"/>
-              </a:spcAft>
-              <a:buNone/>
-              <a:defRPr sz="3150">
-                <a:solidFill>
-                  <a:srgbClr val="FFFFFF"/>
-                </a:solidFill>
-                <a:latin typeface="Arial"/>
-                <a:ea typeface="Arial"/>
-                <a:cs typeface="Arial"/>
-              </a:defRPr>
-            </a:pPr>
-            <a:r>
-              <a:rPr sz="3150">
-                <a:solidFill>
-                  <a:srgbClr val="FFFFFF"/>
-                </a:solidFill>
-                <a:latin typeface="Arial"/>
-                <a:ea typeface="Arial"/>
-                <a:cs typeface="Arial"/>
-              </a:rPr>
-              <a:t>Quick check answers</a:t>
-            </a:r>
-          </a:p>
-        </p:txBody>
-      </p:sp>
-      <p:sp>
-        <p:nvSpPr>
-          <p:cNvPr id="7" name="Google Shape;534;p58">
-            <a:extLst xmlns:a="http://schemas.openxmlformats.org/drawingml/2006/main">
-              <a:ext uri="{FF2B5EF4-FFF2-40B4-BE49-F238E27FC236}">
-                <a16:creationId xmlns:a16="http://schemas.microsoft.com/office/drawing/2014/main" id="{3A923FEE-B8D2-CD3A-ABBD-21770B40AA24}"/>
-              </a:ext>
-            </a:extLst>
-          </p:cNvPr>
-          <p:cNvSpPr>
-            <a:spLocks xmlns:a="http://schemas.openxmlformats.org/drawingml/2006/main" noGrp="1"/>
-          </p:cNvSpPr>
-          <p:nvPr/>
-        </p:nvSpPr>
-        <p:spPr>
-          <a:xfrm xmlns:a="http://schemas.openxmlformats.org/drawingml/2006/main">
-            <a:off x="393700" y="2031999"/>
-            <a:ext cx="5537200" cy="3534787"/>
-          </a:xfrm>
-          <a:prstGeom xmlns:a="http://schemas.openxmlformats.org/drawingml/2006/main" prst="rect">
-            <a:avLst/>
-          </a:prstGeom>
-        </p:spPr>
-        <p:txBody>
-          <a:bodyPr xmlns:a="http://schemas.openxmlformats.org/drawingml/2006/main" spcFirstLastPara="1" vert="horz" wrap="square" lIns="0" tIns="0" rIns="0" bIns="0" anchor="t">
-            <a:noAutofit/>
-          </a:bodyPr>
-          <a:lstStyle xmlns:a="http://schemas.openxmlformats.org/drawingml/2006/main">
-            <a:lvl1pPr marL="228600" indent="-228600" algn="l" defTabSz="914400">
-              <a:lnSpc>
-                <a:spcPct val="90000"/>
-              </a:lnSpc>
-              <a:spcBef>
-                <a:spcPts val="1000"/>
-              </a:spcBef>
-              <a:buFont typeface="Arial"/>
-              <a:buChar char="•"/>
-              <a:defRPr sz="2400" kern="1200">
-                <a:solidFill>
-                  <a:schemeClr val="tx1"/>
-                </a:solidFill>
-                <a:latin typeface="+mn-lt"/>
-                <a:ea typeface="+mn-lt"/>
-                <a:cs typeface="+mn-lt"/>
-              </a:defRPr>
-            </a:lvl1pPr>
-            <a:lvl2pPr marL="685800" indent="-228600" algn="l" defTabSz="914400">
-              <a:lnSpc>
-                <a:spcPct val="90000"/>
-              </a:lnSpc>
-              <a:spcBef>
-                <a:spcPts val="500"/>
-              </a:spcBef>
-              <a:buFont typeface="Arial"/>
-              <a:buChar char="•"/>
-              <a:defRPr sz="2000" kern="1200">
-                <a:solidFill>
-                  <a:schemeClr val="tx1"/>
-                </a:solidFill>
-                <a:latin typeface="+mn-lt"/>
-                <a:ea typeface="+mn-lt"/>
-                <a:cs typeface="+mn-lt"/>
-              </a:defRPr>
-            </a:lvl2pPr>
-            <a:lvl3pPr marL="1143000" indent="-228600" algn="l" defTabSz="914400">
-              <a:lnSpc>
-                <a:spcPct val="90000"/>
-              </a:lnSpc>
-              <a:spcBef>
-                <a:spcPts val="500"/>
-              </a:spcBef>
-              <a:buFont typeface="Arial"/>
-              <a:buChar char="•"/>
-              <a:defRPr sz="1800" kern="1200">
-                <a:solidFill>
-                  <a:schemeClr val="tx1"/>
-                </a:solidFill>
-                <a:latin typeface="+mn-lt"/>
-                <a:ea typeface="+mn-lt"/>
-                <a:cs typeface="+mn-lt"/>
-              </a:defRPr>
-            </a:lvl3pPr>
-            <a:lvl4pPr marL="1600200" indent="-228600" algn="l" defTabSz="914400">
-              <a:lnSpc>
-                <a:spcPct val="90000"/>
-              </a:lnSpc>
-              <a:spcBef>
-                <a:spcPts val="500"/>
-              </a:spcBef>
-              <a:buFont typeface="Arial"/>
-              <a:buChar char="•"/>
-              <a:defRPr sz="1800" kern="1200">
-                <a:solidFill>
-                  <a:schemeClr val="tx1"/>
-                </a:solidFill>
-                <a:latin typeface="+mn-lt"/>
-                <a:ea typeface="+mn-lt"/>
-                <a:cs typeface="+mn-lt"/>
-              </a:defRPr>
-            </a:lvl4pPr>
-            <a:lvl5pPr marL="2057400" indent="-228600" algn="l" defTabSz="914400">
-              <a:lnSpc>
-                <a:spcPct val="90000"/>
-              </a:lnSpc>
-              <a:spcBef>
-                <a:spcPts val="500"/>
-              </a:spcBef>
-              <a:buFont typeface="Arial"/>
-              <a:buChar char="•"/>
-              <a:defRPr sz="1800" kern="1200">
-                <a:solidFill>
-                  <a:schemeClr val="tx1"/>
-                </a:solidFill>
-                <a:latin typeface="+mn-lt"/>
-                <a:ea typeface="+mn-lt"/>
-                <a:cs typeface="+mn-lt"/>
-              </a:defRPr>
-            </a:lvl5pPr>
-            <a:lvl6pPr marL="2514600" indent="-228600" algn="l" defTabSz="914400">
-              <a:lnSpc>
-                <a:spcPct val="90000"/>
-              </a:lnSpc>
-              <a:spcBef>
-                <a:spcPts val="500"/>
-              </a:spcBef>
-              <a:buFont typeface="Arial"/>
-              <a:buChar char="•"/>
-              <a:defRPr sz="1800" kern="1200">
-                <a:solidFill>
-                  <a:schemeClr val="tx1"/>
-                </a:solidFill>
-                <a:latin typeface="+mn-lt"/>
-                <a:ea typeface="+mn-lt"/>
-                <a:cs typeface="+mn-lt"/>
-              </a:defRPr>
-            </a:lvl6pPr>
-            <a:lvl7pPr marL="2971800" indent="-228600" algn="l" defTabSz="914400">
-              <a:lnSpc>
-                <a:spcPct val="90000"/>
-              </a:lnSpc>
-              <a:spcBef>
-                <a:spcPts val="500"/>
-              </a:spcBef>
-              <a:buFont typeface="Arial"/>
-              <a:buChar char="•"/>
-              <a:defRPr sz="1800" kern="1200">
-                <a:solidFill>
-                  <a:schemeClr val="tx1"/>
-                </a:solidFill>
-                <a:latin typeface="+mn-lt"/>
-                <a:ea typeface="+mn-lt"/>
-                <a:cs typeface="+mn-lt"/>
-              </a:defRPr>
-            </a:lvl7pPr>
-            <a:lvl8pPr marL="3429000" indent="-228600" algn="l" defTabSz="914400">
-              <a:lnSpc>
-                <a:spcPct val="90000"/>
-              </a:lnSpc>
-              <a:spcBef>
-                <a:spcPts val="500"/>
-              </a:spcBef>
-              <a:buFont typeface="Arial"/>
-              <a:buChar char="•"/>
-              <a:defRPr sz="1800" kern="1200">
-                <a:solidFill>
-                  <a:schemeClr val="tx1"/>
-                </a:solidFill>
-                <a:latin typeface="+mn-lt"/>
-                <a:ea typeface="+mn-lt"/>
-                <a:cs typeface="+mn-lt"/>
-              </a:defRPr>
-            </a:lvl8pPr>
-            <a:lvl9pPr marL="3886200" indent="-228600" algn="l" defTabSz="914400">
-              <a:lnSpc>
-                <a:spcPct val="90000"/>
-              </a:lnSpc>
-              <a:spcBef>
-                <a:spcPts val="500"/>
-              </a:spcBef>
-              <a:buFont typeface="Arial"/>
-              <a:buChar char="•"/>
-              <a:defRPr sz="1800" kern="1200">
-                <a:solidFill>
-                  <a:schemeClr val="tx1"/>
-                </a:solidFill>
-                <a:latin typeface="+mn-lt"/>
-                <a:ea typeface="+mn-lt"/>
-                <a:cs typeface="+mn-lt"/>
-              </a:defRPr>
-            </a:lvl9pPr>
-          </a:lstStyle>
-          <a:p xmlns:a="http://schemas.openxmlformats.org/drawingml/2006/main">
-            <a:pPr marL="0" indent="0">
-              <a:lnSpc>
-                <a:spcPct val="112000"/>
-              </a:lnSpc>
-              <a:spcBef>
-                <a:spcPts val="0"/>
-              </a:spcBef>
-              <a:spcAft>
-                <a:spcPts val="0"/>
-              </a:spcAft>
-              <a:buNone/>
-              <a:defRPr sz="1875">
-                <a:solidFill>
-                  <a:srgbClr val="FFFFFF"/>
-                </a:solidFill>
-                <a:latin typeface="Arial"/>
-                <a:ea typeface="Arial"/>
-                <a:cs typeface="Arial"/>
-              </a:defRPr>
-            </a:pPr>
-            <a:r>
-              <a:rPr sz="1875">
-                <a:solidFill>
-                  <a:srgbClr val="FFFFFF"/>
-                </a:solidFill>
-                <a:latin typeface="Arial"/>
-                <a:ea typeface="Arial"/>
-                <a:cs typeface="Arial"/>
-              </a:rPr>
-              <a:t>1. 0xB6</a:t>
-            </a:r>
-          </a:p>
-          <a:p xmlns:a="http://schemas.openxmlformats.org/drawingml/2006/main">
-            <a:pPr marL="0" indent="0">
-              <a:lnSpc>
-                <a:spcPct val="112000"/>
-              </a:lnSpc>
-              <a:spcBef>
-                <a:spcPts val="0"/>
-              </a:spcBef>
-              <a:spcAft>
-                <a:spcPts val="0"/>
-              </a:spcAft>
-              <a:buNone/>
-            </a:pPr>
-            <a:r>
-              <a:t/>
-            </a:r>
-          </a:p>
-          <a:p xmlns:a="http://schemas.openxmlformats.org/drawingml/2006/main">
-            <a:pPr marL="0" indent="0">
-              <a:lnSpc>
-                <a:spcPct val="112000"/>
-              </a:lnSpc>
-              <a:spcBef>
-                <a:spcPts val="0"/>
-              </a:spcBef>
-              <a:spcAft>
-                <a:spcPts val="0"/>
-              </a:spcAft>
-              <a:buNone/>
-              <a:defRPr sz="1875">
-                <a:solidFill>
-                  <a:srgbClr val="FFFFFF"/>
-                </a:solidFill>
-                <a:latin typeface="Arial"/>
-                <a:ea typeface="Arial"/>
-                <a:cs typeface="Arial"/>
-              </a:defRPr>
-            </a:pPr>
-            <a:r>
-              <a:rPr sz="1875">
-                <a:solidFill>
-                  <a:srgbClr val="FFFFFF"/>
-                </a:solidFill>
-                <a:latin typeface="Arial"/>
-                <a:ea typeface="Arial"/>
-                <a:cs typeface="Arial"/>
-              </a:rPr>
-              <a:t>2. 0100 1101₂</a:t>
-            </a:r>
-          </a:p>
-          <a:p xmlns:a="http://schemas.openxmlformats.org/drawingml/2006/main">
-            <a:pPr marL="0" indent="0">
-              <a:lnSpc>
-                <a:spcPct val="112000"/>
-              </a:lnSpc>
-              <a:spcBef>
-                <a:spcPts val="0"/>
-              </a:spcBef>
-              <a:spcAft>
-                <a:spcPts val="0"/>
-              </a:spcAft>
-              <a:buNone/>
-            </a:pPr>
-            <a:r>
-              <a:t/>
-            </a:r>
-          </a:p>
-          <a:p xmlns:a="http://schemas.openxmlformats.org/drawingml/2006/main">
-            <a:pPr marL="0" indent="0">
-              <a:lnSpc>
-                <a:spcPct val="112000"/>
-              </a:lnSpc>
-              <a:spcBef>
-                <a:spcPts val="0"/>
-              </a:spcBef>
-              <a:spcAft>
-                <a:spcPts val="0"/>
-              </a:spcAft>
-              <a:buNone/>
-              <a:defRPr sz="1875">
-                <a:solidFill>
-                  <a:srgbClr val="FFFFFF"/>
-                </a:solidFill>
-                <a:latin typeface="Arial"/>
-                <a:ea typeface="Arial"/>
-                <a:cs typeface="Arial"/>
-              </a:defRPr>
-            </a:pPr>
-            <a:r>
-              <a:rPr sz="1875">
-                <a:solidFill>
-                  <a:srgbClr val="FFFFFF"/>
-                </a:solidFill>
-                <a:latin typeface="Arial"/>
-                <a:ea typeface="Arial"/>
-                <a:cs typeface="Arial"/>
-              </a:rPr>
-              <a:t>3. %rax</a:t>
-            </a:r>
-          </a:p>
-        </p:txBody>
-      </p:sp>
-      <p:sp>
-        <p:nvSpPr>
-          <p:cNvPr id="8" name="Content Placeholder 3">
-            <a:extLst xmlns:a="http://schemas.openxmlformats.org/drawingml/2006/main">
-              <a:ext uri="{FF2B5EF4-FFF2-40B4-BE49-F238E27FC236}">
-                <a16:creationId xmlns:a16="http://schemas.microsoft.com/office/drawing/2014/main" id="{2EE8F343-A95F-2AAA-FE9E-A6C31E298DF7}"/>
-              </a:ext>
-            </a:extLst>
-          </p:cNvPr>
-          <p:cNvSpPr>
-            <a:spLocks xmlns:a="http://schemas.openxmlformats.org/drawingml/2006/main" noGrp="1"/>
-          </p:cNvSpPr>
-          <p:nvPr/>
-        </p:nvSpPr>
-        <p:spPr>
-          <a:xfrm xmlns:a="http://schemas.openxmlformats.org/drawingml/2006/main">
-            <a:off x="6256618" y="2031999"/>
-            <a:ext cx="5537200" cy="3534787"/>
-          </a:xfrm>
-          <a:prstGeom xmlns:a="http://schemas.openxmlformats.org/drawingml/2006/main" prst="rect">
-            <a:avLst/>
-          </a:prstGeom>
-        </p:spPr>
-        <p:txBody>
-          <a:bodyPr xmlns:a="http://schemas.openxmlformats.org/drawingml/2006/main" lIns="0" tIns="0" rIns="0" bIns="0" anchor="t">
-            <a:noAutofit/>
-          </a:bodyPr>
-          <a:lstStyle xmlns:a="http://schemas.openxmlformats.org/drawingml/2006/main">
-            <a:lvl1pPr marL="228600" indent="-228600" algn="l" defTabSz="914400">
-              <a:lnSpc>
-                <a:spcPct val="90000"/>
-              </a:lnSpc>
-              <a:spcBef>
-                <a:spcPts val="1000"/>
-              </a:spcBef>
-              <a:buFont typeface="Arial"/>
-              <a:buChar char="•"/>
-              <a:defRPr sz="2400" kern="1200">
-                <a:solidFill>
-                  <a:schemeClr val="tx1"/>
-                </a:solidFill>
-                <a:latin typeface="+mn-lt"/>
-                <a:ea typeface="+mn-lt"/>
-                <a:cs typeface="+mn-lt"/>
-              </a:defRPr>
-            </a:lvl1pPr>
-            <a:lvl2pPr marL="685800" indent="-228600" algn="l" defTabSz="914400">
-              <a:lnSpc>
-                <a:spcPct val="90000"/>
-              </a:lnSpc>
-              <a:spcBef>
-                <a:spcPts val="500"/>
-              </a:spcBef>
-              <a:buFont typeface="Arial"/>
-              <a:buChar char="•"/>
-              <a:defRPr sz="2000" kern="1200">
-                <a:solidFill>
-                  <a:schemeClr val="tx1"/>
-                </a:solidFill>
-                <a:latin typeface="+mn-lt"/>
-                <a:ea typeface="+mn-lt"/>
-                <a:cs typeface="+mn-lt"/>
-              </a:defRPr>
-            </a:lvl2pPr>
-            <a:lvl3pPr marL="1143000" indent="-228600" algn="l" defTabSz="914400">
-              <a:lnSpc>
-                <a:spcPct val="90000"/>
-              </a:lnSpc>
-              <a:spcBef>
-                <a:spcPts val="500"/>
-              </a:spcBef>
-              <a:buFont typeface="Arial"/>
-              <a:buChar char="•"/>
-              <a:defRPr sz="1800" kern="1200">
-                <a:solidFill>
-                  <a:schemeClr val="tx1"/>
-                </a:solidFill>
-                <a:latin typeface="+mn-lt"/>
-                <a:ea typeface="+mn-lt"/>
-                <a:cs typeface="+mn-lt"/>
-              </a:defRPr>
-            </a:lvl3pPr>
-            <a:lvl4pPr marL="1600200" indent="-228600" algn="l" defTabSz="914400">
-              <a:lnSpc>
-                <a:spcPct val="90000"/>
-              </a:lnSpc>
-              <a:spcBef>
-                <a:spcPts val="500"/>
-              </a:spcBef>
-              <a:buFont typeface="Arial"/>
-              <a:buChar char="•"/>
-              <a:defRPr sz="1800" kern="1200">
-                <a:solidFill>
-                  <a:schemeClr val="tx1"/>
-                </a:solidFill>
-                <a:latin typeface="+mn-lt"/>
-                <a:ea typeface="+mn-lt"/>
-                <a:cs typeface="+mn-lt"/>
-              </a:defRPr>
-            </a:lvl4pPr>
-            <a:lvl5pPr marL="2057400" indent="-228600" algn="l" defTabSz="914400">
-              <a:lnSpc>
-                <a:spcPct val="90000"/>
-              </a:lnSpc>
-              <a:spcBef>
-                <a:spcPts val="500"/>
-              </a:spcBef>
-              <a:buFont typeface="Arial"/>
-              <a:buChar char="•"/>
-              <a:defRPr sz="1800" kern="1200">
-                <a:solidFill>
-                  <a:schemeClr val="tx1"/>
-                </a:solidFill>
-                <a:latin typeface="+mn-lt"/>
-                <a:ea typeface="+mn-lt"/>
-                <a:cs typeface="+mn-lt"/>
-              </a:defRPr>
-            </a:lvl5pPr>
-            <a:lvl6pPr marL="2514600" indent="-228600" algn="l" defTabSz="914400">
-              <a:lnSpc>
-                <a:spcPct val="90000"/>
-              </a:lnSpc>
-              <a:spcBef>
-                <a:spcPts val="500"/>
-              </a:spcBef>
-              <a:buFont typeface="Arial"/>
-              <a:buChar char="•"/>
-              <a:defRPr sz="1800" kern="1200">
-                <a:solidFill>
-                  <a:schemeClr val="tx1"/>
-                </a:solidFill>
-                <a:latin typeface="+mn-lt"/>
-                <a:ea typeface="+mn-lt"/>
-                <a:cs typeface="+mn-lt"/>
-              </a:defRPr>
-            </a:lvl6pPr>
-            <a:lvl7pPr marL="2971800" indent="-228600" algn="l" defTabSz="914400">
-              <a:lnSpc>
-                <a:spcPct val="90000"/>
-              </a:lnSpc>
-              <a:spcBef>
-                <a:spcPts val="500"/>
-              </a:spcBef>
-              <a:buFont typeface="Arial"/>
-              <a:buChar char="•"/>
-              <a:defRPr sz="1800" kern="1200">
-                <a:solidFill>
-                  <a:schemeClr val="tx1"/>
-                </a:solidFill>
-                <a:latin typeface="+mn-lt"/>
-                <a:ea typeface="+mn-lt"/>
-                <a:cs typeface="+mn-lt"/>
-              </a:defRPr>
-            </a:lvl7pPr>
-            <a:lvl8pPr marL="3429000" indent="-228600" algn="l" defTabSz="914400">
-              <a:lnSpc>
-                <a:spcPct val="90000"/>
-              </a:lnSpc>
-              <a:spcBef>
-                <a:spcPts val="500"/>
-              </a:spcBef>
-              <a:buFont typeface="Arial"/>
-              <a:buChar char="•"/>
-              <a:defRPr sz="1800" kern="1200">
-                <a:solidFill>
-                  <a:schemeClr val="tx1"/>
-                </a:solidFill>
-                <a:latin typeface="+mn-lt"/>
-                <a:ea typeface="+mn-lt"/>
-                <a:cs typeface="+mn-lt"/>
-              </a:defRPr>
-            </a:lvl8pPr>
-            <a:lvl9pPr marL="3886200" indent="-228600" algn="l" defTabSz="914400">
-              <a:lnSpc>
-                <a:spcPct val="90000"/>
-              </a:lnSpc>
-              <a:spcBef>
-                <a:spcPts val="500"/>
-              </a:spcBef>
-              <a:buFont typeface="Arial"/>
-              <a:buChar char="•"/>
-              <a:defRPr sz="1800" kern="1200">
-                <a:solidFill>
-                  <a:schemeClr val="tx1"/>
-                </a:solidFill>
-                <a:latin typeface="+mn-lt"/>
-                <a:ea typeface="+mn-lt"/>
-                <a:cs typeface="+mn-lt"/>
-              </a:defRPr>
-            </a:lvl9pPr>
-          </a:lstStyle>
-          <a:p xmlns:a="http://schemas.openxmlformats.org/drawingml/2006/main">
-            <a:pPr marL="0" indent="0">
-              <a:lnSpc>
-                <a:spcPct val="112000"/>
-              </a:lnSpc>
-              <a:spcBef>
-                <a:spcPts val="0"/>
-              </a:spcBef>
-              <a:spcAft>
-                <a:spcPts val="0"/>
-              </a:spcAft>
-              <a:buNone/>
-              <a:defRPr sz="1800">
-                <a:solidFill>
-                  <a:srgbClr val="FFFFFF"/>
-                </a:solidFill>
-                <a:latin typeface="Consolas"/>
-                <a:ea typeface="Consolas"/>
-                <a:cs typeface="Consolas"/>
-              </a:defRPr>
-            </a:pPr>
-            <a:r>
-              <a:rPr sz="1800">
-                <a:solidFill>
-                  <a:srgbClr val="FFFFFF"/>
-                </a:solidFill>
-                <a:latin typeface="Consolas"/>
-                <a:ea typeface="Consolas"/>
-                <a:cs typeface="Consolas"/>
-              </a:rPr>
-              <a:t>4. 0x1000 + 5 × 4 = 0x1014</a:t>
-            </a:r>
-          </a:p>
-          <a:p xmlns:a="http://schemas.openxmlformats.org/drawingml/2006/main">
-            <a:pPr marL="0" indent="0">
-              <a:lnSpc>
-                <a:spcPct val="112000"/>
-              </a:lnSpc>
-              <a:spcBef>
-                <a:spcPts val="0"/>
-              </a:spcBef>
-              <a:spcAft>
-                <a:spcPts val="0"/>
-              </a:spcAft>
-              <a:buNone/>
-            </a:pPr>
-            <a:r>
-              <a:t/>
-            </a:r>
-          </a:p>
-          <a:p xmlns:a="http://schemas.openxmlformats.org/drawingml/2006/main">
-            <a:pPr marL="0" indent="0">
-              <a:lnSpc>
-                <a:spcPct val="112000"/>
-              </a:lnSpc>
-              <a:spcBef>
-                <a:spcPts val="0"/>
-              </a:spcBef>
-              <a:spcAft>
-                <a:spcPts val="0"/>
-              </a:spcAft>
-              <a:buNone/>
-              <a:defRPr sz="1800">
-                <a:solidFill>
-                  <a:srgbClr val="FFFFFF"/>
-                </a:solidFill>
-                <a:latin typeface="Consolas"/>
-                <a:ea typeface="Consolas"/>
-                <a:cs typeface="Consolas"/>
-              </a:defRPr>
-            </a:pPr>
-            <a:r>
-              <a:rPr sz="1800">
-                <a:solidFill>
-                  <a:srgbClr val="FFFFFF"/>
-                </a:solidFill>
-                <a:latin typeface="Consolas"/>
-                <a:ea typeface="Consolas"/>
-                <a:cs typeface="Consolas"/>
-              </a:rPr>
-              <a:t>5. Heap storage from malloc/calloc/realloc</a:t>
-            </a:r>
-          </a:p>
-          <a:p xmlns:a="http://schemas.openxmlformats.org/drawingml/2006/main">
-            <a:pPr marL="0" indent="0">
-              <a:lnSpc>
-                <a:spcPct val="112000"/>
-              </a:lnSpc>
-              <a:spcBef>
-                <a:spcPts val="0"/>
-              </a:spcBef>
-              <a:spcAft>
-                <a:spcPts val="0"/>
-              </a:spcAft>
-              <a:buNone/>
-            </a:pPr>
-            <a:r>
-              <a:t/>
-            </a:r>
-          </a:p>
-          <a:p xmlns:a="http://schemas.openxmlformats.org/drawingml/2006/main">
-            <a:pPr marL="0" indent="0">
-              <a:lnSpc>
-                <a:spcPct val="112000"/>
-              </a:lnSpc>
-              <a:spcBef>
-                <a:spcPts val="0"/>
-              </a:spcBef>
-              <a:spcAft>
-                <a:spcPts val="0"/>
-              </a:spcAft>
-              <a:buNone/>
-              <a:defRPr sz="1800">
-                <a:solidFill>
-                  <a:srgbClr val="FFFFFF"/>
-                </a:solidFill>
-                <a:latin typeface="Consolas"/>
-                <a:ea typeface="Consolas"/>
-                <a:cs typeface="Consolas"/>
-              </a:defRPr>
-            </a:pPr>
-            <a:r>
-              <a:rPr sz="1800">
-                <a:solidFill>
-                  <a:srgbClr val="FFFFFF"/>
-                </a:solidFill>
-                <a:latin typeface="Consolas"/>
-                <a:ea typeface="Consolas"/>
-                <a:cs typeface="Consolas"/>
-              </a:rPr>
-              <a:t>6. (+1) × 2¹ × 1.5 = 3.0</a:t>
-            </a:r>
-          </a:p>
-        </p:txBody>
-      </p:sp>
-      <p:sp>
-        <p:nvSpPr>
-          <p:cNvPr id="534" name="Takeaway">
-            <a:extLst xmlns:a="http://schemas.openxmlformats.org/drawingml/2006/main">
-              <a:ext uri="{FF2B5EF4-FFF2-40B4-BE49-F238E27FC236}">
-                <a16:creationId xmlns:a16="http://schemas.microsoft.com/office/drawing/2014/main" id="{FAB3D919-D1A7-4CCB-BC93-AA8F82599E3B}"/>
+                <a16:creationId xmlns:a16="http://schemas.microsoft.com/office/drawing/2014/main" id="{D1AC9751-3A62-4DAD-B6AD-4183D01BCBFC}"/>
               </a:ext>
             </a:extLst>
           </p:cNvPr>
@@ -11107,7 +10133,7 @@
           <p:cNvPr id="534" name="Takeaway">
             <a:extLst xmlns:a="http://schemas.openxmlformats.org/drawingml/2006/main">
               <a:ext uri="{FF2B5EF4-FFF2-40B4-BE49-F238E27FC236}">
-                <a16:creationId xmlns:a16="http://schemas.microsoft.com/office/drawing/2014/main" id="{C424D42C-8D84-43C0-8ED0-C1EAD4A11BAC}"/>
+                <a16:creationId xmlns:a16="http://schemas.microsoft.com/office/drawing/2014/main" id="{B24371FB-CC52-4EF4-8F55-67249FE8325D}"/>
               </a:ext>
             </a:extLst>
           </p:cNvPr>
@@ -12083,7 +11109,7 @@
           <p:cNvPr id="534" name="Takeaway">
             <a:extLst xmlns:a="http://schemas.openxmlformats.org/drawingml/2006/main">
               <a:ext uri="{FF2B5EF4-FFF2-40B4-BE49-F238E27FC236}">
-                <a16:creationId xmlns:a16="http://schemas.microsoft.com/office/drawing/2014/main" id="{0C47D024-AD49-427A-881C-257BBAC9EB8C}"/>
+                <a16:creationId xmlns:a16="http://schemas.microsoft.com/office/drawing/2014/main" id="{FA9FA28D-D153-471B-A230-AAE3E38579DA}"/>
               </a:ext>
             </a:extLst>
           </p:cNvPr>
@@ -13009,7 +12035,7 @@
           <p:cNvPr id="534" name="Takeaway">
             <a:extLst xmlns:a="http://schemas.openxmlformats.org/drawingml/2006/main">
               <a:ext uri="{FF2B5EF4-FFF2-40B4-BE49-F238E27FC236}">
-                <a16:creationId xmlns:a16="http://schemas.microsoft.com/office/drawing/2014/main" id="{2559B224-7DF5-4ADC-A624-F44E1BE78252}"/>
+                <a16:creationId xmlns:a16="http://schemas.microsoft.com/office/drawing/2014/main" id="{EC86B7AE-8666-4E48-8902-4DD5ADECC30C}"/>
               </a:ext>
             </a:extLst>
           </p:cNvPr>
@@ -13952,7 +12978,7 @@
           <p:cNvPr id="534" name="Takeaway">
             <a:extLst xmlns:a="http://schemas.openxmlformats.org/drawingml/2006/main">
               <a:ext uri="{FF2B5EF4-FFF2-40B4-BE49-F238E27FC236}">
-                <a16:creationId xmlns:a16="http://schemas.microsoft.com/office/drawing/2014/main" id="{F5B1F170-C508-4478-AD44-886A61E0868A}"/>
+                <a16:creationId xmlns:a16="http://schemas.microsoft.com/office/drawing/2014/main" id="{982B7403-7764-4DFC-A315-E17A85315C63}"/>
               </a:ext>
             </a:extLst>
           </p:cNvPr>
@@ -14928,7 +13954,7 @@
           <p:cNvPr id="534" name="Takeaway">
             <a:extLst xmlns:a="http://schemas.openxmlformats.org/drawingml/2006/main">
               <a:ext uri="{FF2B5EF4-FFF2-40B4-BE49-F238E27FC236}">
-                <a16:creationId xmlns:a16="http://schemas.microsoft.com/office/drawing/2014/main" id="{13DD2C91-C8AB-4318-8EF8-84A511B4F938}"/>
+                <a16:creationId xmlns:a16="http://schemas.microsoft.com/office/drawing/2014/main" id="{947AFA04-444F-4B58-ADD3-7B56666E4E8F}"/>
               </a:ext>
             </a:extLst>
           </p:cNvPr>
@@ -15903,7 +14929,7 @@
           <p:cNvPr id="534" name="Takeaway">
             <a:extLst xmlns:a="http://schemas.openxmlformats.org/drawingml/2006/main">
               <a:ext uri="{FF2B5EF4-FFF2-40B4-BE49-F238E27FC236}">
-                <a16:creationId xmlns:a16="http://schemas.microsoft.com/office/drawing/2014/main" id="{4B1E1149-DD98-4B24-9E32-5869C257DC81}"/>
+                <a16:creationId xmlns:a16="http://schemas.microsoft.com/office/drawing/2014/main" id="{5B1094FF-8651-4AB6-98EC-E21591341DF4}"/>
               </a:ext>
             </a:extLst>
           </p:cNvPr>
@@ -16879,7 +15905,7 @@
           <p:cNvPr id="534" name="Takeaway">
             <a:extLst xmlns:a="http://schemas.openxmlformats.org/drawingml/2006/main">
               <a:ext uri="{FF2B5EF4-FFF2-40B4-BE49-F238E27FC236}">
-                <a16:creationId xmlns:a16="http://schemas.microsoft.com/office/drawing/2014/main" id="{76675D4D-3945-4958-ABC7-11C38694961E}"/>
+                <a16:creationId xmlns:a16="http://schemas.microsoft.com/office/drawing/2014/main" id="{D297478D-3632-4911-8269-BD8B7CD057F2}"/>
               </a:ext>
             </a:extLst>
           </p:cNvPr>
@@ -17871,7 +16897,7 @@
           <p:cNvPr id="534" name="Takeaway">
             <a:extLst xmlns:a="http://schemas.openxmlformats.org/drawingml/2006/main">
               <a:ext uri="{FF2B5EF4-FFF2-40B4-BE49-F238E27FC236}">
-                <a16:creationId xmlns:a16="http://schemas.microsoft.com/office/drawing/2014/main" id="{094735AB-C2F1-4F15-914C-10078B1BEB06}"/>
+                <a16:creationId xmlns:a16="http://schemas.microsoft.com/office/drawing/2014/main" id="{AD4FD524-8DC7-4DED-A05E-21BD2526C03C}"/>
               </a:ext>
             </a:extLst>
           </p:cNvPr>

</xml_diff>

<commit_message>
Simplify stack frame explanation
</commit_message>
<xml_diff>
--- a/public/presentations/CS211_Recitation_4.pptx
+++ b/public/presentations/CS211_Recitation_4.pptx
@@ -2,36 +2,36 @@
 <file path=ppt/presentation.xml><?xml version="1.0" encoding="utf-8"?>
 <p:presentation xmlns:p="http://schemas.openxmlformats.org/presentationml/2006/main" embedTrueTypeFonts="1" saveSubsetFonts="0">
   <p:sldMasterIdLst>
-    <p:sldMasterId xmlns:r="http://schemas.openxmlformats.org/officeDocument/2006/relationships" id="2147483648" r:id="R8f0bd23c65e84e99"/>
+    <p:sldMasterId xmlns:r="http://schemas.openxmlformats.org/officeDocument/2006/relationships" id="2147483648" r:id="R97fab77288d14aec"/>
   </p:sldMasterIdLst>
   <p:notesMasterIdLst>
-    <p:notesMasterId xmlns:r="http://schemas.openxmlformats.org/officeDocument/2006/relationships" r:id="Rc81aa6ad41bd4ec9"/>
+    <p:notesMasterId xmlns:r="http://schemas.openxmlformats.org/officeDocument/2006/relationships" r:id="R578830ab0c9b46a0"/>
   </p:notesMasterIdLst>
   <p:sldIdLst>
-    <p:sldId xmlns:r="http://schemas.openxmlformats.org/officeDocument/2006/relationships" id="256" r:id="R6d6d43fb8f7a42ec"/>
-    <p:sldId xmlns:r="http://schemas.openxmlformats.org/officeDocument/2006/relationships" id="257" r:id="Rc396024c66e342da"/>
-    <p:sldId xmlns:r="http://schemas.openxmlformats.org/officeDocument/2006/relationships" id="258" r:id="R7d14d7898f104242"/>
-    <p:sldId xmlns:r="http://schemas.openxmlformats.org/officeDocument/2006/relationships" id="259" r:id="R22009fad478e4447"/>
-    <p:sldId xmlns:r="http://schemas.openxmlformats.org/officeDocument/2006/relationships" id="260" r:id="Ra4d6b97c6334422e"/>
-    <p:sldId xmlns:r="http://schemas.openxmlformats.org/officeDocument/2006/relationships" id="261" r:id="Rb4d72a2b207448a5"/>
-    <p:sldId xmlns:r="http://schemas.openxmlformats.org/officeDocument/2006/relationships" id="262" r:id="R5a9c0269a7da4b13"/>
-    <p:sldId xmlns:r="http://schemas.openxmlformats.org/officeDocument/2006/relationships" id="263" r:id="R221e894dd4254af1"/>
-    <p:sldId xmlns:r="http://schemas.openxmlformats.org/officeDocument/2006/relationships" id="264" r:id="R38f487c8db414a35"/>
-    <p:sldId xmlns:r="http://schemas.openxmlformats.org/officeDocument/2006/relationships" id="265" r:id="R1c2783e6051445fe"/>
-    <p:sldId xmlns:r="http://schemas.openxmlformats.org/officeDocument/2006/relationships" id="266" r:id="R621214695dfa45f7"/>
-    <p:sldId xmlns:r="http://schemas.openxmlformats.org/officeDocument/2006/relationships" id="267" r:id="R0d9692e036454694"/>
-    <p:sldId xmlns:r="http://schemas.openxmlformats.org/officeDocument/2006/relationships" id="268" r:id="Re8239a0acedf4682"/>
-    <p:sldId xmlns:r="http://schemas.openxmlformats.org/officeDocument/2006/relationships" id="269" r:id="R1e7a33576cb9433e"/>
+    <p:sldId xmlns:r="http://schemas.openxmlformats.org/officeDocument/2006/relationships" id="256" r:id="R8d79b5744c344aef"/>
+    <p:sldId xmlns:r="http://schemas.openxmlformats.org/officeDocument/2006/relationships" id="257" r:id="Rd8cdca9530a24486"/>
+    <p:sldId xmlns:r="http://schemas.openxmlformats.org/officeDocument/2006/relationships" id="258" r:id="R88dae5c701124022"/>
+    <p:sldId xmlns:r="http://schemas.openxmlformats.org/officeDocument/2006/relationships" id="259" r:id="Rc061f95f701949f8"/>
+    <p:sldId xmlns:r="http://schemas.openxmlformats.org/officeDocument/2006/relationships" id="260" r:id="Rc6681de6b86a45e6"/>
+    <p:sldId xmlns:r="http://schemas.openxmlformats.org/officeDocument/2006/relationships" id="261" r:id="R75bd579837cc47ea"/>
+    <p:sldId xmlns:r="http://schemas.openxmlformats.org/officeDocument/2006/relationships" id="262" r:id="R5ff1d1d3b3024067"/>
+    <p:sldId xmlns:r="http://schemas.openxmlformats.org/officeDocument/2006/relationships" id="263" r:id="Rdbe1821e2d794dc4"/>
+    <p:sldId xmlns:r="http://schemas.openxmlformats.org/officeDocument/2006/relationships" id="264" r:id="R2e51a91f653d447b"/>
+    <p:sldId xmlns:r="http://schemas.openxmlformats.org/officeDocument/2006/relationships" id="265" r:id="Rb801054095424491"/>
+    <p:sldId xmlns:r="http://schemas.openxmlformats.org/officeDocument/2006/relationships" id="266" r:id="Rda9a477f14ed474d"/>
+    <p:sldId xmlns:r="http://schemas.openxmlformats.org/officeDocument/2006/relationships" id="267" r:id="R01d8204ec86648a6"/>
+    <p:sldId xmlns:r="http://schemas.openxmlformats.org/officeDocument/2006/relationships" id="268" r:id="R5d4c372bef6147a8"/>
+    <p:sldId xmlns:r="http://schemas.openxmlformats.org/officeDocument/2006/relationships" id="269" r:id="R62524ffbbb1549cc"/>
   </p:sldIdLst>
   <p:sldSz cx="12192000" cy="6858000"/>
   <p:notesSz cx="6858000" cy="9144000"/>
   <p:embeddedFontLst>
     <p:embeddedFont>
       <p:font typeface="OpenAI Sans"/>
-      <p:regular xmlns:r="http://schemas.openxmlformats.org/officeDocument/2006/relationships" r:id="R89bf8907ad4b4646"/>
-      <p:bold xmlns:r="http://schemas.openxmlformats.org/officeDocument/2006/relationships" r:id="R7ae8332b01c349ee"/>
-      <p:italic xmlns:r="http://schemas.openxmlformats.org/officeDocument/2006/relationships" r:id="R2f975c6bf8124dba"/>
-      <p:boldItalic xmlns:r="http://schemas.openxmlformats.org/officeDocument/2006/relationships" r:id="Rf0a304ebf3d24ee3"/>
+      <p:regular xmlns:r="http://schemas.openxmlformats.org/officeDocument/2006/relationships" r:id="Rfa823aa4a42c479f"/>
+      <p:bold xmlns:r="http://schemas.openxmlformats.org/officeDocument/2006/relationships" r:id="Rbdea248bca344f28"/>
+      <p:italic xmlns:r="http://schemas.openxmlformats.org/officeDocument/2006/relationships" r:id="R5d442aa1a6654866"/>
+      <p:boldItalic xmlns:r="http://schemas.openxmlformats.org/officeDocument/2006/relationships" r:id="R2e3293b59fb8489e"/>
     </p:embeddedFont>
   </p:embeddedFontLst>
 </p:presentation>
@@ -3334,14 +3334,14 @@
   </p:cSld>
   <p:clrMap bg1="dk1" tx1="lt1" bg2="dk2" tx2="lt2" accent1="accent1" accent2="accent2" accent3="accent3" accent4="accent4" accent5="accent5" accent6="accent6" hlink="hlink" folHlink="folHlink"/>
   <p:sldLayoutIdLst>
-    <p:sldLayoutId xmlns:r="http://schemas.openxmlformats.org/officeDocument/2006/relationships" id="2147483649" r:id="R7e98a7fb02bb43b5"/>
-    <p:sldLayoutId xmlns:r="http://schemas.openxmlformats.org/officeDocument/2006/relationships" id="2147483650" r:id="R8cfe0bac8d4749d4"/>
-    <p:sldLayoutId xmlns:r="http://schemas.openxmlformats.org/officeDocument/2006/relationships" id="2147483651" r:id="R2311546c7e6d4a1c"/>
-    <p:sldLayoutId xmlns:r="http://schemas.openxmlformats.org/officeDocument/2006/relationships" id="2147483652" r:id="R46de6821b03b49bd"/>
-    <p:sldLayoutId xmlns:r="http://schemas.openxmlformats.org/officeDocument/2006/relationships" id="2147483653" r:id="Rc95ae3d90c634c4c"/>
-    <p:sldLayoutId xmlns:r="http://schemas.openxmlformats.org/officeDocument/2006/relationships" id="2147483654" r:id="R5fe81431b94741ca"/>
-    <p:sldLayoutId xmlns:r="http://schemas.openxmlformats.org/officeDocument/2006/relationships" id="2147483655" r:id="R5daf3506bb534765"/>
-    <p:sldLayoutId xmlns:r="http://schemas.openxmlformats.org/officeDocument/2006/relationships" id="2147483656" r:id="Ra9ad12d660ea448a"/>
+    <p:sldLayoutId xmlns:r="http://schemas.openxmlformats.org/officeDocument/2006/relationships" id="2147483649" r:id="R26398c0d1e60406e"/>
+    <p:sldLayoutId xmlns:r="http://schemas.openxmlformats.org/officeDocument/2006/relationships" id="2147483650" r:id="R8b6880feb58143ea"/>
+    <p:sldLayoutId xmlns:r="http://schemas.openxmlformats.org/officeDocument/2006/relationships" id="2147483651" r:id="R7a2954886fe5466c"/>
+    <p:sldLayoutId xmlns:r="http://schemas.openxmlformats.org/officeDocument/2006/relationships" id="2147483652" r:id="R3fdf5692ccb84c84"/>
+    <p:sldLayoutId xmlns:r="http://schemas.openxmlformats.org/officeDocument/2006/relationships" id="2147483653" r:id="Rb7ecc30a256b4999"/>
+    <p:sldLayoutId xmlns:r="http://schemas.openxmlformats.org/officeDocument/2006/relationships" id="2147483654" r:id="R1f0e1d0dcafe4229"/>
+    <p:sldLayoutId xmlns:r="http://schemas.openxmlformats.org/officeDocument/2006/relationships" id="2147483655" r:id="R50e04a53c1d34fbe"/>
+    <p:sldLayoutId xmlns:r="http://schemas.openxmlformats.org/officeDocument/2006/relationships" id="2147483656" r:id="Rfe7432c842744613"/>
   </p:sldLayoutIdLst>
   <p:hf hdr="0" dt="0"/>
   <p:txStyles>
@@ -4374,7 +4374,7 @@
           <p:nvPr/>
         </p:nvPicPr>
         <p:blipFill>
-          <a:blip xmlns:r="http://schemas.openxmlformats.org/officeDocument/2006/relationships" xmlns:a="http://schemas.openxmlformats.org/drawingml/2006/main" r:embed="R2992c69a416d491e"/>
+          <a:blip xmlns:r="http://schemas.openxmlformats.org/officeDocument/2006/relationships" xmlns:a="http://schemas.openxmlformats.org/drawingml/2006/main" r:embed="R6f2b52babf6f43ed"/>
           <a:srcRect xmlns:a="http://schemas.openxmlformats.org/drawingml/2006/main" l="8269" t="0" r="8269" b="0"/>
           <a:stretch xmlns:a="http://schemas.openxmlformats.org/drawingml/2006/main"/>
         </p:blipFill>
@@ -5252,7 +5252,7 @@
           <p:cNvPr id="534" name="Takeaway">
             <a:extLst xmlns:a="http://schemas.openxmlformats.org/drawingml/2006/main">
               <a:ext uri="{FF2B5EF4-FFF2-40B4-BE49-F238E27FC236}">
-                <a16:creationId xmlns:a16="http://schemas.microsoft.com/office/drawing/2014/main" id="{9FDE8D85-B573-42D2-9D48-C968388CCED8}"/>
+                <a16:creationId xmlns:a16="http://schemas.microsoft.com/office/drawing/2014/main" id="{DDFE1262-98B4-426E-9BAB-E9509E8B6D72}"/>
               </a:ext>
             </a:extLst>
           </p:cNvPr>
@@ -5793,7 +5793,7 @@
                 <a:ea typeface="Arial"/>
                 <a:cs typeface="Arial"/>
               </a:rPr>
-              <a:t>%rsp marks the top of the stack. %rbp may provide a stable frame reference.</a:t>
+              <a:t>%rsp marks the top of the stack.</a:t>
             </a:r>
           </a:p>
         </p:txBody>
@@ -6227,7 +6227,7 @@
           <p:cNvPr id="534" name="Takeaway">
             <a:extLst xmlns:a="http://schemas.openxmlformats.org/drawingml/2006/main">
               <a:ext uri="{FF2B5EF4-FFF2-40B4-BE49-F238E27FC236}">
-                <a16:creationId xmlns:a16="http://schemas.microsoft.com/office/drawing/2014/main" id="{2ADFC182-7368-47B3-B96D-48D407B274DB}"/>
+                <a16:creationId xmlns:a16="http://schemas.microsoft.com/office/drawing/2014/main" id="{44291D41-2EF1-4EF9-9222-640C27524BC1}"/>
               </a:ext>
             </a:extLst>
           </p:cNvPr>
@@ -7220,7 +7220,7 @@
           <p:cNvPr id="534" name="Takeaway">
             <a:extLst xmlns:a="http://schemas.openxmlformats.org/drawingml/2006/main">
               <a:ext uri="{FF2B5EF4-FFF2-40B4-BE49-F238E27FC236}">
-                <a16:creationId xmlns:a16="http://schemas.microsoft.com/office/drawing/2014/main" id="{C9F268C3-6009-40FB-8ABB-793DF20B6F06}"/>
+                <a16:creationId xmlns:a16="http://schemas.microsoft.com/office/drawing/2014/main" id="{F00312A9-26C5-4936-97D6-BBD55DF3A618}"/>
               </a:ext>
             </a:extLst>
           </p:cNvPr>
@@ -8213,7 +8213,7 @@
           <p:cNvPr id="534" name="Takeaway">
             <a:extLst xmlns:a="http://schemas.openxmlformats.org/drawingml/2006/main">
               <a:ext uri="{FF2B5EF4-FFF2-40B4-BE49-F238E27FC236}">
-                <a16:creationId xmlns:a16="http://schemas.microsoft.com/office/drawing/2014/main" id="{C2F37112-65B3-4922-A67A-B87F405B209B}"/>
+                <a16:creationId xmlns:a16="http://schemas.microsoft.com/office/drawing/2014/main" id="{86D3A2B6-9A38-4CC3-9241-938BAD7FF2C3}"/>
               </a:ext>
             </a:extLst>
           </p:cNvPr>
@@ -9140,7 +9140,7 @@
           <p:cNvPr id="534" name="Takeaway">
             <a:extLst xmlns:a="http://schemas.openxmlformats.org/drawingml/2006/main">
               <a:ext uri="{FF2B5EF4-FFF2-40B4-BE49-F238E27FC236}">
-                <a16:creationId xmlns:a16="http://schemas.microsoft.com/office/drawing/2014/main" id="{D1AC9751-3A62-4DAD-B6AD-4183D01BCBFC}"/>
+                <a16:creationId xmlns:a16="http://schemas.microsoft.com/office/drawing/2014/main" id="{B374E2FA-6783-4AEA-9836-70BF84EAA831}"/>
               </a:ext>
             </a:extLst>
           </p:cNvPr>
@@ -10133,7 +10133,7 @@
           <p:cNvPr id="534" name="Takeaway">
             <a:extLst xmlns:a="http://schemas.openxmlformats.org/drawingml/2006/main">
               <a:ext uri="{FF2B5EF4-FFF2-40B4-BE49-F238E27FC236}">
-                <a16:creationId xmlns:a16="http://schemas.microsoft.com/office/drawing/2014/main" id="{B24371FB-CC52-4EF4-8F55-67249FE8325D}"/>
+                <a16:creationId xmlns:a16="http://schemas.microsoft.com/office/drawing/2014/main" id="{286206F7-4632-479D-A37F-E98C6870D04A}"/>
               </a:ext>
             </a:extLst>
           </p:cNvPr>
@@ -11109,7 +11109,7 @@
           <p:cNvPr id="534" name="Takeaway">
             <a:extLst xmlns:a="http://schemas.openxmlformats.org/drawingml/2006/main">
               <a:ext uri="{FF2B5EF4-FFF2-40B4-BE49-F238E27FC236}">
-                <a16:creationId xmlns:a16="http://schemas.microsoft.com/office/drawing/2014/main" id="{FA9FA28D-D153-471B-A230-AAE3E38579DA}"/>
+                <a16:creationId xmlns:a16="http://schemas.microsoft.com/office/drawing/2014/main" id="{F221E91F-C76B-4B16-9530-0EFCC4ACD8D4}"/>
               </a:ext>
             </a:extLst>
           </p:cNvPr>
@@ -12035,7 +12035,7 @@
           <p:cNvPr id="534" name="Takeaway">
             <a:extLst xmlns:a="http://schemas.openxmlformats.org/drawingml/2006/main">
               <a:ext uri="{FF2B5EF4-FFF2-40B4-BE49-F238E27FC236}">
-                <a16:creationId xmlns:a16="http://schemas.microsoft.com/office/drawing/2014/main" id="{EC86B7AE-8666-4E48-8902-4DD5ADECC30C}"/>
+                <a16:creationId xmlns:a16="http://schemas.microsoft.com/office/drawing/2014/main" id="{CC3FE9EE-D97F-4BB0-AD6B-13DCAE0D30D9}"/>
               </a:ext>
             </a:extLst>
           </p:cNvPr>
@@ -12978,7 +12978,7 @@
           <p:cNvPr id="534" name="Takeaway">
             <a:extLst xmlns:a="http://schemas.openxmlformats.org/drawingml/2006/main">
               <a:ext uri="{FF2B5EF4-FFF2-40B4-BE49-F238E27FC236}">
-                <a16:creationId xmlns:a16="http://schemas.microsoft.com/office/drawing/2014/main" id="{982B7403-7764-4DFC-A315-E17A85315C63}"/>
+                <a16:creationId xmlns:a16="http://schemas.microsoft.com/office/drawing/2014/main" id="{EB922B1C-BB37-4424-BD56-75986008CE70}"/>
               </a:ext>
             </a:extLst>
           </p:cNvPr>
@@ -13954,7 +13954,7 @@
           <p:cNvPr id="534" name="Takeaway">
             <a:extLst xmlns:a="http://schemas.openxmlformats.org/drawingml/2006/main">
               <a:ext uri="{FF2B5EF4-FFF2-40B4-BE49-F238E27FC236}">
-                <a16:creationId xmlns:a16="http://schemas.microsoft.com/office/drawing/2014/main" id="{947AFA04-444F-4B58-ADD3-7B56666E4E8F}"/>
+                <a16:creationId xmlns:a16="http://schemas.microsoft.com/office/drawing/2014/main" id="{5CA75480-DD22-4336-8609-B8FB338BA025}"/>
               </a:ext>
             </a:extLst>
           </p:cNvPr>
@@ -14929,7 +14929,7 @@
           <p:cNvPr id="534" name="Takeaway">
             <a:extLst xmlns:a="http://schemas.openxmlformats.org/drawingml/2006/main">
               <a:ext uri="{FF2B5EF4-FFF2-40B4-BE49-F238E27FC236}">
-                <a16:creationId xmlns:a16="http://schemas.microsoft.com/office/drawing/2014/main" id="{5B1094FF-8651-4AB6-98EC-E21591341DF4}"/>
+                <a16:creationId xmlns:a16="http://schemas.microsoft.com/office/drawing/2014/main" id="{EFF5D5F5-7DDE-4008-8795-7661F9FB5994}"/>
               </a:ext>
             </a:extLst>
           </p:cNvPr>
@@ -15905,7 +15905,7 @@
           <p:cNvPr id="534" name="Takeaway">
             <a:extLst xmlns:a="http://schemas.openxmlformats.org/drawingml/2006/main">
               <a:ext uri="{FF2B5EF4-FFF2-40B4-BE49-F238E27FC236}">
-                <a16:creationId xmlns:a16="http://schemas.microsoft.com/office/drawing/2014/main" id="{D297478D-3632-4911-8269-BD8B7CD057F2}"/>
+                <a16:creationId xmlns:a16="http://schemas.microsoft.com/office/drawing/2014/main" id="{F3D39307-BCC5-44A8-9889-A9CAD31ABAEC}"/>
               </a:ext>
             </a:extLst>
           </p:cNvPr>
@@ -16897,7 +16897,7 @@
           <p:cNvPr id="534" name="Takeaway">
             <a:extLst xmlns:a="http://schemas.openxmlformats.org/drawingml/2006/main">
               <a:ext uri="{FF2B5EF4-FFF2-40B4-BE49-F238E27FC236}">
-                <a16:creationId xmlns:a16="http://schemas.microsoft.com/office/drawing/2014/main" id="{AD4FD524-8DC7-4DED-A05E-21BD2526C03C}"/>
+                <a16:creationId xmlns:a16="http://schemas.microsoft.com/office/drawing/2014/main" id="{578CC582-5F79-4ABE-A54B-E8CEA756B66B}"/>
               </a:ext>
             </a:extLst>
           </p:cNvPr>

</xml_diff>